<commit_message>
Update cronograma data for Silvia, Sara and Melvin
Refresh the single-slide deck with the latest weekly activities from
the updated Word trackers: Silvia's activities and categories were
replaced (new period), Sara's list grew to 12 items with mostly
Finalizado status, and Melvin's liquidity/otros percentages were
bumped to reflect this week's progress.

Co-Authored-By: Claude Sonnet 5 <noreply@anthropic.com>
Claude-Session: https://claude.ai/code/session_01KND4cYnTdx53ydNLfQdR3S
</commit_message>
<xml_diff>
--- a/Administracion_Riesgos_COMEDICA.pptx
+++ b/Administracion_Riesgos_COMEDICA.pptx
@@ -1511,7 +1511,7 @@
                 <a:ea typeface="Calibri" pitchFamily="34" charset="-122"/>
                 <a:cs typeface="Calibri" pitchFamily="34" charset="-120"/>
               </a:rPr>
-              <a:t>15 actividades</a:t>
+              <a:t>12 actividades</a:t>
             </a:r>
             <a:endParaRPr lang="en-US" sz="800" dirty="0"/>
           </a:p>
@@ -1526,11 +1526,11 @@
         <p:spPr>
           <a:xfrm>
             <a:off x="365760" y="1417320"/>
-            <a:ext cx="2769032" cy="1504950"/>
+            <a:ext cx="2769032" cy="1324356"/>
           </a:xfrm>
           <a:prstGeom prst="roundRect">
             <a:avLst>
-              <a:gd name="adj" fmla="val 4253"/>
+              <a:gd name="adj" fmla="val 4833"/>
             </a:avLst>
           </a:prstGeom>
           <a:solidFill>
@@ -1701,7 +1701,7 @@
         <p:spPr>
           <a:xfrm>
             <a:off x="603504" y="1847088"/>
-            <a:ext cx="2412416" cy="213970"/>
+            <a:ext cx="2412416" cy="216713"/>
           </a:xfrm>
           <a:prstGeom prst="rect">
             <a:avLst/>
@@ -1720,7 +1720,7 @@
               <a:buNone/>
             </a:pPr>
             <a:r>
-              <a:rPr lang="en-US" sz="680" dirty="0">
+              <a:rPr lang="en-US" sz="690" dirty="0">
                 <a:solidFill>
                   <a:srgbClr val="243044"/>
                 </a:solidFill>
@@ -1737,7 +1737,7 @@
               <a:buNone/>
             </a:pPr>
             <a:r>
-              <a:rPr lang="en-US" sz="680" b="1" dirty="0">
+              <a:rPr lang="en-US" sz="690" b="1" dirty="0">
                 <a:solidFill>
                   <a:srgbClr val="5B6B82"/>
                 </a:solidFill>
@@ -1745,9 +1745,9 @@
                 <a:ea typeface="Calibri" pitchFamily="34" charset="-122"/>
                 <a:cs typeface="Calibri" pitchFamily="34" charset="-120"/>
               </a:rPr>
-              <a:t>10%</a:t>
-            </a:r>
-            <a:endParaRPr lang="en-US" sz="680" dirty="0"/>
+              <a:t>80%</a:t>
+            </a:r>
+            <a:endParaRPr lang="en-US" sz="690" dirty="0"/>
           </a:p>
         </p:txBody>
       </p:sp>
@@ -1759,7 +1759,7 @@
         </p:nvSpPr>
         <p:spPr>
           <a:xfrm>
-            <a:off x="484632" y="2089404"/>
+            <a:off x="484632" y="2092147"/>
             <a:ext cx="38405" cy="38405"/>
           </a:xfrm>
           <a:prstGeom prst="ellipse">
@@ -1779,8 +1779,8 @@
         </p:nvSpPr>
         <p:spPr>
           <a:xfrm>
-            <a:off x="603504" y="2047342"/>
-            <a:ext cx="2412416" cy="120701"/>
+            <a:off x="603504" y="2050085"/>
+            <a:ext cx="2412416" cy="216713"/>
           </a:xfrm>
           <a:prstGeom prst="rect">
             <a:avLst/>
@@ -1799,7 +1799,7 @@
               <a:buNone/>
             </a:pPr>
             <a:r>
-              <a:rPr lang="en-US" sz="680" dirty="0">
+              <a:rPr lang="en-US" sz="690" dirty="0">
                 <a:solidFill>
                   <a:srgbClr val="243044"/>
                 </a:solidFill>
@@ -1807,16 +1807,16 @@
                 <a:ea typeface="Calibri" pitchFamily="34" charset="-122"/>
                 <a:cs typeface="Calibri" pitchFamily="34" charset="-120"/>
               </a:rPr>
-              <a:t>Atención visita AENOR  </a:t>
-            </a:r>
-            <a:pPr algn="l" indent="0" marL="0">
-              <a:lnSpc>
-                <a:spcPct val="98000"/>
-              </a:lnSpc>
-              <a:buNone/>
-            </a:pPr>
-            <a:r>
-              <a:rPr lang="en-US" sz="680" b="1" dirty="0">
+              <a:t>Envío requerimiento información Auditoría Interna – NRP-17  </a:t>
+            </a:r>
+            <a:pPr algn="l" indent="0" marL="0">
+              <a:lnSpc>
+                <a:spcPct val="98000"/>
+              </a:lnSpc>
+              <a:buNone/>
+            </a:pPr>
+            <a:r>
+              <a:rPr lang="en-US" sz="690" b="1" dirty="0">
                 <a:solidFill>
                   <a:srgbClr val="5B6B82"/>
                 </a:solidFill>
@@ -1826,7 +1826,7 @@
               </a:rPr>
               <a:t>100%</a:t>
             </a:r>
-            <a:endParaRPr lang="en-US" sz="680" dirty="0"/>
+            <a:endParaRPr lang="en-US" sz="690" dirty="0"/>
           </a:p>
         </p:txBody>
       </p:sp>
@@ -1839,11 +1839,11 @@
         <p:spPr>
           <a:xfrm>
             <a:off x="3262808" y="1417320"/>
-            <a:ext cx="2769032" cy="1504950"/>
+            <a:ext cx="2769032" cy="1324356"/>
           </a:xfrm>
           <a:prstGeom prst="roundRect">
             <a:avLst>
-              <a:gd name="adj" fmla="val 4253"/>
+              <a:gd name="adj" fmla="val 4833"/>
             </a:avLst>
           </a:prstGeom>
           <a:solidFill>
@@ -1874,7 +1874,7 @@
             <a:avLst/>
           </a:prstGeom>
           <a:solidFill>
-            <a:srgbClr val="0F766E"/>
+            <a:srgbClr val="1B4F91"/>
           </a:solidFill>
           <a:ln/>
         </p:spPr>
@@ -1894,14 +1894,14 @@
             <a:avLst/>
           </a:prstGeom>
           <a:solidFill>
-            <a:srgbClr val="E4F5F3"/>
+            <a:srgbClr val="EAF0F8"/>
           </a:solidFill>
           <a:ln/>
         </p:spPr>
       </p:sp>
       <p:pic>
         <p:nvPicPr>
-          <p:cNvPr id="37" name="Image 1" descr="/tmp/claude-0/-home-user-riesgo/579fb8c8-70e5-51d5-80ec-6ed51cc2e8df/scratchpad/pptx-build/icons/users_0F766E.png">    </p:cNvPr>
+          <p:cNvPr id="37" name="Image 1" descr="/tmp/claude-0/-home-user-riesgo/579fb8c8-70e5-51d5-80ec-6ed51cc2e8df/scratchpad/pptx-build/icons/filetext_1B4F91.png">    </p:cNvPr>
           <p:cNvPicPr>
             <a:picLocks noChangeAspect="1"/>
           </p:cNvPicPr>
@@ -1959,7 +1959,7 @@
                 <a:ea typeface="Calibri" pitchFamily="34" charset="-122"/>
                 <a:cs typeface="Calibri" pitchFamily="34" charset="-120"/>
               </a:rPr>
-              <a:t>Comité de Riesgos y Gestión</a:t>
+              <a:t>Gestión Documental y Crédito</a:t>
             </a:r>
             <a:endParaRPr lang="en-US" sz="760" dirty="0"/>
           </a:p>
@@ -1980,7 +1980,7 @@
             <a:avLst/>
           </a:prstGeom>
           <a:solidFill>
-            <a:srgbClr val="0F766E"/>
+            <a:srgbClr val="1B4F91"/>
           </a:solidFill>
           <a:ln/>
         </p:spPr>
@@ -2014,7 +2014,7 @@
         <p:spPr>
           <a:xfrm>
             <a:off x="3500552" y="1847088"/>
-            <a:ext cx="2412416" cy="208483"/>
+            <a:ext cx="2412416" cy="216713"/>
           </a:xfrm>
           <a:prstGeom prst="rect">
             <a:avLst/>
@@ -2033,7 +2033,7 @@
               <a:buNone/>
             </a:pPr>
             <a:r>
-              <a:rPr lang="en-US" sz="660" dirty="0">
+              <a:rPr lang="en-US" sz="690" dirty="0">
                 <a:solidFill>
                   <a:srgbClr val="243044"/>
                 </a:solidFill>
@@ -2041,16 +2041,16 @@
                 <a:ea typeface="Calibri" pitchFamily="34" charset="-122"/>
                 <a:cs typeface="Calibri" pitchFamily="34" charset="-120"/>
               </a:rPr>
-              <a:t>Informe ejecutivo RO y Reputacional para Comité (cierre agosto 2026)  </a:t>
-            </a:r>
-            <a:pPr algn="l" indent="0" marL="0">
-              <a:lnSpc>
-                <a:spcPct val="98000"/>
-              </a:lnSpc>
-              <a:buNone/>
-            </a:pPr>
-            <a:r>
-              <a:rPr lang="en-US" sz="660" b="1" dirty="0">
+              <a:t>Evaluación Matriz de Riesgo proyecto Gestor Documental  </a:t>
+            </a:r>
+            <a:pPr algn="l" indent="0" marL="0">
+              <a:lnSpc>
+                <a:spcPct val="98000"/>
+              </a:lnSpc>
+              <a:buNone/>
+            </a:pPr>
+            <a:r>
+              <a:rPr lang="en-US" sz="690" b="1" dirty="0">
                 <a:solidFill>
                   <a:srgbClr val="5B6B82"/>
                 </a:solidFill>
@@ -2058,9 +2058,9 @@
                 <a:ea typeface="Calibri" pitchFamily="34" charset="-122"/>
                 <a:cs typeface="Calibri" pitchFamily="34" charset="-120"/>
               </a:rPr>
-              <a:t>20%</a:t>
-            </a:r>
-            <a:endParaRPr lang="en-US" sz="660" dirty="0"/>
+              <a:t>80%</a:t>
+            </a:r>
+            <a:endParaRPr lang="en-US" sz="690" dirty="0"/>
           </a:p>
         </p:txBody>
       </p:sp>
@@ -2072,14 +2072,14 @@
         </p:nvSpPr>
         <p:spPr>
           <a:xfrm>
-            <a:off x="3381680" y="2083918"/>
+            <a:off x="3381680" y="2092147"/>
             <a:ext cx="38405" cy="38405"/>
           </a:xfrm>
           <a:prstGeom prst="ellipse">
             <a:avLst/>
           </a:prstGeom>
           <a:solidFill>
-            <a:srgbClr val="A6650F"/>
+            <a:srgbClr val="1E8449"/>
           </a:solidFill>
           <a:ln/>
         </p:spPr>
@@ -2092,8 +2092,8 @@
         </p:nvSpPr>
         <p:spPr>
           <a:xfrm>
-            <a:off x="3500552" y="2041855"/>
-            <a:ext cx="2412416" cy="208483"/>
+            <a:off x="3500552" y="2050085"/>
+            <a:ext cx="2412416" cy="216713"/>
           </a:xfrm>
           <a:prstGeom prst="rect">
             <a:avLst/>
@@ -2112,7 +2112,7 @@
               <a:buNone/>
             </a:pPr>
             <a:r>
-              <a:rPr lang="en-US" sz="660" dirty="0">
+              <a:rPr lang="en-US" sz="690" dirty="0">
                 <a:solidFill>
                   <a:srgbClr val="243044"/>
                 </a:solidFill>
@@ -2120,16 +2120,16 @@
                 <a:ea typeface="Calibri" pitchFamily="34" charset="-122"/>
                 <a:cs typeface="Calibri" pitchFamily="34" charset="-120"/>
               </a:rPr>
-              <a:t>Reunión con Custodia de Valores – Gestor Documental (Evaluación Matriz de Riesgos)  </a:t>
-            </a:r>
-            <a:pPr algn="l" indent="0" marL="0">
-              <a:lnSpc>
-                <a:spcPct val="98000"/>
-              </a:lnSpc>
-              <a:buNone/>
-            </a:pPr>
-            <a:r>
-              <a:rPr lang="en-US" sz="660" b="1" dirty="0">
+              <a:t>Reunión Fábrica de Créditos – Revisión de documentos de Riesgos necesarios para expediente  </a:t>
+            </a:r>
+            <a:pPr algn="l" indent="0" marL="0">
+              <a:lnSpc>
+                <a:spcPct val="98000"/>
+              </a:lnSpc>
+              <a:buNone/>
+            </a:pPr>
+            <a:r>
+              <a:rPr lang="en-US" sz="690" b="1" dirty="0">
                 <a:solidFill>
                   <a:srgbClr val="5B6B82"/>
                 </a:solidFill>
@@ -2137,9 +2137,9 @@
                 <a:ea typeface="Calibri" pitchFamily="34" charset="-122"/>
                 <a:cs typeface="Calibri" pitchFamily="34" charset="-120"/>
               </a:rPr>
-              <a:t>25%</a:t>
-            </a:r>
-            <a:endParaRPr lang="en-US" sz="660" dirty="0"/>
+              <a:t>100%</a:t>
+            </a:r>
+            <a:endParaRPr lang="en-US" sz="690" dirty="0"/>
           </a:p>
         </p:txBody>
       </p:sp>
@@ -2151,170 +2151,12 @@
         </p:nvSpPr>
         <p:spPr>
           <a:xfrm>
-            <a:off x="3381680" y="2278685"/>
-            <a:ext cx="38405" cy="38405"/>
-          </a:xfrm>
-          <a:prstGeom prst="ellipse">
-            <a:avLst/>
-          </a:prstGeom>
-          <a:solidFill>
-            <a:srgbClr val="A6650F"/>
-          </a:solidFill>
-          <a:ln/>
-        </p:spPr>
-      </p:sp>
-      <p:sp>
-        <p:nvSpPr>
-          <p:cNvPr id="45" name="Text 41"/>
-          <p:cNvSpPr txBox="1"/>
-          <p:nvPr/>
-        </p:nvSpPr>
-        <p:spPr>
-          <a:xfrm>
-            <a:off x="3500552" y="2236622"/>
-            <a:ext cx="2412416" cy="208483"/>
-          </a:xfrm>
-          <a:prstGeom prst="rect">
-            <a:avLst/>
-          </a:prstGeom>
-          <a:noFill/>
-          <a:ln/>
-        </p:spPr>
-        <p:txBody>
-          <a:bodyPr wrap="square" lIns="0" tIns="0" rIns="0" bIns="0" rtlCol="0" anchor="t"/>
-          <a:lstStyle/>
-          <a:p>
-            <a:pPr algn="l" indent="0" marL="0">
-              <a:lnSpc>
-                <a:spcPct val="98000"/>
-              </a:lnSpc>
-              <a:buNone/>
-            </a:pPr>
-            <a:r>
-              <a:rPr lang="en-US" sz="660" dirty="0">
-                <a:solidFill>
-                  <a:srgbClr val="243044"/>
-                </a:solidFill>
-                <a:latin typeface="Calibri" pitchFamily="34" charset="0"/>
-                <a:ea typeface="Calibri" pitchFamily="34" charset="-122"/>
-                <a:cs typeface="Calibri" pitchFamily="34" charset="-120"/>
-              </a:rPr>
-              <a:t>Evento de pérdida – Multa Gerencia Finanzas (pendiente firma GF)  </a:t>
-            </a:r>
-            <a:pPr algn="l" indent="0" marL="0">
-              <a:lnSpc>
-                <a:spcPct val="98000"/>
-              </a:lnSpc>
-              <a:buNone/>
-            </a:pPr>
-            <a:r>
-              <a:rPr lang="en-US" sz="660" b="1" dirty="0">
-                <a:solidFill>
-                  <a:srgbClr val="5B6B82"/>
-                </a:solidFill>
-                <a:latin typeface="Calibri" pitchFamily="34" charset="0"/>
-                <a:ea typeface="Calibri" pitchFamily="34" charset="-122"/>
-                <a:cs typeface="Calibri" pitchFamily="34" charset="-120"/>
-              </a:rPr>
-              <a:t>50%</a:t>
-            </a:r>
-            <a:endParaRPr lang="en-US" sz="660" dirty="0"/>
-          </a:p>
-        </p:txBody>
-      </p:sp>
-      <p:sp>
-        <p:nvSpPr>
-          <p:cNvPr id="46" name="Shape 42"/>
-          <p:cNvSpPr/>
-          <p:nvPr/>
-        </p:nvSpPr>
-        <p:spPr>
-          <a:xfrm>
-            <a:off x="3381680" y="2473452"/>
-            <a:ext cx="38405" cy="38405"/>
-          </a:xfrm>
-          <a:prstGeom prst="ellipse">
-            <a:avLst/>
-          </a:prstGeom>
-          <a:solidFill>
-            <a:srgbClr val="1E8449"/>
-          </a:solidFill>
-          <a:ln/>
-        </p:spPr>
-      </p:sp>
-      <p:sp>
-        <p:nvSpPr>
-          <p:cNvPr id="47" name="Text 43"/>
-          <p:cNvSpPr txBox="1"/>
-          <p:nvPr/>
-        </p:nvSpPr>
-        <p:spPr>
-          <a:xfrm>
-            <a:off x="3500552" y="2431390"/>
-            <a:ext cx="2412416" cy="208483"/>
-          </a:xfrm>
-          <a:prstGeom prst="rect">
-            <a:avLst/>
-          </a:prstGeom>
-          <a:noFill/>
-          <a:ln/>
-        </p:spPr>
-        <p:txBody>
-          <a:bodyPr wrap="square" lIns="0" tIns="0" rIns="0" bIns="0" rtlCol="0" anchor="t"/>
-          <a:lstStyle/>
-          <a:p>
-            <a:pPr algn="l" indent="0" marL="0">
-              <a:lnSpc>
-                <a:spcPct val="98000"/>
-              </a:lnSpc>
-              <a:buNone/>
-            </a:pPr>
-            <a:r>
-              <a:rPr lang="en-US" sz="660" dirty="0">
-                <a:solidFill>
-                  <a:srgbClr val="243044"/>
-                </a:solidFill>
-                <a:latin typeface="Calibri" pitchFamily="34" charset="0"/>
-                <a:ea typeface="Calibri" pitchFamily="34" charset="-122"/>
-                <a:cs typeface="Calibri" pitchFamily="34" charset="-120"/>
-              </a:rPr>
-              <a:t>Revisión de Matriz de Acuerdos – Sesión 150 Comité de Riesgos  </a:t>
-            </a:r>
-            <a:pPr algn="l" indent="0" marL="0">
-              <a:lnSpc>
-                <a:spcPct val="98000"/>
-              </a:lnSpc>
-              <a:buNone/>
-            </a:pPr>
-            <a:r>
-              <a:rPr lang="en-US" sz="660" b="1" dirty="0">
-                <a:solidFill>
-                  <a:srgbClr val="5B6B82"/>
-                </a:solidFill>
-                <a:latin typeface="Calibri" pitchFamily="34" charset="0"/>
-                <a:ea typeface="Calibri" pitchFamily="34" charset="-122"/>
-                <a:cs typeface="Calibri" pitchFamily="34" charset="-120"/>
-              </a:rPr>
-              <a:t>100%</a:t>
-            </a:r>
-            <a:endParaRPr lang="en-US" sz="660" dirty="0"/>
-          </a:p>
-        </p:txBody>
-      </p:sp>
-      <p:sp>
-        <p:nvSpPr>
-          <p:cNvPr id="48" name="Shape 44"/>
-          <p:cNvSpPr/>
-          <p:nvPr/>
-        </p:nvSpPr>
-        <p:spPr>
-          <a:xfrm>
             <a:off x="6159856" y="1417320"/>
-            <a:ext cx="2769032" cy="1504950"/>
+            <a:ext cx="2769032" cy="1324356"/>
           </a:xfrm>
           <a:prstGeom prst="roundRect">
             <a:avLst>
-              <a:gd name="adj" fmla="val 4253"/>
+              <a:gd name="adj" fmla="val 4833"/>
             </a:avLst>
           </a:prstGeom>
           <a:solidFill>
@@ -2332,7 +2174,7 @@
       </p:sp>
       <p:sp>
         <p:nvSpPr>
-          <p:cNvPr id="49" name="Shape 45"/>
+          <p:cNvPr id="45" name="Shape 41"/>
           <p:cNvSpPr/>
           <p:nvPr/>
         </p:nvSpPr>
@@ -2352,7 +2194,7 @@
       </p:sp>
       <p:sp>
         <p:nvSpPr>
-          <p:cNvPr id="50" name="Shape 46"/>
+          <p:cNvPr id="46" name="Shape 42"/>
           <p:cNvSpPr/>
           <p:nvPr/>
         </p:nvSpPr>
@@ -2372,7 +2214,7 @@
       </p:sp>
       <p:pic>
         <p:nvPicPr>
-          <p:cNvPr id="51" name="Image 2" descr="/tmp/claude-0/-home-user-riesgo/579fb8c8-70e5-51d5-80ec-6ed51cc2e8df/scratchpad/pptx-build/icons/refreshcw_1D63A1.png">    </p:cNvPr>
+          <p:cNvPr id="47" name="Image 2" descr="/tmp/claude-0/-home-user-riesgo/579fb8c8-70e5-51d5-80ec-6ed51cc2e8df/scratchpad/pptx-build/icons/activity_1D63A1.png">    </p:cNvPr>
           <p:cNvPicPr>
             <a:picLocks noChangeAspect="1"/>
           </p:cNvPicPr>
@@ -2396,7 +2238,7 @@
       </p:pic>
       <p:sp>
         <p:nvSpPr>
-          <p:cNvPr id="52" name="Text 47"/>
+          <p:cNvPr id="48" name="Text 43"/>
           <p:cNvSpPr txBox="1"/>
           <p:nvPr/>
         </p:nvSpPr>
@@ -2430,7 +2272,7 @@
                 <a:ea typeface="Calibri" pitchFamily="34" charset="-122"/>
                 <a:cs typeface="Calibri" pitchFamily="34" charset="-120"/>
               </a:rPr>
-              <a:t>Continuidad del Negocio</a:t>
+              <a:t>Riesgo Operacional y Tecnológico</a:t>
             </a:r>
             <a:endParaRPr lang="en-US" sz="760" dirty="0"/>
           </a:p>
@@ -2438,7 +2280,7 @@
       </p:sp>
       <p:sp>
         <p:nvSpPr>
-          <p:cNvPr id="53" name="Shape 48"/>
+          <p:cNvPr id="49" name="Shape 44"/>
           <p:cNvSpPr/>
           <p:nvPr/>
         </p:nvSpPr>
@@ -2458,7 +2300,7 @@
       </p:sp>
       <p:sp>
         <p:nvSpPr>
-          <p:cNvPr id="54" name="Shape 49"/>
+          <p:cNvPr id="50" name="Shape 45"/>
           <p:cNvSpPr/>
           <p:nvPr/>
         </p:nvSpPr>
@@ -2471,6 +2313,164 @@
             <a:avLst/>
           </a:prstGeom>
           <a:solidFill>
+            <a:srgbClr val="A6650F"/>
+          </a:solidFill>
+          <a:ln/>
+        </p:spPr>
+      </p:sp>
+      <p:sp>
+        <p:nvSpPr>
+          <p:cNvPr id="51" name="Text 46"/>
+          <p:cNvSpPr txBox="1"/>
+          <p:nvPr/>
+        </p:nvSpPr>
+        <p:spPr>
+          <a:xfrm>
+            <a:off x="6397600" y="1847088"/>
+            <a:ext cx="2412416" cy="183794"/>
+          </a:xfrm>
+          <a:prstGeom prst="rect">
+            <a:avLst/>
+          </a:prstGeom>
+          <a:noFill/>
+          <a:ln/>
+        </p:spPr>
+        <p:txBody>
+          <a:bodyPr wrap="square" lIns="0" tIns="0" rIns="0" bIns="0" rtlCol="0" anchor="t"/>
+          <a:lstStyle/>
+          <a:p>
+            <a:pPr algn="l" indent="0" marL="0">
+              <a:lnSpc>
+                <a:spcPct val="98000"/>
+              </a:lnSpc>
+              <a:buNone/>
+            </a:pPr>
+            <a:r>
+              <a:rPr lang="en-US" sz="570" dirty="0">
+                <a:solidFill>
+                  <a:srgbClr val="243044"/>
+                </a:solidFill>
+                <a:latin typeface="Calibri" pitchFamily="34" charset="0"/>
+                <a:ea typeface="Calibri" pitchFamily="34" charset="-122"/>
+                <a:cs typeface="Calibri" pitchFamily="34" charset="-120"/>
+              </a:rPr>
+              <a:t>Seguimiento a lanzamiento de nueva plataforma de Canales Digitales – informe de Riesgo Reputacional  </a:t>
+            </a:r>
+            <a:pPr algn="l" indent="0" marL="0">
+              <a:lnSpc>
+                <a:spcPct val="98000"/>
+              </a:lnSpc>
+              <a:buNone/>
+            </a:pPr>
+            <a:r>
+              <a:rPr lang="en-US" sz="570" b="1" dirty="0">
+                <a:solidFill>
+                  <a:srgbClr val="5B6B82"/>
+                </a:solidFill>
+                <a:latin typeface="Calibri" pitchFamily="34" charset="0"/>
+                <a:ea typeface="Calibri" pitchFamily="34" charset="-122"/>
+                <a:cs typeface="Calibri" pitchFamily="34" charset="-120"/>
+              </a:rPr>
+              <a:t>30%</a:t>
+            </a:r>
+            <a:endParaRPr lang="en-US" sz="570" dirty="0"/>
+          </a:p>
+        </p:txBody>
+      </p:sp>
+      <p:sp>
+        <p:nvSpPr>
+          <p:cNvPr id="52" name="Shape 47"/>
+          <p:cNvSpPr/>
+          <p:nvPr/>
+        </p:nvSpPr>
+        <p:spPr>
+          <a:xfrm>
+            <a:off x="6278728" y="2059229"/>
+            <a:ext cx="38405" cy="38405"/>
+          </a:xfrm>
+          <a:prstGeom prst="ellipse">
+            <a:avLst/>
+          </a:prstGeom>
+          <a:solidFill>
+            <a:srgbClr val="A6650F"/>
+          </a:solidFill>
+          <a:ln/>
+        </p:spPr>
+      </p:sp>
+      <p:sp>
+        <p:nvSpPr>
+          <p:cNvPr id="53" name="Text 48"/>
+          <p:cNvSpPr txBox="1"/>
+          <p:nvPr/>
+        </p:nvSpPr>
+        <p:spPr>
+          <a:xfrm>
+            <a:off x="6397600" y="2017166"/>
+            <a:ext cx="2412416" cy="183794"/>
+          </a:xfrm>
+          <a:prstGeom prst="rect">
+            <a:avLst/>
+          </a:prstGeom>
+          <a:noFill/>
+          <a:ln/>
+        </p:spPr>
+        <p:txBody>
+          <a:bodyPr wrap="square" lIns="0" tIns="0" rIns="0" bIns="0" rtlCol="0" anchor="t"/>
+          <a:lstStyle/>
+          <a:p>
+            <a:pPr algn="l" indent="0" marL="0">
+              <a:lnSpc>
+                <a:spcPct val="98000"/>
+              </a:lnSpc>
+              <a:buNone/>
+            </a:pPr>
+            <a:r>
+              <a:rPr lang="en-US" sz="570" dirty="0">
+                <a:solidFill>
+                  <a:srgbClr val="243044"/>
+                </a:solidFill>
+                <a:latin typeface="Calibri" pitchFamily="34" charset="0"/>
+                <a:ea typeface="Calibri" pitchFamily="34" charset="-122"/>
+                <a:cs typeface="Calibri" pitchFamily="34" charset="-120"/>
+              </a:rPr>
+              <a:t>Reunión evaluación de Riesgos Operacionales y Tecnológicos – cambio de Procesador de TC  </a:t>
+            </a:r>
+            <a:pPr algn="l" indent="0" marL="0">
+              <a:lnSpc>
+                <a:spcPct val="98000"/>
+              </a:lnSpc>
+              <a:buNone/>
+            </a:pPr>
+            <a:r>
+              <a:rPr lang="en-US" sz="570" b="1" dirty="0">
+                <a:solidFill>
+                  <a:srgbClr val="5B6B82"/>
+                </a:solidFill>
+                <a:latin typeface="Calibri" pitchFamily="34" charset="0"/>
+                <a:ea typeface="Calibri" pitchFamily="34" charset="-122"/>
+                <a:cs typeface="Calibri" pitchFamily="34" charset="-120"/>
+              </a:rPr>
+              <a:t>20%</a:t>
+            </a:r>
+            <a:endParaRPr lang="en-US" sz="570" dirty="0"/>
+          </a:p>
+        </p:txBody>
+      </p:sp>
+      <p:sp>
+        <p:nvSpPr>
+          <p:cNvPr id="54" name="Shape 49"/>
+          <p:cNvSpPr/>
+          <p:nvPr/>
+        </p:nvSpPr>
+        <p:spPr>
+          <a:xfrm>
+            <a:off x="6278728" y="2229307"/>
+            <a:ext cx="38405" cy="38405"/>
+          </a:xfrm>
+          <a:prstGeom prst="ellipse">
+            <a:avLst/>
+          </a:prstGeom>
+          <a:solidFill>
             <a:srgbClr val="1E8449"/>
           </a:solidFill>
           <a:ln/>
@@ -2484,8 +2484,8 @@
         </p:nvSpPr>
         <p:spPr>
           <a:xfrm>
-            <a:off x="6397600" y="1847088"/>
-            <a:ext cx="2412416" cy="211226"/>
+            <a:off x="6397600" y="2187245"/>
+            <a:ext cx="2412416" cy="183794"/>
           </a:xfrm>
           <a:prstGeom prst="rect">
             <a:avLst/>
@@ -2504,7 +2504,7 @@
               <a:buNone/>
             </a:pPr>
             <a:r>
-              <a:rPr lang="en-US" sz="670" dirty="0">
+              <a:rPr lang="en-US" sz="570" dirty="0">
                 <a:solidFill>
                   <a:srgbClr val="243044"/>
                 </a:solidFill>
@@ -2512,16 +2512,16 @@
                 <a:ea typeface="Calibri" pitchFamily="34" charset="-122"/>
                 <a:cs typeface="Calibri" pitchFamily="34" charset="-120"/>
               </a:rPr>
-              <a:t>Informe primera prueba de CN (10 días hábiles) – envío a SSF vence 12.09.2026  </a:t>
-            </a:r>
-            <a:pPr algn="l" indent="0" marL="0">
-              <a:lnSpc>
-                <a:spcPct val="98000"/>
-              </a:lnSpc>
-              <a:buNone/>
-            </a:pPr>
-            <a:r>
-              <a:rPr lang="en-US" sz="670" b="1" dirty="0">
+              <a:t>Elaboración de encuesta e informe de evaluación del Servicio de Procesamiento de Tarjetas de Crédito  </a:t>
+            </a:r>
+            <a:pPr algn="l" indent="0" marL="0">
+              <a:lnSpc>
+                <a:spcPct val="98000"/>
+              </a:lnSpc>
+              <a:buNone/>
+            </a:pPr>
+            <a:r>
+              <a:rPr lang="en-US" sz="570" b="1" dirty="0">
                 <a:solidFill>
                   <a:srgbClr val="5B6B82"/>
                 </a:solidFill>
@@ -2529,9 +2529,9 @@
                 <a:ea typeface="Calibri" pitchFamily="34" charset="-122"/>
                 <a:cs typeface="Calibri" pitchFamily="34" charset="-120"/>
               </a:rPr>
-              <a:t>80%</a:t>
-            </a:r>
-            <a:endParaRPr lang="en-US" sz="670" dirty="0"/>
+              <a:t>100%</a:t>
+            </a:r>
+            <a:endParaRPr lang="en-US" sz="570" dirty="0"/>
           </a:p>
         </p:txBody>
       </p:sp>
@@ -2543,14 +2543,14 @@
         </p:nvSpPr>
         <p:spPr>
           <a:xfrm>
-            <a:off x="6278728" y="2086661"/>
+            <a:off x="6278728" y="2399386"/>
             <a:ext cx="38405" cy="38405"/>
           </a:xfrm>
           <a:prstGeom prst="ellipse">
             <a:avLst/>
           </a:prstGeom>
           <a:solidFill>
-            <a:srgbClr val="1E8449"/>
+            <a:srgbClr val="A6650F"/>
           </a:solidFill>
           <a:ln/>
         </p:spPr>
@@ -2563,8 +2563,8 @@
         </p:nvSpPr>
         <p:spPr>
           <a:xfrm>
-            <a:off x="6397600" y="2044598"/>
-            <a:ext cx="2412416" cy="211226"/>
+            <a:off x="6397600" y="2357323"/>
+            <a:ext cx="2412416" cy="183794"/>
           </a:xfrm>
           <a:prstGeom prst="rect">
             <a:avLst/>
@@ -2583,7 +2583,7 @@
               <a:buNone/>
             </a:pPr>
             <a:r>
-              <a:rPr lang="en-US" sz="670" dirty="0">
+              <a:rPr lang="en-US" sz="570" dirty="0">
                 <a:solidFill>
                   <a:srgbClr val="243044"/>
                 </a:solidFill>
@@ -2591,16 +2591,16 @@
                 <a:ea typeface="Calibri" pitchFamily="34" charset="-122"/>
                 <a:cs typeface="Calibri" pitchFamily="34" charset="-120"/>
               </a:rPr>
-              <a:t>Puntos Gerenciales: seminario "análisis de la cartera" y Diagnóstico SGCN  </a:t>
-            </a:r>
-            <a:pPr algn="l" indent="0" marL="0">
-              <a:lnSpc>
-                <a:spcPct val="98000"/>
-              </a:lnSpc>
-              <a:buNone/>
-            </a:pPr>
-            <a:r>
-              <a:rPr lang="en-US" sz="670" b="1" dirty="0">
+              <a:t>Elaboración de Matriz de Riesgos Operacionales por cambio de Procesador de TC  </a:t>
+            </a:r>
+            <a:pPr algn="l" indent="0" marL="0">
+              <a:lnSpc>
+                <a:spcPct val="98000"/>
+              </a:lnSpc>
+              <a:buNone/>
+            </a:pPr>
+            <a:r>
+              <a:rPr lang="en-US" sz="570" b="1" dirty="0">
                 <a:solidFill>
                   <a:srgbClr val="5B6B82"/>
                 </a:solidFill>
@@ -2608,9 +2608,9 @@
                 <a:ea typeface="Calibri" pitchFamily="34" charset="-122"/>
                 <a:cs typeface="Calibri" pitchFamily="34" charset="-120"/>
               </a:rPr>
-              <a:t>100%</a:t>
-            </a:r>
-            <a:endParaRPr lang="en-US" sz="670" dirty="0"/>
+              <a:t>50%</a:t>
+            </a:r>
+            <a:endParaRPr lang="en-US" sz="570" dirty="0"/>
           </a:p>
         </p:txBody>
       </p:sp>
@@ -2622,14 +2622,14 @@
         </p:nvSpPr>
         <p:spPr>
           <a:xfrm>
-            <a:off x="6278728" y="2284171"/>
+            <a:off x="6278728" y="2569464"/>
             <a:ext cx="38405" cy="38405"/>
           </a:xfrm>
           <a:prstGeom prst="ellipse">
             <a:avLst/>
           </a:prstGeom>
           <a:solidFill>
-            <a:srgbClr val="1E8449"/>
+            <a:srgbClr val="A6650F"/>
           </a:solidFill>
           <a:ln/>
         </p:spPr>
@@ -2642,8 +2642,8 @@
         </p:nvSpPr>
         <p:spPr>
           <a:xfrm>
-            <a:off x="6397600" y="2242109"/>
-            <a:ext cx="2412416" cy="211226"/>
+            <a:off x="6397600" y="2527402"/>
+            <a:ext cx="2412416" cy="105613"/>
           </a:xfrm>
           <a:prstGeom prst="rect">
             <a:avLst/>
@@ -2662,7 +2662,7 @@
               <a:buNone/>
             </a:pPr>
             <a:r>
-              <a:rPr lang="en-US" sz="670" dirty="0">
+              <a:rPr lang="en-US" sz="570" dirty="0">
                 <a:solidFill>
                   <a:srgbClr val="243044"/>
                 </a:solidFill>
@@ -2670,16 +2670,16 @@
                 <a:ea typeface="Calibri" pitchFamily="34" charset="-122"/>
                 <a:cs typeface="Calibri" pitchFamily="34" charset="-120"/>
               </a:rPr>
-              <a:t>Revisión de Líderes de CN solicitado por Procesos  </a:t>
-            </a:r>
-            <a:pPr algn="l" indent="0" marL="0">
-              <a:lnSpc>
-                <a:spcPct val="98000"/>
-              </a:lnSpc>
-              <a:buNone/>
-            </a:pPr>
-            <a:r>
-              <a:rPr lang="en-US" sz="670" b="1" dirty="0">
+              <a:t>Evento de pérdida TC, DPF  </a:t>
+            </a:r>
+            <a:pPr algn="l" indent="0" marL="0">
+              <a:lnSpc>
+                <a:spcPct val="98000"/>
+              </a:lnSpc>
+              <a:buNone/>
+            </a:pPr>
+            <a:r>
+              <a:rPr lang="en-US" sz="570" b="1" dirty="0">
                 <a:solidFill>
                   <a:srgbClr val="5B6B82"/>
                 </a:solidFill>
@@ -2687,26 +2687,105 @@
                 <a:ea typeface="Calibri" pitchFamily="34" charset="-122"/>
                 <a:cs typeface="Calibri" pitchFamily="34" charset="-120"/>
               </a:rPr>
+              <a:t>50%</a:t>
+            </a:r>
+            <a:endParaRPr lang="en-US" sz="570" dirty="0"/>
+          </a:p>
+        </p:txBody>
+      </p:sp>
+      <p:sp>
+        <p:nvSpPr>
+          <p:cNvPr id="60" name="Shape 55"/>
+          <p:cNvSpPr/>
+          <p:nvPr/>
+        </p:nvSpPr>
+        <p:spPr>
+          <a:xfrm>
+            <a:off x="6278728" y="2661361"/>
+            <a:ext cx="38405" cy="38405"/>
+          </a:xfrm>
+          <a:prstGeom prst="ellipse">
+            <a:avLst/>
+          </a:prstGeom>
+          <a:solidFill>
+            <a:srgbClr val="1E8449"/>
+          </a:solidFill>
+          <a:ln/>
+        </p:spPr>
+      </p:sp>
+      <p:sp>
+        <p:nvSpPr>
+          <p:cNvPr id="61" name="Text 56"/>
+          <p:cNvSpPr txBox="1"/>
+          <p:nvPr/>
+        </p:nvSpPr>
+        <p:spPr>
+          <a:xfrm>
+            <a:off x="6397600" y="2619299"/>
+            <a:ext cx="2412416" cy="105613"/>
+          </a:xfrm>
+          <a:prstGeom prst="rect">
+            <a:avLst/>
+          </a:prstGeom>
+          <a:noFill/>
+          <a:ln/>
+        </p:spPr>
+        <p:txBody>
+          <a:bodyPr wrap="square" lIns="0" tIns="0" rIns="0" bIns="0" rtlCol="0" anchor="t"/>
+          <a:lstStyle/>
+          <a:p>
+            <a:pPr algn="l" indent="0" marL="0">
+              <a:lnSpc>
+                <a:spcPct val="98000"/>
+              </a:lnSpc>
+              <a:buNone/>
+            </a:pPr>
+            <a:r>
+              <a:rPr lang="en-US" sz="570" dirty="0">
+                <a:solidFill>
+                  <a:srgbClr val="243044"/>
+                </a:solidFill>
+                <a:latin typeface="Calibri" pitchFamily="34" charset="0"/>
+                <a:ea typeface="Calibri" pitchFamily="34" charset="-122"/>
+                <a:cs typeface="Calibri" pitchFamily="34" charset="-120"/>
+              </a:rPr>
+              <a:t>Evaluación de Criticidad IT  </a:t>
+            </a:r>
+            <a:pPr algn="l" indent="0" marL="0">
+              <a:lnSpc>
+                <a:spcPct val="98000"/>
+              </a:lnSpc>
+              <a:buNone/>
+            </a:pPr>
+            <a:r>
+              <a:rPr lang="en-US" sz="570" b="1" dirty="0">
+                <a:solidFill>
+                  <a:srgbClr val="5B6B82"/>
+                </a:solidFill>
+                <a:latin typeface="Calibri" pitchFamily="34" charset="0"/>
+                <a:ea typeface="Calibri" pitchFamily="34" charset="-122"/>
+                <a:cs typeface="Calibri" pitchFamily="34" charset="-120"/>
+              </a:rPr>
               <a:t>100%</a:t>
             </a:r>
-            <a:endParaRPr lang="en-US" sz="670" dirty="0"/>
-          </a:p>
-        </p:txBody>
-      </p:sp>
-      <p:sp>
-        <p:nvSpPr>
-          <p:cNvPr id="60" name="Shape 55"/>
+            <a:endParaRPr lang="en-US" sz="570" dirty="0"/>
+          </a:p>
+        </p:txBody>
+      </p:sp>
+      <p:sp>
+        <p:nvSpPr>
+          <p:cNvPr id="62" name="Shape 57"/>
           <p:cNvSpPr/>
           <p:nvPr/>
         </p:nvSpPr>
         <p:spPr>
           <a:xfrm>
             <a:off x="9056903" y="1417320"/>
-            <a:ext cx="2769032" cy="1504950"/>
+            <a:ext cx="2769032" cy="1324356"/>
           </a:xfrm>
           <a:prstGeom prst="roundRect">
             <a:avLst>
-              <a:gd name="adj" fmla="val 4253"/>
+              <a:gd name="adj" fmla="val 4833"/>
             </a:avLst>
           </a:prstGeom>
           <a:solidFill>
@@ -2724,7 +2803,7 @@
       </p:sp>
       <p:sp>
         <p:nvSpPr>
-          <p:cNvPr id="61" name="Shape 56"/>
+          <p:cNvPr id="63" name="Shape 58"/>
           <p:cNvSpPr/>
           <p:nvPr/>
         </p:nvSpPr>
@@ -2737,14 +2816,14 @@
             <a:avLst/>
           </a:prstGeom>
           <a:solidFill>
-            <a:srgbClr val="1B4F91"/>
-          </a:solidFill>
-          <a:ln/>
-        </p:spPr>
-      </p:sp>
-      <p:sp>
-        <p:nvSpPr>
-          <p:cNvPr id="62" name="Shape 57"/>
+            <a:srgbClr val="0F766E"/>
+          </a:solidFill>
+          <a:ln/>
+        </p:spPr>
+      </p:sp>
+      <p:sp>
+        <p:nvSpPr>
+          <p:cNvPr id="64" name="Shape 59"/>
           <p:cNvSpPr/>
           <p:nvPr/>
         </p:nvSpPr>
@@ -2757,14 +2836,14 @@
             <a:avLst/>
           </a:prstGeom>
           <a:solidFill>
-            <a:srgbClr val="EAF0F8"/>
+            <a:srgbClr val="E4F5F3"/>
           </a:solidFill>
           <a:ln/>
         </p:spPr>
       </p:sp>
       <p:pic>
         <p:nvPicPr>
-          <p:cNvPr id="63" name="Image 3" descr="/tmp/claude-0/-home-user-riesgo/579fb8c8-70e5-51d5-80ec-6ed51cc2e8df/scratchpad/pptx-build/icons/briefcase_1B4F91.png">    </p:cNvPr>
+          <p:cNvPr id="65" name="Image 3" descr="/tmp/claude-0/-home-user-riesgo/579fb8c8-70e5-51d5-80ec-6ed51cc2e8df/scratchpad/pptx-build/icons/briefcase_1B4F91.png">    </p:cNvPr>
           <p:cNvPicPr>
             <a:picLocks noChangeAspect="1"/>
           </p:cNvPicPr>
@@ -2788,7 +2867,7 @@
       </p:pic>
       <p:sp>
         <p:nvSpPr>
-          <p:cNvPr id="64" name="Text 58"/>
+          <p:cNvPr id="66" name="Text 60"/>
           <p:cNvSpPr txBox="1"/>
           <p:nvPr/>
         </p:nvSpPr>
@@ -2830,7 +2909,7 @@
       </p:sp>
       <p:sp>
         <p:nvSpPr>
-          <p:cNvPr id="65" name="Shape 59"/>
+          <p:cNvPr id="67" name="Shape 61"/>
           <p:cNvSpPr/>
           <p:nvPr/>
         </p:nvSpPr>
@@ -2843,14 +2922,14 @@
             <a:avLst/>
           </a:prstGeom>
           <a:solidFill>
-            <a:srgbClr val="1B4F91"/>
-          </a:solidFill>
-          <a:ln/>
-        </p:spPr>
-      </p:sp>
-      <p:sp>
-        <p:nvSpPr>
-          <p:cNvPr id="66" name="Shape 60"/>
+            <a:srgbClr val="0F766E"/>
+          </a:solidFill>
+          <a:ln/>
+        </p:spPr>
+      </p:sp>
+      <p:sp>
+        <p:nvSpPr>
+          <p:cNvPr id="68" name="Shape 62"/>
           <p:cNvSpPr/>
           <p:nvPr/>
         </p:nvSpPr>
@@ -2863,85 +2942,6 @@
             <a:avLst/>
           </a:prstGeom>
           <a:solidFill>
-            <a:srgbClr val="A6650F"/>
-          </a:solidFill>
-          <a:ln/>
-        </p:spPr>
-      </p:sp>
-      <p:sp>
-        <p:nvSpPr>
-          <p:cNvPr id="67" name="Text 61"/>
-          <p:cNvSpPr txBox="1"/>
-          <p:nvPr/>
-        </p:nvSpPr>
-        <p:spPr>
-          <a:xfrm>
-            <a:off x="9294647" y="1847088"/>
-            <a:ext cx="2412416" cy="208483"/>
-          </a:xfrm>
-          <a:prstGeom prst="rect">
-            <a:avLst/>
-          </a:prstGeom>
-          <a:noFill/>
-          <a:ln/>
-        </p:spPr>
-        <p:txBody>
-          <a:bodyPr wrap="square" lIns="0" tIns="0" rIns="0" bIns="0" rtlCol="0" anchor="t"/>
-          <a:lstStyle/>
-          <a:p>
-            <a:pPr algn="l" indent="0" marL="0">
-              <a:lnSpc>
-                <a:spcPct val="98000"/>
-              </a:lnSpc>
-              <a:buNone/>
-            </a:pPr>
-            <a:r>
-              <a:rPr lang="en-US" sz="660" dirty="0">
-                <a:solidFill>
-                  <a:srgbClr val="243044"/>
-                </a:solidFill>
-                <a:latin typeface="Calibri" pitchFamily="34" charset="0"/>
-                <a:ea typeface="Calibri" pitchFamily="34" charset="-122"/>
-                <a:cs typeface="Calibri" pitchFamily="34" charset="-120"/>
-              </a:rPr>
-              <a:t>Creación de perfil Gerente General (web) y solicitud de arte a Mercadeo  </a:t>
-            </a:r>
-            <a:pPr algn="l" indent="0" marL="0">
-              <a:lnSpc>
-                <a:spcPct val="98000"/>
-              </a:lnSpc>
-              <a:buNone/>
-            </a:pPr>
-            <a:r>
-              <a:rPr lang="en-US" sz="660" b="1" dirty="0">
-                <a:solidFill>
-                  <a:srgbClr val="5B6B82"/>
-                </a:solidFill>
-                <a:latin typeface="Calibri" pitchFamily="34" charset="0"/>
-                <a:ea typeface="Calibri" pitchFamily="34" charset="-122"/>
-                <a:cs typeface="Calibri" pitchFamily="34" charset="-120"/>
-              </a:rPr>
-              <a:t>80%</a:t>
-            </a:r>
-            <a:endParaRPr lang="en-US" sz="660" dirty="0"/>
-          </a:p>
-        </p:txBody>
-      </p:sp>
-      <p:sp>
-        <p:nvSpPr>
-          <p:cNvPr id="68" name="Shape 62"/>
-          <p:cNvSpPr/>
-          <p:nvPr/>
-        </p:nvSpPr>
-        <p:spPr>
-          <a:xfrm>
-            <a:off x="9175775" y="2083918"/>
-            <a:ext cx="38405" cy="38405"/>
-          </a:xfrm>
-          <a:prstGeom prst="ellipse">
-            <a:avLst/>
-          </a:prstGeom>
-          <a:solidFill>
             <a:srgbClr val="1E8449"/>
           </a:solidFill>
           <a:ln/>
@@ -2955,8 +2955,8 @@
         </p:nvSpPr>
         <p:spPr>
           <a:xfrm>
-            <a:off x="9294647" y="2041855"/>
-            <a:ext cx="2412416" cy="208483"/>
+            <a:off x="9294647" y="1847088"/>
+            <a:ext cx="2412416" cy="122072"/>
           </a:xfrm>
           <a:prstGeom prst="rect">
             <a:avLst/>
@@ -2975,7 +2975,7 @@
               <a:buNone/>
             </a:pPr>
             <a:r>
-              <a:rPr lang="en-US" sz="660" dirty="0">
+              <a:rPr lang="en-US" sz="690" dirty="0">
                 <a:solidFill>
                   <a:srgbClr val="243044"/>
                 </a:solidFill>
@@ -2983,16 +2983,16 @@
                 <a:ea typeface="Calibri" pitchFamily="34" charset="-122"/>
                 <a:cs typeface="Calibri" pitchFamily="34" charset="-120"/>
               </a:rPr>
-              <a:t>Publicación en página web de actualización de Gobierno Corporativo  </a:t>
-            </a:r>
-            <a:pPr algn="l" indent="0" marL="0">
-              <a:lnSpc>
-                <a:spcPct val="98000"/>
-              </a:lnSpc>
-              <a:buNone/>
-            </a:pPr>
-            <a:r>
-              <a:rPr lang="en-US" sz="660" b="1" dirty="0">
+              <a:t>Envío de RIA #4 Gobierno Corporativo  </a:t>
+            </a:r>
+            <a:pPr algn="l" indent="0" marL="0">
+              <a:lnSpc>
+                <a:spcPct val="98000"/>
+              </a:lnSpc>
+              <a:buNone/>
+            </a:pPr>
+            <a:r>
+              <a:rPr lang="en-US" sz="690" b="1" dirty="0">
                 <a:solidFill>
                   <a:srgbClr val="5B6B82"/>
                 </a:solidFill>
@@ -3002,7 +3002,7 @@
               </a:rPr>
               <a:t>100%</a:t>
             </a:r>
-            <a:endParaRPr lang="en-US" sz="660" dirty="0"/>
+            <a:endParaRPr lang="en-US" sz="690" dirty="0"/>
           </a:p>
         </p:txBody>
       </p:sp>
@@ -3014,7 +3014,7 @@
         </p:nvSpPr>
         <p:spPr>
           <a:xfrm>
-            <a:off x="9175775" y="2278685"/>
+            <a:off x="9175775" y="1997507"/>
             <a:ext cx="38405" cy="38405"/>
           </a:xfrm>
           <a:prstGeom prst="ellipse">
@@ -3034,8 +3034,8 @@
         </p:nvSpPr>
         <p:spPr>
           <a:xfrm>
-            <a:off x="9294647" y="2236622"/>
-            <a:ext cx="2412416" cy="208483"/>
+            <a:off x="9294647" y="1955444"/>
+            <a:ext cx="2412416" cy="122072"/>
           </a:xfrm>
           <a:prstGeom prst="rect">
             <a:avLst/>
@@ -3054,7 +3054,7 @@
               <a:buNone/>
             </a:pPr>
             <a:r>
-              <a:rPr lang="en-US" sz="660" dirty="0">
+              <a:rPr lang="en-US" sz="690" dirty="0">
                 <a:solidFill>
                   <a:srgbClr val="243044"/>
                 </a:solidFill>
@@ -3062,16 +3062,16 @@
                 <a:ea typeface="Calibri" pitchFamily="34" charset="-122"/>
                 <a:cs typeface="Calibri" pitchFamily="34" charset="-120"/>
               </a:rPr>
-              <a:t>Envío de acuerdo del CA a Mercadeo y Educación (traslado de créditos / récord crediticio)  </a:t>
-            </a:r>
-            <a:pPr algn="l" indent="0" marL="0">
-              <a:lnSpc>
-                <a:spcPct val="98000"/>
-              </a:lnSpc>
-              <a:buNone/>
-            </a:pPr>
-            <a:r>
-              <a:rPr lang="en-US" sz="660" b="1" dirty="0">
+              <a:t>Envío de RIA #5 Gobierno Corporativo  </a:t>
+            </a:r>
+            <a:pPr algn="l" indent="0" marL="0">
+              <a:lnSpc>
+                <a:spcPct val="98000"/>
+              </a:lnSpc>
+              <a:buNone/>
+            </a:pPr>
+            <a:r>
+              <a:rPr lang="en-US" sz="690" b="1" dirty="0">
                 <a:solidFill>
                   <a:srgbClr val="5B6B82"/>
                 </a:solidFill>
@@ -3081,7 +3081,7 @@
               </a:rPr>
               <a:t>100%</a:t>
             </a:r>
-            <a:endParaRPr lang="en-US" sz="660" dirty="0"/>
+            <a:endParaRPr lang="en-US" sz="690" dirty="0"/>
           </a:p>
         </p:txBody>
       </p:sp>
@@ -3093,244 +3093,7 @@
         </p:nvSpPr>
         <p:spPr>
           <a:xfrm>
-            <a:off x="9175775" y="2473452"/>
-            <a:ext cx="38405" cy="38405"/>
-          </a:xfrm>
-          <a:prstGeom prst="ellipse">
-            <a:avLst/>
-          </a:prstGeom>
-          <a:solidFill>
-            <a:srgbClr val="1E8449"/>
-          </a:solidFill>
-          <a:ln/>
-        </p:spPr>
-      </p:sp>
-      <p:sp>
-        <p:nvSpPr>
-          <p:cNvPr id="73" name="Text 67"/>
-          <p:cNvSpPr txBox="1"/>
-          <p:nvPr/>
-        </p:nvSpPr>
-        <p:spPr>
-          <a:xfrm>
-            <a:off x="9294647" y="2431390"/>
-            <a:ext cx="2412416" cy="117958"/>
-          </a:xfrm>
-          <a:prstGeom prst="rect">
-            <a:avLst/>
-          </a:prstGeom>
-          <a:noFill/>
-          <a:ln/>
-        </p:spPr>
-        <p:txBody>
-          <a:bodyPr wrap="square" lIns="0" tIns="0" rIns="0" bIns="0" rtlCol="0" anchor="t"/>
-          <a:lstStyle/>
-          <a:p>
-            <a:pPr algn="l" indent="0" marL="0">
-              <a:lnSpc>
-                <a:spcPct val="98000"/>
-              </a:lnSpc>
-              <a:buNone/>
-            </a:pPr>
-            <a:r>
-              <a:rPr lang="en-US" sz="660" dirty="0">
-                <a:solidFill>
-                  <a:srgbClr val="243044"/>
-                </a:solidFill>
-                <a:latin typeface="Calibri" pitchFamily="34" charset="0"/>
-                <a:ea typeface="Calibri" pitchFamily="34" charset="-122"/>
-                <a:cs typeface="Calibri" pitchFamily="34" charset="-120"/>
-              </a:rPr>
-              <a:t>Envío de RIA #1 Gobierno Corporativo  </a:t>
-            </a:r>
-            <a:pPr algn="l" indent="0" marL="0">
-              <a:lnSpc>
-                <a:spcPct val="98000"/>
-              </a:lnSpc>
-              <a:buNone/>
-            </a:pPr>
-            <a:r>
-              <a:rPr lang="en-US" sz="660" b="1" dirty="0">
-                <a:solidFill>
-                  <a:srgbClr val="5B6B82"/>
-                </a:solidFill>
-                <a:latin typeface="Calibri" pitchFamily="34" charset="0"/>
-                <a:ea typeface="Calibri" pitchFamily="34" charset="-122"/>
-                <a:cs typeface="Calibri" pitchFamily="34" charset="-120"/>
-              </a:rPr>
-              <a:t>100%</a:t>
-            </a:r>
-            <a:endParaRPr lang="en-US" sz="660" dirty="0"/>
-          </a:p>
-        </p:txBody>
-      </p:sp>
-      <p:sp>
-        <p:nvSpPr>
-          <p:cNvPr id="74" name="Shape 68"/>
-          <p:cNvSpPr/>
-          <p:nvPr/>
-        </p:nvSpPr>
-        <p:spPr>
-          <a:xfrm>
-            <a:off x="9175775" y="2577694"/>
-            <a:ext cx="38405" cy="38405"/>
-          </a:xfrm>
-          <a:prstGeom prst="ellipse">
-            <a:avLst/>
-          </a:prstGeom>
-          <a:solidFill>
-            <a:srgbClr val="1E8449"/>
-          </a:solidFill>
-          <a:ln/>
-        </p:spPr>
-      </p:sp>
-      <p:sp>
-        <p:nvSpPr>
-          <p:cNvPr id="75" name="Text 69"/>
-          <p:cNvSpPr txBox="1"/>
-          <p:nvPr/>
-        </p:nvSpPr>
-        <p:spPr>
-          <a:xfrm>
-            <a:off x="9294647" y="2535631"/>
-            <a:ext cx="2412416" cy="117958"/>
-          </a:xfrm>
-          <a:prstGeom prst="rect">
-            <a:avLst/>
-          </a:prstGeom>
-          <a:noFill/>
-          <a:ln/>
-        </p:spPr>
-        <p:txBody>
-          <a:bodyPr wrap="square" lIns="0" tIns="0" rIns="0" bIns="0" rtlCol="0" anchor="t"/>
-          <a:lstStyle/>
-          <a:p>
-            <a:pPr algn="l" indent="0" marL="0">
-              <a:lnSpc>
-                <a:spcPct val="98000"/>
-              </a:lnSpc>
-              <a:buNone/>
-            </a:pPr>
-            <a:r>
-              <a:rPr lang="en-US" sz="660" dirty="0">
-                <a:solidFill>
-                  <a:srgbClr val="243044"/>
-                </a:solidFill>
-                <a:latin typeface="Calibri" pitchFamily="34" charset="0"/>
-                <a:ea typeface="Calibri" pitchFamily="34" charset="-122"/>
-                <a:cs typeface="Calibri" pitchFamily="34" charset="-120"/>
-              </a:rPr>
-              <a:t>Envío de RIA #2 Gobierno Corporativo  </a:t>
-            </a:r>
-            <a:pPr algn="l" indent="0" marL="0">
-              <a:lnSpc>
-                <a:spcPct val="98000"/>
-              </a:lnSpc>
-              <a:buNone/>
-            </a:pPr>
-            <a:r>
-              <a:rPr lang="en-US" sz="660" b="1" dirty="0">
-                <a:solidFill>
-                  <a:srgbClr val="5B6B82"/>
-                </a:solidFill>
-                <a:latin typeface="Calibri" pitchFamily="34" charset="0"/>
-                <a:ea typeface="Calibri" pitchFamily="34" charset="-122"/>
-                <a:cs typeface="Calibri" pitchFamily="34" charset="-120"/>
-              </a:rPr>
-              <a:t>100%</a:t>
-            </a:r>
-            <a:endParaRPr lang="en-US" sz="660" dirty="0"/>
-          </a:p>
-        </p:txBody>
-      </p:sp>
-      <p:sp>
-        <p:nvSpPr>
-          <p:cNvPr id="76" name="Shape 70"/>
-          <p:cNvSpPr/>
-          <p:nvPr/>
-        </p:nvSpPr>
-        <p:spPr>
-          <a:xfrm>
-            <a:off x="9175775" y="2681935"/>
-            <a:ext cx="38405" cy="38405"/>
-          </a:xfrm>
-          <a:prstGeom prst="ellipse">
-            <a:avLst/>
-          </a:prstGeom>
-          <a:solidFill>
-            <a:srgbClr val="1E8449"/>
-          </a:solidFill>
-          <a:ln/>
-        </p:spPr>
-      </p:sp>
-      <p:sp>
-        <p:nvSpPr>
-          <p:cNvPr id="77" name="Text 71"/>
-          <p:cNvSpPr txBox="1"/>
-          <p:nvPr/>
-        </p:nvSpPr>
-        <p:spPr>
-          <a:xfrm>
-            <a:off x="9294647" y="2639873"/>
-            <a:ext cx="2412416" cy="117958"/>
-          </a:xfrm>
-          <a:prstGeom prst="rect">
-            <a:avLst/>
-          </a:prstGeom>
-          <a:noFill/>
-          <a:ln/>
-        </p:spPr>
-        <p:txBody>
-          <a:bodyPr wrap="square" lIns="0" tIns="0" rIns="0" bIns="0" rtlCol="0" anchor="t"/>
-          <a:lstStyle/>
-          <a:p>
-            <a:pPr algn="l" indent="0" marL="0">
-              <a:lnSpc>
-                <a:spcPct val="98000"/>
-              </a:lnSpc>
-              <a:buNone/>
-            </a:pPr>
-            <a:r>
-              <a:rPr lang="en-US" sz="660" dirty="0">
-                <a:solidFill>
-                  <a:srgbClr val="243044"/>
-                </a:solidFill>
-                <a:latin typeface="Calibri" pitchFamily="34" charset="0"/>
-                <a:ea typeface="Calibri" pitchFamily="34" charset="-122"/>
-                <a:cs typeface="Calibri" pitchFamily="34" charset="-120"/>
-              </a:rPr>
-              <a:t>Envío de RIA #3 Gobierno Corporativo  </a:t>
-            </a:r>
-            <a:pPr algn="l" indent="0" marL="0">
-              <a:lnSpc>
-                <a:spcPct val="98000"/>
-              </a:lnSpc>
-              <a:buNone/>
-            </a:pPr>
-            <a:r>
-              <a:rPr lang="en-US" sz="660" b="1" dirty="0">
-                <a:solidFill>
-                  <a:srgbClr val="5B6B82"/>
-                </a:solidFill>
-                <a:latin typeface="Calibri" pitchFamily="34" charset="0"/>
-                <a:ea typeface="Calibri" pitchFamily="34" charset="-122"/>
-                <a:cs typeface="Calibri" pitchFamily="34" charset="-120"/>
-              </a:rPr>
-              <a:t>100%</a:t>
-            </a:r>
-            <a:endParaRPr lang="en-US" sz="660" dirty="0"/>
-          </a:p>
-        </p:txBody>
-      </p:sp>
-      <p:sp>
-        <p:nvSpPr>
-          <p:cNvPr id="78" name="Shape 72"/>
-          <p:cNvSpPr/>
-          <p:nvPr/>
-        </p:nvSpPr>
-        <p:spPr>
-          <a:xfrm>
-            <a:off x="365760" y="3013710"/>
+            <a:off x="365760" y="2833116"/>
             <a:ext cx="11460175" cy="219456"/>
           </a:xfrm>
           <a:prstGeom prst="roundRect">
@@ -3346,13 +3109,13 @@
       </p:sp>
       <p:sp>
         <p:nvSpPr>
-          <p:cNvPr id="79" name="Text 73"/>
+          <p:cNvPr id="73" name="Text 67"/>
           <p:cNvSpPr txBox="1"/>
           <p:nvPr/>
         </p:nvSpPr>
         <p:spPr>
           <a:xfrm>
-            <a:off x="493776" y="3013710"/>
+            <a:off x="493776" y="2833116"/>
             <a:ext cx="8716975" cy="219456"/>
           </a:xfrm>
           <a:prstGeom prst="rect">
@@ -3385,13 +3148,13 @@
       </p:sp>
       <p:sp>
         <p:nvSpPr>
-          <p:cNvPr id="80" name="Text 74"/>
+          <p:cNvPr id="74" name="Text 68"/>
           <p:cNvSpPr txBox="1"/>
           <p:nvPr/>
         </p:nvSpPr>
         <p:spPr>
           <a:xfrm>
-            <a:off x="9174175" y="3013710"/>
+            <a:off x="9174175" y="2833116"/>
             <a:ext cx="2523744" cy="219456"/>
           </a:xfrm>
           <a:prstGeom prst="rect">
@@ -3416,7 +3179,7 @@
                 <a:ea typeface="Calibri" pitchFamily="34" charset="-122"/>
                 <a:cs typeface="Calibri" pitchFamily="34" charset="-120"/>
               </a:rPr>
-              <a:t>9 actividades</a:t>
+              <a:t>12 actividades</a:t>
             </a:r>
             <a:endParaRPr lang="en-US" sz="800" dirty="0"/>
           </a:p>
@@ -3424,18 +3187,18 @@
       </p:sp>
       <p:sp>
         <p:nvSpPr>
-          <p:cNvPr id="81" name="Shape 75"/>
-          <p:cNvSpPr/>
-          <p:nvPr/>
-        </p:nvSpPr>
-        <p:spPr>
-          <a:xfrm>
-            <a:off x="365760" y="3260598"/>
-            <a:ext cx="3734714" cy="993267"/>
+          <p:cNvPr id="75" name="Shape 69"/>
+          <p:cNvSpPr/>
+          <p:nvPr/>
+        </p:nvSpPr>
+        <p:spPr>
+          <a:xfrm>
+            <a:off x="365760" y="3080004"/>
+            <a:ext cx="3734714" cy="1173861"/>
           </a:xfrm>
           <a:prstGeom prst="roundRect">
             <a:avLst>
-              <a:gd name="adj" fmla="val 6444"/>
+              <a:gd name="adj" fmla="val 5453"/>
             </a:avLst>
           </a:prstGeom>
           <a:solidFill>
@@ -3453,13 +3216,13 @@
       </p:sp>
       <p:sp>
         <p:nvSpPr>
-          <p:cNvPr id="82" name="Shape 76"/>
-          <p:cNvSpPr/>
-          <p:nvPr/>
-        </p:nvSpPr>
-        <p:spPr>
-          <a:xfrm>
-            <a:off x="365760" y="3260598"/>
+          <p:cNvPr id="76" name="Shape 70"/>
+          <p:cNvSpPr/>
+          <p:nvPr/>
+        </p:nvSpPr>
+        <p:spPr>
+          <a:xfrm>
+            <a:off x="365760" y="3080004"/>
             <a:ext cx="3734714" cy="41148"/>
           </a:xfrm>
           <a:prstGeom prst="rect">
@@ -3473,13 +3236,13 @@
       </p:sp>
       <p:sp>
         <p:nvSpPr>
-          <p:cNvPr id="83" name="Shape 77"/>
-          <p:cNvSpPr/>
-          <p:nvPr/>
-        </p:nvSpPr>
-        <p:spPr>
-          <a:xfrm>
-            <a:off x="2132533" y="3310890"/>
+          <p:cNvPr id="77" name="Shape 71"/>
+          <p:cNvSpPr/>
+          <p:nvPr/>
+        </p:nvSpPr>
+        <p:spPr>
+          <a:xfrm>
+            <a:off x="2132533" y="3130296"/>
             <a:ext cx="201168" cy="201168"/>
           </a:xfrm>
           <a:prstGeom prst="ellipse">
@@ -3493,7 +3256,7 @@
       </p:sp>
       <p:pic>
         <p:nvPicPr>
-          <p:cNvPr id="84" name="Image 4" descr="/tmp/claude-0/-home-user-riesgo/579fb8c8-70e5-51d5-80ec-6ed51cc2e8df/scratchpad/pptx-build/icons/users_1B4F91.png">    </p:cNvPr>
+          <p:cNvPr id="78" name="Image 4" descr="/tmp/claude-0/-home-user-riesgo/579fb8c8-70e5-51d5-80ec-6ed51cc2e8df/scratchpad/pptx-build/icons/users_1B4F91.png">    </p:cNvPr>
           <p:cNvPicPr>
             <a:picLocks noChangeAspect="1"/>
           </p:cNvPicPr>
@@ -3507,7 +3270,7 @@
         </p:blipFill>
         <p:spPr>
           <a:xfrm>
-            <a:off x="2172767" y="3351124"/>
+            <a:off x="2172767" y="3170530"/>
             <a:ext cx="120701" cy="120701"/>
           </a:xfrm>
           <a:prstGeom prst="rect">
@@ -3517,13 +3280,13 @@
       </p:pic>
       <p:sp>
         <p:nvSpPr>
-          <p:cNvPr id="85" name="Text 78"/>
+          <p:cNvPr id="79" name="Text 72"/>
           <p:cNvSpPr txBox="1"/>
           <p:nvPr/>
         </p:nvSpPr>
         <p:spPr>
           <a:xfrm>
-            <a:off x="411480" y="3544062"/>
+            <a:off x="411480" y="3363468"/>
             <a:ext cx="3643274" cy="237744"/>
           </a:xfrm>
           <a:prstGeom prst="rect">
@@ -3559,13 +3322,13 @@
       </p:sp>
       <p:sp>
         <p:nvSpPr>
-          <p:cNvPr id="86" name="Shape 79"/>
-          <p:cNvSpPr/>
-          <p:nvPr/>
-        </p:nvSpPr>
-        <p:spPr>
-          <a:xfrm>
-            <a:off x="2114245" y="3662934"/>
+          <p:cNvPr id="80" name="Shape 73"/>
+          <p:cNvSpPr/>
+          <p:nvPr/>
+        </p:nvSpPr>
+        <p:spPr>
+          <a:xfrm>
+            <a:off x="2114245" y="3482340"/>
             <a:ext cx="237744" cy="13716"/>
           </a:xfrm>
           <a:prstGeom prst="rect">
@@ -3579,13 +3342,199 @@
       </p:sp>
       <p:sp>
         <p:nvSpPr>
+          <p:cNvPr id="81" name="Shape 74"/>
+          <p:cNvSpPr/>
+          <p:nvPr/>
+        </p:nvSpPr>
+        <p:spPr>
+          <a:xfrm>
+            <a:off x="484632" y="3551834"/>
+            <a:ext cx="38405" cy="38405"/>
+          </a:xfrm>
+          <a:prstGeom prst="ellipse">
+            <a:avLst/>
+          </a:prstGeom>
+          <a:solidFill>
+            <a:srgbClr val="1E8449"/>
+          </a:solidFill>
+          <a:ln/>
+        </p:spPr>
+      </p:sp>
+      <p:sp>
+        <p:nvSpPr>
+          <p:cNvPr id="82" name="Text 75"/>
+          <p:cNvSpPr txBox="1"/>
+          <p:nvPr/>
+        </p:nvSpPr>
+        <p:spPr>
+          <a:xfrm>
+            <a:off x="603504" y="3509772"/>
+            <a:ext cx="3378098" cy="119329"/>
+          </a:xfrm>
+          <a:prstGeom prst="rect">
+            <a:avLst/>
+          </a:prstGeom>
+          <a:noFill/>
+          <a:ln/>
+        </p:spPr>
+        <p:txBody>
+          <a:bodyPr wrap="square" lIns="0" tIns="0" rIns="0" bIns="0" rtlCol="0" anchor="t"/>
+          <a:lstStyle/>
+          <a:p>
+            <a:pPr algn="l" indent="0" marL="0">
+              <a:lnSpc>
+                <a:spcPct val="98000"/>
+              </a:lnSpc>
+              <a:buNone/>
+            </a:pPr>
+            <a:r>
+              <a:rPr lang="en-US" sz="670" dirty="0">
+                <a:solidFill>
+                  <a:srgbClr val="243044"/>
+                </a:solidFill>
+                <a:latin typeface="Calibri" pitchFamily="34" charset="0"/>
+                <a:ea typeface="Calibri" pitchFamily="34" charset="-122"/>
+                <a:cs typeface="Calibri" pitchFamily="34" charset="-120"/>
+              </a:rPr>
+              <a:t>Elaboración matriz de acuerdos Comité de Riesgos</a:t>
+            </a:r>
+            <a:endParaRPr lang="en-US" sz="670" dirty="0"/>
+          </a:p>
+        </p:txBody>
+      </p:sp>
+      <p:sp>
+        <p:nvSpPr>
+          <p:cNvPr id="83" name="Shape 76"/>
+          <p:cNvSpPr/>
+          <p:nvPr/>
+        </p:nvSpPr>
+        <p:spPr>
+          <a:xfrm>
+            <a:off x="484632" y="3657448"/>
+            <a:ext cx="38405" cy="38405"/>
+          </a:xfrm>
+          <a:prstGeom prst="ellipse">
+            <a:avLst/>
+          </a:prstGeom>
+          <a:solidFill>
+            <a:srgbClr val="1E8449"/>
+          </a:solidFill>
+          <a:ln/>
+        </p:spPr>
+      </p:sp>
+      <p:sp>
+        <p:nvSpPr>
+          <p:cNvPr id="84" name="Text 77"/>
+          <p:cNvSpPr txBox="1"/>
+          <p:nvPr/>
+        </p:nvSpPr>
+        <p:spPr>
+          <a:xfrm>
+            <a:off x="603504" y="3615385"/>
+            <a:ext cx="3378098" cy="119329"/>
+          </a:xfrm>
+          <a:prstGeom prst="rect">
+            <a:avLst/>
+          </a:prstGeom>
+          <a:noFill/>
+          <a:ln/>
+        </p:spPr>
+        <p:txBody>
+          <a:bodyPr wrap="square" lIns="0" tIns="0" rIns="0" bIns="0" rtlCol="0" anchor="t"/>
+          <a:lstStyle/>
+          <a:p>
+            <a:pPr algn="l" indent="0" marL="0">
+              <a:lnSpc>
+                <a:spcPct val="98000"/>
+              </a:lnSpc>
+              <a:buNone/>
+            </a:pPr>
+            <a:r>
+              <a:rPr lang="en-US" sz="670" dirty="0">
+                <a:solidFill>
+                  <a:srgbClr val="243044"/>
+                </a:solidFill>
+                <a:latin typeface="Calibri" pitchFamily="34" charset="0"/>
+                <a:ea typeface="Calibri" pitchFamily="34" charset="-122"/>
+                <a:cs typeface="Calibri" pitchFamily="34" charset="-120"/>
+              </a:rPr>
+              <a:t>Acta mensual Comité de Riesgos</a:t>
+            </a:r>
+            <a:endParaRPr lang="en-US" sz="670" dirty="0"/>
+          </a:p>
+        </p:txBody>
+      </p:sp>
+      <p:sp>
+        <p:nvSpPr>
+          <p:cNvPr id="85" name="Shape 78"/>
+          <p:cNvSpPr/>
+          <p:nvPr/>
+        </p:nvSpPr>
+        <p:spPr>
+          <a:xfrm>
+            <a:off x="484632" y="3763061"/>
+            <a:ext cx="38405" cy="38405"/>
+          </a:xfrm>
+          <a:prstGeom prst="ellipse">
+            <a:avLst/>
+          </a:prstGeom>
+          <a:solidFill>
+            <a:srgbClr val="1E8449"/>
+          </a:solidFill>
+          <a:ln/>
+        </p:spPr>
+      </p:sp>
+      <p:sp>
+        <p:nvSpPr>
+          <p:cNvPr id="86" name="Text 79"/>
+          <p:cNvSpPr txBox="1"/>
+          <p:nvPr/>
+        </p:nvSpPr>
+        <p:spPr>
+          <a:xfrm>
+            <a:off x="603504" y="3720998"/>
+            <a:ext cx="3378098" cy="211226"/>
+          </a:xfrm>
+          <a:prstGeom prst="rect">
+            <a:avLst/>
+          </a:prstGeom>
+          <a:noFill/>
+          <a:ln/>
+        </p:spPr>
+        <p:txBody>
+          <a:bodyPr wrap="square" lIns="0" tIns="0" rIns="0" bIns="0" rtlCol="0" anchor="t"/>
+          <a:lstStyle/>
+          <a:p>
+            <a:pPr algn="l" indent="0" marL="0">
+              <a:lnSpc>
+                <a:spcPct val="98000"/>
+              </a:lnSpc>
+              <a:buNone/>
+            </a:pPr>
+            <a:r>
+              <a:rPr lang="en-US" sz="670" dirty="0">
+                <a:solidFill>
+                  <a:srgbClr val="243044"/>
+                </a:solidFill>
+                <a:latin typeface="Calibri" pitchFamily="34" charset="0"/>
+                <a:ea typeface="Calibri" pitchFamily="34" charset="-122"/>
+                <a:cs typeface="Calibri" pitchFamily="34" charset="-120"/>
+              </a:rPr>
+              <a:t>Elaboración de informe Mensual de sesión de Comité de Riesgos al Consejo de Administración</a:t>
+            </a:r>
+            <a:endParaRPr lang="en-US" sz="670" dirty="0"/>
+          </a:p>
+        </p:txBody>
+      </p:sp>
+      <p:sp>
+        <p:nvSpPr>
           <p:cNvPr id="87" name="Shape 80"/>
           <p:cNvSpPr/>
           <p:nvPr/>
         </p:nvSpPr>
         <p:spPr>
           <a:xfrm>
-            <a:off x="484632" y="3732428"/>
+            <a:off x="484632" y="3960571"/>
             <a:ext cx="38405" cy="38405"/>
           </a:xfrm>
           <a:prstGeom prst="ellipse">
@@ -3605,7 +3554,7 @@
         </p:nvSpPr>
         <p:spPr>
           <a:xfrm>
-            <a:off x="603504" y="3690366"/>
+            <a:off x="603504" y="3918509"/>
             <a:ext cx="3378098" cy="119329"/>
           </a:xfrm>
           <a:prstGeom prst="rect">
@@ -3633,7 +3582,7 @@
                 <a:ea typeface="Calibri" pitchFamily="34" charset="-122"/>
                 <a:cs typeface="Calibri" pitchFamily="34" charset="-120"/>
               </a:rPr>
-              <a:t>Elaboración matriz de acuerdos Comité de Riesgos</a:t>
+              <a:t>Elaboración informe riesgo legal para Comité de Riesgos</a:t>
             </a:r>
             <a:endParaRPr lang="en-US" sz="670" dirty="0"/>
           </a:p>
@@ -3647,198 +3596,12 @@
         </p:nvSpPr>
         <p:spPr>
           <a:xfrm>
-            <a:off x="484632" y="3838042"/>
-            <a:ext cx="38405" cy="38405"/>
-          </a:xfrm>
-          <a:prstGeom prst="ellipse">
-            <a:avLst/>
-          </a:prstGeom>
-          <a:solidFill>
-            <a:srgbClr val="A6650F"/>
-          </a:solidFill>
-          <a:ln/>
-        </p:spPr>
-      </p:sp>
-      <p:sp>
-        <p:nvSpPr>
-          <p:cNvPr id="90" name="Text 83"/>
-          <p:cNvSpPr txBox="1"/>
-          <p:nvPr/>
-        </p:nvSpPr>
-        <p:spPr>
-          <a:xfrm>
-            <a:off x="603504" y="3795979"/>
-            <a:ext cx="3378098" cy="119329"/>
-          </a:xfrm>
-          <a:prstGeom prst="rect">
-            <a:avLst/>
-          </a:prstGeom>
-          <a:noFill/>
-          <a:ln/>
-        </p:spPr>
-        <p:txBody>
-          <a:bodyPr wrap="square" lIns="0" tIns="0" rIns="0" bIns="0" rtlCol="0" anchor="t"/>
-          <a:lstStyle/>
-          <a:p>
-            <a:pPr algn="l" indent="0" marL="0">
-              <a:lnSpc>
-                <a:spcPct val="98000"/>
-              </a:lnSpc>
-              <a:buNone/>
-            </a:pPr>
-            <a:r>
-              <a:rPr lang="en-US" sz="670" dirty="0">
-                <a:solidFill>
-                  <a:srgbClr val="243044"/>
-                </a:solidFill>
-                <a:latin typeface="Calibri" pitchFamily="34" charset="0"/>
-                <a:ea typeface="Calibri" pitchFamily="34" charset="-122"/>
-                <a:cs typeface="Calibri" pitchFamily="34" charset="-120"/>
-              </a:rPr>
-              <a:t>Acta mensual Comité de Riesgos</a:t>
-            </a:r>
-            <a:endParaRPr lang="en-US" sz="670" dirty="0"/>
-          </a:p>
-        </p:txBody>
-      </p:sp>
-      <p:sp>
-        <p:nvSpPr>
-          <p:cNvPr id="91" name="Shape 84"/>
-          <p:cNvSpPr/>
-          <p:nvPr/>
-        </p:nvSpPr>
-        <p:spPr>
-          <a:xfrm>
-            <a:off x="484632" y="3943655"/>
-            <a:ext cx="38405" cy="38405"/>
-          </a:xfrm>
-          <a:prstGeom prst="ellipse">
-            <a:avLst/>
-          </a:prstGeom>
-          <a:solidFill>
-            <a:srgbClr val="A6650F"/>
-          </a:solidFill>
-          <a:ln/>
-        </p:spPr>
-      </p:sp>
-      <p:sp>
-        <p:nvSpPr>
-          <p:cNvPr id="92" name="Text 85"/>
-          <p:cNvSpPr txBox="1"/>
-          <p:nvPr/>
-        </p:nvSpPr>
-        <p:spPr>
-          <a:xfrm>
-            <a:off x="603504" y="3901592"/>
-            <a:ext cx="3378098" cy="119329"/>
-          </a:xfrm>
-          <a:prstGeom prst="rect">
-            <a:avLst/>
-          </a:prstGeom>
-          <a:noFill/>
-          <a:ln/>
-        </p:spPr>
-        <p:txBody>
-          <a:bodyPr wrap="square" lIns="0" tIns="0" rIns="0" bIns="0" rtlCol="0" anchor="t"/>
-          <a:lstStyle/>
-          <a:p>
-            <a:pPr algn="l" indent="0" marL="0">
-              <a:lnSpc>
-                <a:spcPct val="98000"/>
-              </a:lnSpc>
-              <a:buNone/>
-            </a:pPr>
-            <a:r>
-              <a:rPr lang="en-US" sz="670" dirty="0">
-                <a:solidFill>
-                  <a:srgbClr val="243044"/>
-                </a:solidFill>
-                <a:latin typeface="Calibri" pitchFamily="34" charset="0"/>
-                <a:ea typeface="Calibri" pitchFamily="34" charset="-122"/>
-                <a:cs typeface="Calibri" pitchFamily="34" charset="-120"/>
-              </a:rPr>
-              <a:t>Informe mensual de sesión de Comité de Riesgos al Consejo de Administración</a:t>
-            </a:r>
-            <a:endParaRPr lang="en-US" sz="670" dirty="0"/>
-          </a:p>
-        </p:txBody>
-      </p:sp>
-      <p:sp>
-        <p:nvSpPr>
-          <p:cNvPr id="93" name="Shape 86"/>
-          <p:cNvSpPr/>
-          <p:nvPr/>
-        </p:nvSpPr>
-        <p:spPr>
-          <a:xfrm>
-            <a:off x="484632" y="4049268"/>
-            <a:ext cx="38405" cy="38405"/>
-          </a:xfrm>
-          <a:prstGeom prst="ellipse">
-            <a:avLst/>
-          </a:prstGeom>
-          <a:solidFill>
-            <a:srgbClr val="C3CBD6"/>
-          </a:solidFill>
-          <a:ln/>
-        </p:spPr>
-      </p:sp>
-      <p:sp>
-        <p:nvSpPr>
-          <p:cNvPr id="94" name="Text 87"/>
-          <p:cNvSpPr txBox="1"/>
-          <p:nvPr/>
-        </p:nvSpPr>
-        <p:spPr>
-          <a:xfrm>
-            <a:off x="603504" y="4007206"/>
-            <a:ext cx="3378098" cy="119329"/>
-          </a:xfrm>
-          <a:prstGeom prst="rect">
-            <a:avLst/>
-          </a:prstGeom>
-          <a:noFill/>
-          <a:ln/>
-        </p:spPr>
-        <p:txBody>
-          <a:bodyPr wrap="square" lIns="0" tIns="0" rIns="0" bIns="0" rtlCol="0" anchor="t"/>
-          <a:lstStyle/>
-          <a:p>
-            <a:pPr algn="l" indent="0" marL="0">
-              <a:lnSpc>
-                <a:spcPct val="98000"/>
-              </a:lnSpc>
-              <a:buNone/>
-            </a:pPr>
-            <a:r>
-              <a:rPr lang="en-US" sz="670" dirty="0">
-                <a:solidFill>
-                  <a:srgbClr val="243044"/>
-                </a:solidFill>
-                <a:latin typeface="Calibri" pitchFamily="34" charset="0"/>
-                <a:ea typeface="Calibri" pitchFamily="34" charset="-122"/>
-                <a:cs typeface="Calibri" pitchFamily="34" charset="-120"/>
-              </a:rPr>
-              <a:t>Presentación de informes para Comité de Riesgos</a:t>
-            </a:r>
-            <a:endParaRPr lang="en-US" sz="670" dirty="0"/>
-          </a:p>
-        </p:txBody>
-      </p:sp>
-      <p:sp>
-        <p:nvSpPr>
-          <p:cNvPr id="95" name="Shape 88"/>
-          <p:cNvSpPr/>
-          <p:nvPr/>
-        </p:nvSpPr>
-        <p:spPr>
-          <a:xfrm>
-            <a:off x="4228490" y="3260598"/>
-            <a:ext cx="3734714" cy="993267"/>
+            <a:off x="4228490" y="3080004"/>
+            <a:ext cx="3734714" cy="1173861"/>
           </a:xfrm>
           <a:prstGeom prst="roundRect">
             <a:avLst>
-              <a:gd name="adj" fmla="val 6444"/>
+              <a:gd name="adj" fmla="val 5453"/>
             </a:avLst>
           </a:prstGeom>
           <a:solidFill>
@@ -3856,13 +3619,13 @@
       </p:sp>
       <p:sp>
         <p:nvSpPr>
-          <p:cNvPr id="96" name="Shape 89"/>
-          <p:cNvSpPr/>
-          <p:nvPr/>
-        </p:nvSpPr>
-        <p:spPr>
-          <a:xfrm>
-            <a:off x="4228490" y="3260598"/>
+          <p:cNvPr id="90" name="Shape 83"/>
+          <p:cNvSpPr/>
+          <p:nvPr/>
+        </p:nvSpPr>
+        <p:spPr>
+          <a:xfrm>
+            <a:off x="4228490" y="3080004"/>
             <a:ext cx="3734714" cy="41148"/>
           </a:xfrm>
           <a:prstGeom prst="rect">
@@ -3876,13 +3639,13 @@
       </p:sp>
       <p:sp>
         <p:nvSpPr>
-          <p:cNvPr id="97" name="Shape 90"/>
-          <p:cNvSpPr/>
-          <p:nvPr/>
-        </p:nvSpPr>
-        <p:spPr>
-          <a:xfrm>
-            <a:off x="5995264" y="3310890"/>
+          <p:cNvPr id="91" name="Shape 84"/>
+          <p:cNvSpPr/>
+          <p:nvPr/>
+        </p:nvSpPr>
+        <p:spPr>
+          <a:xfrm>
+            <a:off x="5995264" y="3130296"/>
             <a:ext cx="201168" cy="201168"/>
           </a:xfrm>
           <a:prstGeom prst="ellipse">
@@ -3896,7 +3659,7 @@
       </p:sp>
       <p:pic>
         <p:nvPicPr>
-          <p:cNvPr id="98" name="Image 5" descr="/tmp/claude-0/-home-user-riesgo/579fb8c8-70e5-51d5-80ec-6ed51cc2e8df/scratchpad/pptx-build/icons/home_1E8449.png">    </p:cNvPr>
+          <p:cNvPr id="92" name="Image 5" descr="/tmp/claude-0/-home-user-riesgo/579fb8c8-70e5-51d5-80ec-6ed51cc2e8df/scratchpad/pptx-build/icons/home_1E8449.png">    </p:cNvPr>
           <p:cNvPicPr>
             <a:picLocks noChangeAspect="1"/>
           </p:cNvPicPr>
@@ -3910,7 +3673,7 @@
         </p:blipFill>
         <p:spPr>
           <a:xfrm>
-            <a:off x="6035497" y="3351124"/>
+            <a:off x="6035497" y="3170530"/>
             <a:ext cx="120701" cy="120701"/>
           </a:xfrm>
           <a:prstGeom prst="rect">
@@ -3920,13 +3683,13 @@
       </p:pic>
       <p:sp>
         <p:nvSpPr>
-          <p:cNvPr id="99" name="Text 91"/>
+          <p:cNvPr id="93" name="Text 85"/>
           <p:cNvSpPr txBox="1"/>
           <p:nvPr/>
         </p:nvSpPr>
         <p:spPr>
           <a:xfrm>
-            <a:off x="4274210" y="3544062"/>
+            <a:off x="4274210" y="3363468"/>
             <a:ext cx="3643274" cy="237744"/>
           </a:xfrm>
           <a:prstGeom prst="rect">
@@ -3962,13 +3725,13 @@
       </p:sp>
       <p:sp>
         <p:nvSpPr>
-          <p:cNvPr id="100" name="Shape 92"/>
-          <p:cNvSpPr/>
-          <p:nvPr/>
-        </p:nvSpPr>
-        <p:spPr>
-          <a:xfrm>
-            <a:off x="5976976" y="3662934"/>
+          <p:cNvPr id="94" name="Shape 86"/>
+          <p:cNvSpPr/>
+          <p:nvPr/>
+        </p:nvSpPr>
+        <p:spPr>
+          <a:xfrm>
+            <a:off x="5976976" y="3482340"/>
             <a:ext cx="237744" cy="13716"/>
           </a:xfrm>
           <a:prstGeom prst="rect">
@@ -3982,20 +3745,206 @@
       </p:sp>
       <p:sp>
         <p:nvSpPr>
+          <p:cNvPr id="95" name="Shape 87"/>
+          <p:cNvSpPr/>
+          <p:nvPr/>
+        </p:nvSpPr>
+        <p:spPr>
+          <a:xfrm>
+            <a:off x="4347362" y="3551834"/>
+            <a:ext cx="38405" cy="38405"/>
+          </a:xfrm>
+          <a:prstGeom prst="ellipse">
+            <a:avLst/>
+          </a:prstGeom>
+          <a:solidFill>
+            <a:srgbClr val="1E8449"/>
+          </a:solidFill>
+          <a:ln/>
+        </p:spPr>
+      </p:sp>
+      <p:sp>
+        <p:nvSpPr>
+          <p:cNvPr id="96" name="Text 88"/>
+          <p:cNvSpPr txBox="1"/>
+          <p:nvPr/>
+        </p:nvSpPr>
+        <p:spPr>
+          <a:xfrm>
+            <a:off x="4466234" y="3509772"/>
+            <a:ext cx="3378098" cy="106985"/>
+          </a:xfrm>
+          <a:prstGeom prst="rect">
+            <a:avLst/>
+          </a:prstGeom>
+          <a:noFill/>
+          <a:ln/>
+        </p:spPr>
+        <p:txBody>
+          <a:bodyPr wrap="square" lIns="0" tIns="0" rIns="0" bIns="0" rtlCol="0" anchor="t"/>
+          <a:lstStyle/>
+          <a:p>
+            <a:pPr algn="l" indent="0" marL="0">
+              <a:lnSpc>
+                <a:spcPct val="98000"/>
+              </a:lnSpc>
+              <a:buNone/>
+            </a:pPr>
+            <a:r>
+              <a:rPr lang="en-US" sz="580" dirty="0">
+                <a:solidFill>
+                  <a:srgbClr val="243044"/>
+                </a:solidFill>
+                <a:latin typeface="Calibri" pitchFamily="34" charset="0"/>
+                <a:ea typeface="Calibri" pitchFamily="34" charset="-122"/>
+                <a:cs typeface="Calibri" pitchFamily="34" charset="-120"/>
+              </a:rPr>
+              <a:t>Creación nueva base de avalúos vencidos y por vencer</a:t>
+            </a:r>
+            <a:endParaRPr lang="en-US" sz="580" dirty="0"/>
+          </a:p>
+        </p:txBody>
+      </p:sp>
+      <p:sp>
+        <p:nvSpPr>
+          <p:cNvPr id="97" name="Shape 89"/>
+          <p:cNvSpPr/>
+          <p:nvPr/>
+        </p:nvSpPr>
+        <p:spPr>
+          <a:xfrm>
+            <a:off x="4347362" y="3645103"/>
+            <a:ext cx="38405" cy="38405"/>
+          </a:xfrm>
+          <a:prstGeom prst="ellipse">
+            <a:avLst/>
+          </a:prstGeom>
+          <a:solidFill>
+            <a:srgbClr val="A6650F"/>
+          </a:solidFill>
+          <a:ln/>
+        </p:spPr>
+      </p:sp>
+      <p:sp>
+        <p:nvSpPr>
+          <p:cNvPr id="98" name="Text 90"/>
+          <p:cNvSpPr txBox="1"/>
+          <p:nvPr/>
+        </p:nvSpPr>
+        <p:spPr>
+          <a:xfrm>
+            <a:off x="4466234" y="3603041"/>
+            <a:ext cx="3378098" cy="106985"/>
+          </a:xfrm>
+          <a:prstGeom prst="rect">
+            <a:avLst/>
+          </a:prstGeom>
+          <a:noFill/>
+          <a:ln/>
+        </p:spPr>
+        <p:txBody>
+          <a:bodyPr wrap="square" lIns="0" tIns="0" rIns="0" bIns="0" rtlCol="0" anchor="t"/>
+          <a:lstStyle/>
+          <a:p>
+            <a:pPr algn="l" indent="0" marL="0">
+              <a:lnSpc>
+                <a:spcPct val="98000"/>
+              </a:lnSpc>
+              <a:buNone/>
+            </a:pPr>
+            <a:r>
+              <a:rPr lang="en-US" sz="580" dirty="0">
+                <a:solidFill>
+                  <a:srgbClr val="243044"/>
+                </a:solidFill>
+                <a:latin typeface="Calibri" pitchFamily="34" charset="0"/>
+                <a:ea typeface="Calibri" pitchFamily="34" charset="-122"/>
+                <a:cs typeface="Calibri" pitchFamily="34" charset="-120"/>
+              </a:rPr>
+              <a:t>Solicitar devolución de avalúos asignados, depurar y reasignar (cambios Norma NCB-022)</a:t>
+            </a:r>
+            <a:endParaRPr lang="en-US" sz="580" dirty="0"/>
+          </a:p>
+        </p:txBody>
+      </p:sp>
+      <p:sp>
+        <p:nvSpPr>
+          <p:cNvPr id="99" name="Shape 91"/>
+          <p:cNvSpPr/>
+          <p:nvPr/>
+        </p:nvSpPr>
+        <p:spPr>
+          <a:xfrm>
+            <a:off x="4347362" y="3738372"/>
+            <a:ext cx="38405" cy="38405"/>
+          </a:xfrm>
+          <a:prstGeom prst="ellipse">
+            <a:avLst/>
+          </a:prstGeom>
+          <a:solidFill>
+            <a:srgbClr val="A6650F"/>
+          </a:solidFill>
+          <a:ln/>
+        </p:spPr>
+      </p:sp>
+      <p:sp>
+        <p:nvSpPr>
+          <p:cNvPr id="100" name="Text 92"/>
+          <p:cNvSpPr txBox="1"/>
+          <p:nvPr/>
+        </p:nvSpPr>
+        <p:spPr>
+          <a:xfrm>
+            <a:off x="4466234" y="3696310"/>
+            <a:ext cx="3378098" cy="106985"/>
+          </a:xfrm>
+          <a:prstGeom prst="rect">
+            <a:avLst/>
+          </a:prstGeom>
+          <a:noFill/>
+          <a:ln/>
+        </p:spPr>
+        <p:txBody>
+          <a:bodyPr wrap="square" lIns="0" tIns="0" rIns="0" bIns="0" rtlCol="0" anchor="t"/>
+          <a:lstStyle/>
+          <a:p>
+            <a:pPr algn="l" indent="0" marL="0">
+              <a:lnSpc>
+                <a:spcPct val="98000"/>
+              </a:lnSpc>
+              <a:buNone/>
+            </a:pPr>
+            <a:r>
+              <a:rPr lang="en-US" sz="580" dirty="0">
+                <a:solidFill>
+                  <a:srgbClr val="243044"/>
+                </a:solidFill>
+                <a:latin typeface="Calibri" pitchFamily="34" charset="0"/>
+                <a:ea typeface="Calibri" pitchFamily="34" charset="-122"/>
+                <a:cs typeface="Calibri" pitchFamily="34" charset="-120"/>
+              </a:rPr>
+              <a:t>Gestiones de avalúos</a:t>
+            </a:r>
+            <a:endParaRPr lang="en-US" sz="580" dirty="0"/>
+          </a:p>
+        </p:txBody>
+      </p:sp>
+      <p:sp>
+        <p:nvSpPr>
           <p:cNvPr id="101" name="Shape 93"/>
           <p:cNvSpPr/>
           <p:nvPr/>
         </p:nvSpPr>
         <p:spPr>
           <a:xfrm>
-            <a:off x="4347362" y="3732428"/>
+            <a:off x="4347362" y="3831641"/>
             <a:ext cx="38405" cy="38405"/>
           </a:xfrm>
           <a:prstGeom prst="ellipse">
             <a:avLst/>
           </a:prstGeom>
           <a:solidFill>
-            <a:srgbClr val="A6650F"/>
+            <a:srgbClr val="1E8449"/>
           </a:solidFill>
           <a:ln/>
         </p:spPr>
@@ -4008,8 +3957,8 @@
         </p:nvSpPr>
         <p:spPr>
           <a:xfrm>
-            <a:off x="4466234" y="3690366"/>
-            <a:ext cx="3378098" cy="119329"/>
+            <a:off x="4466234" y="3789578"/>
+            <a:ext cx="3378098" cy="106985"/>
           </a:xfrm>
           <a:prstGeom prst="rect">
             <a:avLst/>
@@ -4028,7 +3977,7 @@
               <a:buNone/>
             </a:pPr>
             <a:r>
-              <a:rPr lang="en-US" sz="670" dirty="0">
+              <a:rPr lang="en-US" sz="580" dirty="0">
                 <a:solidFill>
                   <a:srgbClr val="243044"/>
                 </a:solidFill>
@@ -4036,9 +3985,9 @@
                 <a:ea typeface="Calibri" pitchFamily="34" charset="-122"/>
                 <a:cs typeface="Calibri" pitchFamily="34" charset="-120"/>
               </a:rPr>
-              <a:t>Creación nueva base de avalúos vencidos y por vencer</a:t>
-            </a:r>
-            <a:endParaRPr lang="en-US" sz="670" dirty="0"/>
+              <a:t>Informe estado actual de base de avalúos para analista de Riesgos Financieros</a:t>
+            </a:r>
+            <a:endParaRPr lang="en-US" sz="580" dirty="0"/>
           </a:p>
         </p:txBody>
       </p:sp>
@@ -4050,7 +3999,7 @@
         </p:nvSpPr>
         <p:spPr>
           <a:xfrm>
-            <a:off x="4347362" y="3838042"/>
+            <a:off x="4347362" y="3924910"/>
             <a:ext cx="38405" cy="38405"/>
           </a:xfrm>
           <a:prstGeom prst="ellipse">
@@ -4070,8 +4019,8 @@
         </p:nvSpPr>
         <p:spPr>
           <a:xfrm>
-            <a:off x="4466234" y="3795979"/>
-            <a:ext cx="3378098" cy="211226"/>
+            <a:off x="4466234" y="3882847"/>
+            <a:ext cx="3378098" cy="186538"/>
           </a:xfrm>
           <a:prstGeom prst="rect">
             <a:avLst/>
@@ -4090,7 +4039,7 @@
               <a:buNone/>
             </a:pPr>
             <a:r>
-              <a:rPr lang="en-US" sz="670" dirty="0">
+              <a:rPr lang="en-US" sz="580" dirty="0">
                 <a:solidFill>
                   <a:srgbClr val="243044"/>
                 </a:solidFill>
@@ -4098,9 +4047,9 @@
                 <a:ea typeface="Calibri" pitchFamily="34" charset="-122"/>
                 <a:cs typeface="Calibri" pitchFamily="34" charset="-120"/>
               </a:rPr>
-              <a:t>Solicitar devolución de avalúos asignados, depurar y reasignar (cambios Norma NCB-022)</a:t>
-            </a:r>
-            <a:endParaRPr lang="en-US" sz="670" dirty="0"/>
+              <a:t>Gestiones con perito valuador GRIS, S.A. de C.V. – revisión de informe de avalúo (NRP-27)</a:t>
+            </a:r>
+            <a:endParaRPr lang="en-US" sz="580" dirty="0"/>
           </a:p>
         </p:txBody>
       </p:sp>
@@ -4112,14 +4061,14 @@
         </p:nvSpPr>
         <p:spPr>
           <a:xfrm>
-            <a:off x="4347362" y="4035552"/>
+            <a:off x="4347362" y="4097731"/>
             <a:ext cx="38405" cy="38405"/>
           </a:xfrm>
           <a:prstGeom prst="ellipse">
             <a:avLst/>
           </a:prstGeom>
           <a:solidFill>
-            <a:srgbClr val="A6650F"/>
+            <a:srgbClr val="1E8449"/>
           </a:solidFill>
           <a:ln/>
         </p:spPr>
@@ -4132,8 +4081,8 @@
         </p:nvSpPr>
         <p:spPr>
           <a:xfrm>
-            <a:off x="4466234" y="3993490"/>
-            <a:ext cx="3378098" cy="119329"/>
+            <a:off x="4466234" y="4055669"/>
+            <a:ext cx="3378098" cy="106985"/>
           </a:xfrm>
           <a:prstGeom prst="rect">
             <a:avLst/>
@@ -4152,7 +4101,7 @@
               <a:buNone/>
             </a:pPr>
             <a:r>
-              <a:rPr lang="en-US" sz="670" dirty="0">
+              <a:rPr lang="en-US" sz="580" dirty="0">
                 <a:solidFill>
                   <a:srgbClr val="243044"/>
                 </a:solidFill>
@@ -4160,9 +4109,9 @@
                 <a:ea typeface="Calibri" pitchFamily="34" charset="-122"/>
                 <a:cs typeface="Calibri" pitchFamily="34" charset="-120"/>
               </a:rPr>
-              <a:t>Gestiones de avalúos</a:t>
-            </a:r>
-            <a:endParaRPr lang="en-US" sz="670" dirty="0"/>
+              <a:t>Revisión de informes de avalúos digitales recibidos por peritos</a:t>
+            </a:r>
+            <a:endParaRPr lang="en-US" sz="580" dirty="0"/>
           </a:p>
         </p:txBody>
       </p:sp>
@@ -4174,74 +4123,12 @@
         </p:nvSpPr>
         <p:spPr>
           <a:xfrm>
-            <a:off x="4347362" y="4141165"/>
-            <a:ext cx="38405" cy="38405"/>
-          </a:xfrm>
-          <a:prstGeom prst="ellipse">
-            <a:avLst/>
-          </a:prstGeom>
-          <a:solidFill>
-            <a:srgbClr val="46586E"/>
-          </a:solidFill>
-          <a:ln/>
-        </p:spPr>
-      </p:sp>
-      <p:sp>
-        <p:nvSpPr>
-          <p:cNvPr id="108" name="Text 100"/>
-          <p:cNvSpPr txBox="1"/>
-          <p:nvPr/>
-        </p:nvSpPr>
-        <p:spPr>
-          <a:xfrm>
-            <a:off x="4466234" y="4099103"/>
-            <a:ext cx="3378098" cy="119329"/>
-          </a:xfrm>
-          <a:prstGeom prst="rect">
-            <a:avLst/>
-          </a:prstGeom>
-          <a:noFill/>
-          <a:ln/>
-        </p:spPr>
-        <p:txBody>
-          <a:bodyPr wrap="square" lIns="0" tIns="0" rIns="0" bIns="0" rtlCol="0" anchor="t"/>
-          <a:lstStyle/>
-          <a:p>
-            <a:pPr algn="l" indent="0" marL="0">
-              <a:lnSpc>
-                <a:spcPct val="98000"/>
-              </a:lnSpc>
-              <a:buNone/>
-            </a:pPr>
-            <a:r>
-              <a:rPr lang="en-US" sz="670" dirty="0">
-                <a:solidFill>
-                  <a:srgbClr val="243044"/>
-                </a:solidFill>
-                <a:latin typeface="Calibri" pitchFamily="34" charset="0"/>
-                <a:ea typeface="Calibri" pitchFamily="34" charset="-122"/>
-                <a:cs typeface="Calibri" pitchFamily="34" charset="-120"/>
-              </a:rPr>
-              <a:t>Asignación de avalúos a peritos valuadores</a:t>
-            </a:r>
-            <a:endParaRPr lang="en-US" sz="670" dirty="0"/>
-          </a:p>
-        </p:txBody>
-      </p:sp>
-      <p:sp>
-        <p:nvSpPr>
-          <p:cNvPr id="109" name="Shape 101"/>
-          <p:cNvSpPr/>
-          <p:nvPr/>
-        </p:nvSpPr>
-        <p:spPr>
-          <a:xfrm>
-            <a:off x="8091221" y="3260598"/>
-            <a:ext cx="3734714" cy="993267"/>
+            <a:off x="8091221" y="3080004"/>
+            <a:ext cx="3734714" cy="1173861"/>
           </a:xfrm>
           <a:prstGeom prst="roundRect">
             <a:avLst>
-              <a:gd name="adj" fmla="val 6444"/>
+              <a:gd name="adj" fmla="val 5453"/>
             </a:avLst>
           </a:prstGeom>
           <a:solidFill>
@@ -4259,13 +4146,13 @@
       </p:sp>
       <p:sp>
         <p:nvSpPr>
-          <p:cNvPr id="110" name="Shape 102"/>
-          <p:cNvSpPr/>
-          <p:nvPr/>
-        </p:nvSpPr>
-        <p:spPr>
-          <a:xfrm>
-            <a:off x="8091221" y="3260598"/>
+          <p:cNvPr id="108" name="Shape 100"/>
+          <p:cNvSpPr/>
+          <p:nvPr/>
+        </p:nvSpPr>
+        <p:spPr>
+          <a:xfrm>
+            <a:off x="8091221" y="3080004"/>
             <a:ext cx="3734714" cy="41148"/>
           </a:xfrm>
           <a:prstGeom prst="rect">
@@ -4279,13 +4166,13 @@
       </p:sp>
       <p:sp>
         <p:nvSpPr>
-          <p:cNvPr id="111" name="Shape 103"/>
-          <p:cNvSpPr/>
-          <p:nvPr/>
-        </p:nvSpPr>
-        <p:spPr>
-          <a:xfrm>
-            <a:off x="9857994" y="3310890"/>
+          <p:cNvPr id="109" name="Shape 101"/>
+          <p:cNvSpPr/>
+          <p:nvPr/>
+        </p:nvSpPr>
+        <p:spPr>
+          <a:xfrm>
+            <a:off x="9857994" y="3130296"/>
             <a:ext cx="201168" cy="201168"/>
           </a:xfrm>
           <a:prstGeom prst="ellipse">
@@ -4299,7 +4186,7 @@
       </p:sp>
       <p:pic>
         <p:nvPicPr>
-          <p:cNvPr id="112" name="Image 6" descr="/tmp/claude-0/-home-user-riesgo/579fb8c8-70e5-51d5-80ec-6ed51cc2e8df/scratchpad/pptx-build/icons/checkcircle_0F766E.png">    </p:cNvPr>
+          <p:cNvPr id="110" name="Image 6" descr="/tmp/claude-0/-home-user-riesgo/579fb8c8-70e5-51d5-80ec-6ed51cc2e8df/scratchpad/pptx-build/icons/checkcircle_0F766E.png">    </p:cNvPr>
           <p:cNvPicPr>
             <a:picLocks noChangeAspect="1"/>
           </p:cNvPicPr>
@@ -4313,7 +4200,7 @@
         </p:blipFill>
         <p:spPr>
           <a:xfrm>
-            <a:off x="9898228" y="3351124"/>
+            <a:off x="9898228" y="3170530"/>
             <a:ext cx="120701" cy="120701"/>
           </a:xfrm>
           <a:prstGeom prst="rect">
@@ -4323,13 +4210,13 @@
       </p:pic>
       <p:sp>
         <p:nvSpPr>
-          <p:cNvPr id="113" name="Text 104"/>
+          <p:cNvPr id="111" name="Text 102"/>
           <p:cNvSpPr txBox="1"/>
           <p:nvPr/>
         </p:nvSpPr>
         <p:spPr>
           <a:xfrm>
-            <a:off x="8136941" y="3544062"/>
+            <a:off x="8136941" y="3363468"/>
             <a:ext cx="3643274" cy="237744"/>
           </a:xfrm>
           <a:prstGeom prst="rect">
@@ -4365,13 +4252,13 @@
       </p:sp>
       <p:sp>
         <p:nvSpPr>
-          <p:cNvPr id="114" name="Shape 105"/>
-          <p:cNvSpPr/>
-          <p:nvPr/>
-        </p:nvSpPr>
-        <p:spPr>
-          <a:xfrm>
-            <a:off x="9839706" y="3662934"/>
+          <p:cNvPr id="112" name="Shape 103"/>
+          <p:cNvSpPr/>
+          <p:nvPr/>
+        </p:nvSpPr>
+        <p:spPr>
+          <a:xfrm>
+            <a:off x="9839706" y="3482340"/>
             <a:ext cx="237744" cy="13716"/>
           </a:xfrm>
           <a:prstGeom prst="rect">
@@ -4385,20 +4272,82 @@
       </p:sp>
       <p:sp>
         <p:nvSpPr>
+          <p:cNvPr id="113" name="Shape 104"/>
+          <p:cNvSpPr/>
+          <p:nvPr/>
+        </p:nvSpPr>
+        <p:spPr>
+          <a:xfrm>
+            <a:off x="8210093" y="3551834"/>
+            <a:ext cx="38405" cy="38405"/>
+          </a:xfrm>
+          <a:prstGeom prst="ellipse">
+            <a:avLst/>
+          </a:prstGeom>
+          <a:solidFill>
+            <a:srgbClr val="1E8449"/>
+          </a:solidFill>
+          <a:ln/>
+        </p:spPr>
+      </p:sp>
+      <p:sp>
+        <p:nvSpPr>
+          <p:cNvPr id="114" name="Text 105"/>
+          <p:cNvSpPr txBox="1"/>
+          <p:nvPr/>
+        </p:nvSpPr>
+        <p:spPr>
+          <a:xfrm>
+            <a:off x="8328965" y="3509772"/>
+            <a:ext cx="3378098" cy="119329"/>
+          </a:xfrm>
+          <a:prstGeom prst="rect">
+            <a:avLst/>
+          </a:prstGeom>
+          <a:noFill/>
+          <a:ln/>
+        </p:spPr>
+        <p:txBody>
+          <a:bodyPr wrap="square" lIns="0" tIns="0" rIns="0" bIns="0" rtlCol="0" anchor="t"/>
+          <a:lstStyle/>
+          <a:p>
+            <a:pPr algn="l" indent="0" marL="0">
+              <a:lnSpc>
+                <a:spcPct val="98000"/>
+              </a:lnSpc>
+              <a:buNone/>
+            </a:pPr>
+            <a:r>
+              <a:rPr lang="en-US" sz="670" dirty="0">
+                <a:solidFill>
+                  <a:srgbClr val="243044"/>
+                </a:solidFill>
+                <a:latin typeface="Calibri" pitchFamily="34" charset="0"/>
+                <a:ea typeface="Calibri" pitchFamily="34" charset="-122"/>
+                <a:cs typeface="Calibri" pitchFamily="34" charset="-120"/>
+              </a:rPr>
+              <a:t>Atención a requerimientos vía correo electrónico SSF</a:t>
+            </a:r>
+            <a:endParaRPr lang="en-US" sz="670" dirty="0"/>
+          </a:p>
+        </p:txBody>
+      </p:sp>
+      <p:sp>
+        <p:nvSpPr>
           <p:cNvPr id="115" name="Shape 106"/>
           <p:cNvSpPr/>
           <p:nvPr/>
         </p:nvSpPr>
         <p:spPr>
           <a:xfrm>
-            <a:off x="8210093" y="3732428"/>
+            <a:off x="8210093" y="3657448"/>
             <a:ext cx="38405" cy="38405"/>
           </a:xfrm>
           <a:prstGeom prst="ellipse">
             <a:avLst/>
           </a:prstGeom>
           <a:solidFill>
-            <a:srgbClr val="C3CBD6"/>
+            <a:srgbClr val="1E8449"/>
           </a:solidFill>
           <a:ln/>
         </p:spPr>
@@ -4411,8 +4360,8 @@
         </p:nvSpPr>
         <p:spPr>
           <a:xfrm>
-            <a:off x="8328965" y="3690366"/>
-            <a:ext cx="3378098" cy="119329"/>
+            <a:off x="8328965" y="3615385"/>
+            <a:ext cx="3378098" cy="211226"/>
           </a:xfrm>
           <a:prstGeom prst="rect">
             <a:avLst/>
@@ -4439,7 +4388,7 @@
                 <a:ea typeface="Calibri" pitchFamily="34" charset="-122"/>
                 <a:cs typeface="Calibri" pitchFamily="34" charset="-120"/>
               </a:rPr>
-              <a:t>Atención a requerimientos SSF – BCR</a:t>
+              <a:t>Seguimiento notas SABAO-DR-10417 (visita de supervisión SI/CS) – matriz de resultados del informe preliminar</a:t>
             </a:r>
             <a:endParaRPr lang="en-US" sz="670" dirty="0"/>
           </a:p>
@@ -5007,7 +4956,7 @@
                 <a:ea typeface="Calibri" pitchFamily="34" charset="-122"/>
                 <a:cs typeface="Calibri" pitchFamily="34" charset="-120"/>
               </a:rPr>
-              <a:t>0%</a:t>
+              <a:t>50%</a:t>
             </a:r>
             <a:endParaRPr lang="en-US" sz="640" dirty="0"/>
           </a:p>
@@ -5028,7 +4977,7 @@
             <a:avLst/>
           </a:prstGeom>
           <a:solidFill>
-            <a:srgbClr val="A6650F"/>
+            <a:srgbClr val="1E8449"/>
           </a:solidFill>
           <a:ln/>
         </p:spPr>
@@ -5086,7 +5035,7 @@
                 <a:ea typeface="Calibri" pitchFamily="34" charset="-122"/>
                 <a:cs typeface="Calibri" pitchFamily="34" charset="-120"/>
               </a:rPr>
-              <a:t>0%</a:t>
+              <a:t>100%</a:t>
             </a:r>
             <a:endParaRPr lang="en-US" sz="640" dirty="0"/>
           </a:p>
@@ -5107,7 +5056,7 @@
             <a:avLst/>
           </a:prstGeom>
           <a:solidFill>
-            <a:srgbClr val="A6650F"/>
+            <a:srgbClr val="1E8449"/>
           </a:solidFill>
           <a:ln/>
         </p:spPr>
@@ -5165,7 +5114,7 @@
                 <a:ea typeface="Calibri" pitchFamily="34" charset="-122"/>
                 <a:cs typeface="Calibri" pitchFamily="34" charset="-120"/>
               </a:rPr>
-              <a:t>0%</a:t>
+              <a:t>100%</a:t>
             </a:r>
             <a:endParaRPr lang="en-US" sz="640" dirty="0"/>
           </a:p>
@@ -6049,7 +5998,7 @@
             <a:avLst/>
           </a:prstGeom>
           <a:solidFill>
-            <a:srgbClr val="A6650F"/>
+            <a:srgbClr val="1E8449"/>
           </a:solidFill>
           <a:ln/>
         </p:spPr>
@@ -6107,7 +6056,7 @@
                 <a:ea typeface="Calibri" pitchFamily="34" charset="-122"/>
                 <a:cs typeface="Calibri" pitchFamily="34" charset="-120"/>
               </a:rPr>
-              <a:t>5%</a:t>
+              <a:t>100%</a:t>
             </a:r>
             <a:endParaRPr lang="en-US" sz="650" dirty="0"/>
           </a:p>
@@ -6186,7 +6135,7 @@
                 <a:ea typeface="Calibri" pitchFamily="34" charset="-122"/>
                 <a:cs typeface="Calibri" pitchFamily="34" charset="-120"/>
               </a:rPr>
-              <a:t>0%</a:t>
+              <a:t>50%</a:t>
             </a:r>
             <a:endParaRPr lang="en-US" sz="650" dirty="0"/>
           </a:p>

</xml_diff>

<commit_message>
Reorganizar cronograma de riesgos por tipo de riesgo en vez de por persona
Agrupa las tarjetas en Riesgo Operacional, Riesgo Regulatorio y Gestión
Avalúos, y Riesgo Financieros (antes Silvia/Sara/Melvin), renombra la
tarjeta "Gestión Documental y Crédito" a "Proyectos" y actualiza
encabezado/pie con el nuevo periodo (14 al 19 de septiembre 2026).
También corrige un traslape de texto en la tarjeta "Proyectos a Largo
Plazo" ajustando el margen de seguridad del cálculo de ajuste de línea.

Co-Authored-By: Claude Sonnet 5 <noreply@anthropic.com>
Claude-Session: https://claude.ai/code/session_01KND4cYnTdx53ydNLfQdR3S
</commit_message>
<xml_diff>
--- a/Administracion_Riesgos_COMEDICA.pptx
+++ b/Administracion_Riesgos_COMEDICA.pptx
@@ -1036,7 +1036,7 @@
                 <a:ea typeface="Calibri" pitchFamily="34" charset="-122"/>
                 <a:cs typeface="Calibri" pitchFamily="34" charset="-120"/>
               </a:rPr>
-              <a:t>COMÉDICA</a:t>
+              <a:t>COMÉDICA DE R.L.</a:t>
             </a:r>
             <a:endParaRPr lang="en-US" sz="1000" dirty="0"/>
           </a:p>
@@ -1114,7 +1114,7 @@
                 <a:ea typeface="Calibri" pitchFamily="34" charset="-122"/>
                 <a:cs typeface="Calibri" pitchFamily="34" charset="-120"/>
               </a:rPr>
-              <a:t>Cronograma de Actividades · Informes Semanal – Mensual</a:t>
+              <a:t>Cronograma de Actividades · Informe Semanal – 14 al 19 de septiembre 2026</a:t>
             </a:r>
             <a:endParaRPr lang="en-US" sz="1100" dirty="0"/>
           </a:p>
@@ -1411,7 +1411,7 @@
                 <a:ea typeface="Calibri" pitchFamily="34" charset="-122"/>
                 <a:cs typeface="Calibri" pitchFamily="34" charset="-120"/>
               </a:rPr>
-              <a:t>COMÉDICA  ·  Cronograma de Actividades — Silvia · Sara · Melvin</a:t>
+              <a:t>COMÉDICA DE R.L.  ·  Cronograma de Actividades</a:t>
             </a:r>
             <a:endParaRPr lang="en-US" sz="900" dirty="0"/>
           </a:p>
@@ -1472,7 +1472,7 @@
                 <a:ea typeface="Calibri" pitchFamily="34" charset="-122"/>
                 <a:cs typeface="Calibri" pitchFamily="34" charset="-120"/>
               </a:rPr>
-              <a:t>Silvia</a:t>
+              <a:t>Riesgo Operacional</a:t>
             </a:r>
             <a:endParaRPr lang="en-US" sz="1100" dirty="0"/>
           </a:p>
@@ -1959,7 +1959,7 @@
                 <a:ea typeface="Calibri" pitchFamily="34" charset="-122"/>
                 <a:cs typeface="Calibri" pitchFamily="34" charset="-120"/>
               </a:rPr>
-              <a:t>Gestión Documental y Crédito</a:t>
+              <a:t>Proyectos</a:t>
             </a:r>
             <a:endParaRPr lang="en-US" sz="760" dirty="0"/>
           </a:p>
@@ -2093,7 +2093,7 @@
         <p:spPr>
           <a:xfrm>
             <a:off x="3500552" y="2050085"/>
-            <a:ext cx="2412416" cy="216713"/>
+            <a:ext cx="2412416" cy="311353"/>
           </a:xfrm>
           <a:prstGeom prst="rect">
             <a:avLst/>
@@ -3140,7 +3140,7 @@
                 <a:ea typeface="Calibri" pitchFamily="34" charset="-122"/>
                 <a:cs typeface="Calibri" pitchFamily="34" charset="-120"/>
               </a:rPr>
-              <a:t>Sara</a:t>
+              <a:t>Riesgo Regulatorio y Gestión Avalúos</a:t>
             </a:r>
             <a:endParaRPr lang="en-US" sz="1100" dirty="0"/>
           </a:p>
@@ -3834,7 +3834,7 @@
         <p:spPr>
           <a:xfrm>
             <a:off x="4466234" y="3603041"/>
-            <a:ext cx="3378098" cy="106985"/>
+            <a:ext cx="3378098" cy="186538"/>
           </a:xfrm>
           <a:prstGeom prst="rect">
             <a:avLst/>
@@ -3875,7 +3875,7 @@
         </p:nvSpPr>
         <p:spPr>
           <a:xfrm>
-            <a:off x="4347362" y="3738372"/>
+            <a:off x="4347362" y="3817925"/>
             <a:ext cx="38405" cy="38405"/>
           </a:xfrm>
           <a:prstGeom prst="ellipse">
@@ -3895,7 +3895,7 @@
         </p:nvSpPr>
         <p:spPr>
           <a:xfrm>
-            <a:off x="4466234" y="3696310"/>
+            <a:off x="4466234" y="3775862"/>
             <a:ext cx="3378098" cy="106985"/>
           </a:xfrm>
           <a:prstGeom prst="rect">
@@ -3937,7 +3937,7 @@
         </p:nvSpPr>
         <p:spPr>
           <a:xfrm>
-            <a:off x="4347362" y="3831641"/>
+            <a:off x="4347362" y="3911194"/>
             <a:ext cx="38405" cy="38405"/>
           </a:xfrm>
           <a:prstGeom prst="ellipse">
@@ -3957,7 +3957,7 @@
         </p:nvSpPr>
         <p:spPr>
           <a:xfrm>
-            <a:off x="4466234" y="3789578"/>
+            <a:off x="4466234" y="3869131"/>
             <a:ext cx="3378098" cy="106985"/>
           </a:xfrm>
           <a:prstGeom prst="rect">
@@ -3999,7 +3999,7 @@
         </p:nvSpPr>
         <p:spPr>
           <a:xfrm>
-            <a:off x="4347362" y="3924910"/>
+            <a:off x="4347362" y="4004462"/>
             <a:ext cx="38405" cy="38405"/>
           </a:xfrm>
           <a:prstGeom prst="ellipse">
@@ -4019,7 +4019,7 @@
         </p:nvSpPr>
         <p:spPr>
           <a:xfrm>
-            <a:off x="4466234" y="3882847"/>
+            <a:off x="4466234" y="3962400"/>
             <a:ext cx="3378098" cy="186538"/>
           </a:xfrm>
           <a:prstGeom prst="rect">
@@ -4061,7 +4061,7 @@
         </p:nvSpPr>
         <p:spPr>
           <a:xfrm>
-            <a:off x="4347362" y="4097731"/>
+            <a:off x="4347362" y="4177284"/>
             <a:ext cx="38405" cy="38405"/>
           </a:xfrm>
           <a:prstGeom prst="ellipse">
@@ -4081,7 +4081,7 @@
         </p:nvSpPr>
         <p:spPr>
           <a:xfrm>
-            <a:off x="4466234" y="4055669"/>
+            <a:off x="4466234" y="4135222"/>
             <a:ext cx="3378098" cy="106985"/>
           </a:xfrm>
           <a:prstGeom prst="rect">
@@ -4449,7 +4449,7 @@
                 <a:ea typeface="Calibri" pitchFamily="34" charset="-122"/>
                 <a:cs typeface="Calibri" pitchFamily="34" charset="-120"/>
               </a:rPr>
-              <a:t>Melvin</a:t>
+              <a:t>Riesgo Financieros</a:t>
             </a:r>
             <a:endParaRPr lang="en-US" sz="1100" dirty="0"/>
           </a:p>
@@ -6562,7 +6562,7 @@
         <p:spPr>
           <a:xfrm>
             <a:off x="9874057" y="5021961"/>
-            <a:ext cx="1833006" cy="208483"/>
+            <a:ext cx="1833006" cy="299009"/>
           </a:xfrm>
           <a:prstGeom prst="rect">
             <a:avLst/>
@@ -6620,7 +6620,7 @@
         </p:nvSpPr>
         <p:spPr>
           <a:xfrm>
-            <a:off x="9755185" y="5258791"/>
+            <a:off x="9755185" y="5349316"/>
             <a:ext cx="38405" cy="38405"/>
           </a:xfrm>
           <a:prstGeom prst="ellipse">
@@ -6640,7 +6640,7 @@
         </p:nvSpPr>
         <p:spPr>
           <a:xfrm>
-            <a:off x="9874057" y="5216728"/>
+            <a:off x="9874057" y="5307254"/>
             <a:ext cx="1833006" cy="299009"/>
           </a:xfrm>
           <a:prstGeom prst="rect">

</xml_diff>

<commit_message>
Agregar lámina de resumen ejecutivo con plan de acción SABAO-DR-10417
Nueva segunda diapositiva que resume las actividades de Riesgo
Operacional (RO) y Riesgo Crediticio (RC) etiquetadas en el documento
fuente, más una sección de Riesgo Regulatorio y Gestión Avalúos con
el plan de acción de la visita focalizada SABAO-DR-10417: KPIs (fecha
de inicio, salida y firma de acta, total de requerimientos,
observaciones), estado de informes y cronología completa de la visita.

Co-Authored-By: Claude Sonnet 5 <noreply@anthropic.com>
Claude-Session: https://claude.ai/code/session_01KND4cYnTdx53ydNLfQdR3S
</commit_message>
<xml_diff>
--- a/Administracion_Riesgos_COMEDICA.pptx
+++ b/Administracion_Riesgos_COMEDICA.pptx
@@ -6,9 +6,10 @@
   </p:sldMasterIdLst>
   <p:sldIdLst>
     <p:sldId id="256" r:id="rId2"/>
+    <p:sldId id="257" r:id="rId3"/>
   </p:sldIdLst>
   <p:notesMasterIdLst>
-    <p:notesMasterId r:id="rId3"/>
+    <p:notesMasterId r:id="rId4"/>
   </p:notesMasterIdLst>
   <p:sldSz cx="12191695" cy="6858000"/>
   <p:notesSz cx="6858000" cy="12191695"/>
@@ -544,6 +545,94 @@
 </p:notes>
 </file>
 
+<file path=ppt/notesSlides/notesSlide2.xml><?xml version="1.0" encoding="utf-8"?>
+<p:notes xmlns:a="http://schemas.openxmlformats.org/drawingml/2006/main" xmlns:r="http://schemas.openxmlformats.org/officeDocument/2006/relationships" xmlns:p="http://schemas.openxmlformats.org/presentationml/2006/main">
+  <p:cSld>
+    <p:spTree>
+      <p:nvGrpSpPr>
+        <p:cNvPr id="1" name=""/>
+        <p:cNvGrpSpPr/>
+        <p:nvPr/>
+      </p:nvGrpSpPr>
+      <p:grpSpPr>
+        <a:xfrm>
+          <a:off x="0" y="0"/>
+          <a:ext cx="0" cy="0"/>
+          <a:chOff x="0" y="0"/>
+          <a:chExt cx="0" cy="0"/>
+        </a:xfrm>
+      </p:grpSpPr>
+      <p:sp>
+        <p:nvSpPr>
+          <p:cNvPr id="2" name="Slide Image Placeholder 1"/>
+          <p:cNvSpPr>
+            <a:spLocks noGrp="1" noRot="1" noChangeAspect="1"/>
+          </p:cNvSpPr>
+          <p:nvPr>
+            <p:ph type="sldImg"/>
+          </p:nvPr>
+        </p:nvSpPr>
+        <p:spPr/>
+      </p:sp>
+      <p:sp>
+        <p:nvSpPr>
+          <p:cNvPr id="3" name="Notes Placeholder 2"/>
+          <p:cNvSpPr>
+            <a:spLocks noGrp="1"/>
+          </p:cNvSpPr>
+          <p:nvPr>
+            <p:ph type="body" idx="1"/>
+          </p:nvPr>
+        </p:nvSpPr>
+        <p:spPr/>
+        <p:txBody>
+          <a:bodyPr/>
+          <a:lstStyle/>
+          <a:p>
+            <a:r>
+              <a:rPr lang="en-US" dirty="0"/>
+              <a:t/>
+            </a:r>
+            <a:endParaRPr lang="en-US" dirty="0"/>
+          </a:p>
+        </p:txBody>
+      </p:sp>
+      <p:sp>
+        <p:nvSpPr>
+          <p:cNvPr id="4" name="Slide Number Placeholder 3"/>
+          <p:cNvSpPr>
+            <a:spLocks noGrp="1"/>
+          </p:cNvSpPr>
+          <p:nvPr>
+            <p:ph type="sldNum" sz="quarter" idx="10"/>
+          </p:nvPr>
+        </p:nvSpPr>
+        <p:spPr/>
+        <p:txBody>
+          <a:bodyPr/>
+          <a:lstStyle/>
+          <a:p>
+            <a:fld id="{F7021451-1387-4CA6-816F-3879F97B5CBC}" type="slidenum">
+              <a:rPr lang="en-US"/>
+              <a:t>2</a:t>
+            </a:fld>
+            <a:endParaRPr lang="en-US"/>
+          </a:p>
+        </p:txBody>
+      </p:sp>
+    </p:spTree>
+    <p:extLst>
+      <p:ext uri="{BB962C8B-B14F-4D97-AF65-F5344CB8AC3E}">
+        <p14:creationId xmlns:p14="http://schemas.microsoft.com/office/powerpoint/2010/main" val="1024086991"/>
+      </p:ext>
+    </p:extLst>
+  </p:cSld>
+  <p:clrMapOvr>
+    <a:masterClrMapping/>
+  </p:clrMapOvr>
+</p:notes>
+</file>
+
 <file path=ppt/slideLayouts/slideLayout1.xml><?xml version="1.0" encoding="utf-8"?>
 <p:sldLayout xmlns:a="http://schemas.openxmlformats.org/drawingml/2006/main" xmlns:r="http://schemas.openxmlformats.org/officeDocument/2006/relationships" xmlns:p="http://schemas.openxmlformats.org/presentationml/2006/main" preserve="1">
   <p:cSld name="DEFAULT">
@@ -6688,6 +6777,2941 @@
               <a:t>100%</a:t>
             </a:r>
             <a:endParaRPr lang="en-US" sz="660" dirty="0"/>
+          </a:p>
+        </p:txBody>
+      </p:sp>
+    </p:spTree>
+  </p:cSld>
+  <p:clrMapOvr>
+    <a:masterClrMapping/>
+  </p:clrMapOvr>
+</p:sld>
+</file>
+
+<file path=ppt/slides/slide2.xml><?xml version="1.0" encoding="utf-8"?>
+<p:sld xmlns:a="http://schemas.openxmlformats.org/drawingml/2006/main" xmlns:r="http://schemas.openxmlformats.org/officeDocument/2006/relationships" xmlns:p="http://schemas.openxmlformats.org/presentationml/2006/main">
+  <p:cSld name="Slide 2">
+    <p:bg>
+      <p:bgPr>
+        <a:solidFill>
+          <a:srgbClr val="F2F5F9"/>
+        </a:solidFill>
+      </p:bgPr>
+    </p:bg>
+    <p:spTree>
+      <p:nvGrpSpPr>
+        <p:cNvPr id="1" name=""/>
+        <p:cNvGrpSpPr/>
+        <p:nvPr/>
+      </p:nvGrpSpPr>
+      <p:grpSpPr>
+        <a:xfrm>
+          <a:off x="0" y="0"/>
+          <a:ext cx="0" cy="0"/>
+          <a:chOff x="0" y="0"/>
+          <a:chExt cx="0" cy="0"/>
+        </a:xfrm>
+      </p:grpSpPr>
+      <p:sp>
+        <p:nvSpPr>
+          <p:cNvPr id="2" name="Shape 0"/>
+          <p:cNvSpPr/>
+          <p:nvPr/>
+        </p:nvSpPr>
+        <p:spPr>
+          <a:xfrm>
+            <a:off x="0" y="0"/>
+            <a:ext cx="12191695" cy="1005840"/>
+          </a:xfrm>
+          <a:prstGeom prst="rect">
+            <a:avLst/>
+          </a:prstGeom>
+          <a:solidFill>
+            <a:srgbClr val="133B6C"/>
+          </a:solidFill>
+          <a:ln/>
+        </p:spPr>
+      </p:sp>
+      <p:sp>
+        <p:nvSpPr>
+          <p:cNvPr id="3" name="Shape 1"/>
+          <p:cNvSpPr/>
+          <p:nvPr/>
+        </p:nvSpPr>
+        <p:spPr>
+          <a:xfrm>
+            <a:off x="0" y="0"/>
+            <a:ext cx="5120512" cy="1005840"/>
+          </a:xfrm>
+          <a:prstGeom prst="rect">
+            <a:avLst/>
+          </a:prstGeom>
+          <a:solidFill>
+            <a:srgbClr val="0A1F3B"/>
+          </a:solidFill>
+          <a:ln/>
+        </p:spPr>
+      </p:sp>
+      <p:sp>
+        <p:nvSpPr>
+          <p:cNvPr id="4" name="Shape 2"/>
+          <p:cNvSpPr/>
+          <p:nvPr/>
+        </p:nvSpPr>
+        <p:spPr>
+          <a:xfrm>
+            <a:off x="9997190" y="0"/>
+            <a:ext cx="2194505" cy="1005840"/>
+          </a:xfrm>
+          <a:prstGeom prst="rect">
+            <a:avLst/>
+          </a:prstGeom>
+          <a:solidFill>
+            <a:srgbClr val="106B78"/>
+          </a:solidFill>
+          <a:ln/>
+        </p:spPr>
+      </p:sp>
+      <p:sp>
+        <p:nvSpPr>
+          <p:cNvPr id="5" name="Shape 3"/>
+          <p:cNvSpPr/>
+          <p:nvPr/>
+        </p:nvSpPr>
+        <p:spPr>
+          <a:xfrm>
+            <a:off x="0" y="973836"/>
+            <a:ext cx="12191695" cy="32004"/>
+          </a:xfrm>
+          <a:prstGeom prst="rect">
+            <a:avLst/>
+          </a:prstGeom>
+          <a:solidFill>
+            <a:srgbClr val="17A9B0"/>
+          </a:solidFill>
+          <a:ln/>
+        </p:spPr>
+      </p:sp>
+      <p:sp>
+        <p:nvSpPr>
+          <p:cNvPr id="6" name="Shape 4"/>
+          <p:cNvSpPr/>
+          <p:nvPr/>
+        </p:nvSpPr>
+        <p:spPr>
+          <a:xfrm>
+            <a:off x="10774375" y="-960120"/>
+            <a:ext cx="2377440" cy="2377440"/>
+          </a:xfrm>
+          <a:prstGeom prst="ellipse">
+            <a:avLst/>
+          </a:prstGeom>
+          <a:ln w="12700">
+            <a:solidFill>
+              <a:srgbClr val="97D8DB">
+                <a:alpha val="18000"/>
+              </a:srgbClr>
+            </a:solidFill>
+            <a:prstDash val="solid"/>
+          </a:ln>
+        </p:spPr>
+      </p:sp>
+      <p:sp>
+        <p:nvSpPr>
+          <p:cNvPr id="7" name="Shape 5"/>
+          <p:cNvSpPr/>
+          <p:nvPr/>
+        </p:nvSpPr>
+        <p:spPr>
+          <a:xfrm>
+            <a:off x="11048695" y="-685800"/>
+            <a:ext cx="1828800" cy="1828800"/>
+          </a:xfrm>
+          <a:prstGeom prst="ellipse">
+            <a:avLst/>
+          </a:prstGeom>
+          <a:ln w="12700">
+            <a:solidFill>
+              <a:srgbClr val="97D8DB">
+                <a:alpha val="18000"/>
+              </a:srgbClr>
+            </a:solidFill>
+            <a:prstDash val="solid"/>
+          </a:ln>
+        </p:spPr>
+      </p:sp>
+      <p:sp>
+        <p:nvSpPr>
+          <p:cNvPr id="8" name="Text 6"/>
+          <p:cNvSpPr txBox="1"/>
+          <p:nvPr/>
+        </p:nvSpPr>
+        <p:spPr>
+          <a:xfrm>
+            <a:off x="365760" y="128016"/>
+            <a:ext cx="8229600" cy="201168"/>
+          </a:xfrm>
+          <a:prstGeom prst="rect">
+            <a:avLst/>
+          </a:prstGeom>
+          <a:noFill/>
+          <a:ln/>
+        </p:spPr>
+        <p:txBody>
+          <a:bodyPr wrap="square" lIns="0" tIns="0" rIns="0" bIns="0" rtlCol="0" anchor="ctr"/>
+          <a:lstStyle/>
+          <a:p>
+            <a:pPr algn="l" indent="0" marL="0">
+              <a:buNone/>
+            </a:pPr>
+            <a:r>
+              <a:rPr lang="en-US" sz="1000" b="1" spc="200" kern="0" dirty="0">
+                <a:solidFill>
+                  <a:srgbClr val="97D8DB"/>
+                </a:solidFill>
+                <a:latin typeface="Calibri" pitchFamily="34" charset="0"/>
+                <a:ea typeface="Calibri" pitchFamily="34" charset="-122"/>
+                <a:cs typeface="Calibri" pitchFamily="34" charset="-120"/>
+              </a:rPr>
+              <a:t>COMÉDICA DE R.L.</a:t>
+            </a:r>
+            <a:endParaRPr lang="en-US" sz="1000" dirty="0"/>
+          </a:p>
+        </p:txBody>
+      </p:sp>
+      <p:sp>
+        <p:nvSpPr>
+          <p:cNvPr id="9" name="Text 7"/>
+          <p:cNvSpPr txBox="1"/>
+          <p:nvPr/>
+        </p:nvSpPr>
+        <p:spPr>
+          <a:xfrm>
+            <a:off x="365760" y="329184"/>
+            <a:ext cx="8229600" cy="384048"/>
+          </a:xfrm>
+          <a:prstGeom prst="rect">
+            <a:avLst/>
+          </a:prstGeom>
+          <a:noFill/>
+          <a:ln/>
+        </p:spPr>
+        <p:txBody>
+          <a:bodyPr wrap="square" lIns="0" tIns="0" rIns="0" bIns="0" rtlCol="0" anchor="ctr"/>
+          <a:lstStyle/>
+          <a:p>
+            <a:pPr algn="l" indent="0" marL="0">
+              <a:buNone/>
+            </a:pPr>
+            <a:r>
+              <a:rPr lang="en-US" sz="2500" b="1" dirty="0">
+                <a:solidFill>
+                  <a:srgbClr val="FFFFFF"/>
+                </a:solidFill>
+                <a:latin typeface="Calibri" pitchFamily="34" charset="0"/>
+                <a:ea typeface="Calibri" pitchFamily="34" charset="-122"/>
+                <a:cs typeface="Calibri" pitchFamily="34" charset="-120"/>
+              </a:rPr>
+              <a:t>Administración de Riesgos</a:t>
+            </a:r>
+            <a:endParaRPr lang="en-US" sz="2500" dirty="0"/>
+          </a:p>
+        </p:txBody>
+      </p:sp>
+      <p:sp>
+        <p:nvSpPr>
+          <p:cNvPr id="10" name="Text 8"/>
+          <p:cNvSpPr txBox="1"/>
+          <p:nvPr/>
+        </p:nvSpPr>
+        <p:spPr>
+          <a:xfrm>
+            <a:off x="365760" y="713232"/>
+            <a:ext cx="8229600" cy="219456"/>
+          </a:xfrm>
+          <a:prstGeom prst="rect">
+            <a:avLst/>
+          </a:prstGeom>
+          <a:noFill/>
+          <a:ln/>
+        </p:spPr>
+        <p:txBody>
+          <a:bodyPr wrap="square" lIns="0" tIns="0" rIns="0" bIns="0" rtlCol="0" anchor="ctr"/>
+          <a:lstStyle/>
+          <a:p>
+            <a:pPr algn="l" indent="0" marL="0">
+              <a:buNone/>
+            </a:pPr>
+            <a:r>
+              <a:rPr lang="en-US" sz="1100" dirty="0">
+                <a:solidFill>
+                  <a:srgbClr val="8CBCE0"/>
+                </a:solidFill>
+                <a:latin typeface="Calibri" pitchFamily="34" charset="0"/>
+                <a:ea typeface="Calibri" pitchFamily="34" charset="-122"/>
+                <a:cs typeface="Calibri" pitchFamily="34" charset="-120"/>
+              </a:rPr>
+              <a:t>Cronograma de Actividades · Resumen Ejecutivo</a:t>
+            </a:r>
+            <a:endParaRPr lang="en-US" sz="1100" dirty="0"/>
+          </a:p>
+        </p:txBody>
+      </p:sp>
+      <p:sp>
+        <p:nvSpPr>
+          <p:cNvPr id="11" name="Text 9"/>
+          <p:cNvSpPr txBox="1"/>
+          <p:nvPr/>
+        </p:nvSpPr>
+        <p:spPr>
+          <a:xfrm>
+            <a:off x="8899855" y="219456"/>
+            <a:ext cx="2926080" cy="182880"/>
+          </a:xfrm>
+          <a:prstGeom prst="rect">
+            <a:avLst/>
+          </a:prstGeom>
+          <a:noFill/>
+          <a:ln/>
+        </p:spPr>
+        <p:txBody>
+          <a:bodyPr wrap="square" lIns="0" tIns="0" rIns="0" bIns="0" rtlCol="0" anchor="ctr"/>
+          <a:lstStyle/>
+          <a:p>
+            <a:pPr algn="r" indent="0" marL="0">
+              <a:buNone/>
+            </a:pPr>
+            <a:endParaRPr lang="en-US" sz="900" dirty="0"/>
+          </a:p>
+        </p:txBody>
+      </p:sp>
+      <p:sp>
+        <p:nvSpPr>
+          <p:cNvPr id="12" name="Text 10"/>
+          <p:cNvSpPr txBox="1"/>
+          <p:nvPr/>
+        </p:nvSpPr>
+        <p:spPr>
+          <a:xfrm>
+            <a:off x="8899855" y="402336"/>
+            <a:ext cx="2926080" cy="292608"/>
+          </a:xfrm>
+          <a:prstGeom prst="rect">
+            <a:avLst/>
+          </a:prstGeom>
+          <a:noFill/>
+          <a:ln/>
+        </p:spPr>
+        <p:txBody>
+          <a:bodyPr wrap="square" lIns="0" tIns="0" rIns="0" bIns="0" rtlCol="0" anchor="ctr"/>
+          <a:lstStyle/>
+          <a:p>
+            <a:pPr algn="r" indent="0" marL="0">
+              <a:buNone/>
+            </a:pPr>
+            <a:endParaRPr lang="en-US" sz="1500" dirty="0"/>
+          </a:p>
+        </p:txBody>
+      </p:sp>
+      <p:sp>
+        <p:nvSpPr>
+          <p:cNvPr id="13" name="Shape 11"/>
+          <p:cNvSpPr/>
+          <p:nvPr/>
+        </p:nvSpPr>
+        <p:spPr>
+          <a:xfrm>
+            <a:off x="0" y="6565392"/>
+            <a:ext cx="12191695" cy="292608"/>
+          </a:xfrm>
+          <a:prstGeom prst="rect">
+            <a:avLst/>
+          </a:prstGeom>
+          <a:solidFill>
+            <a:srgbClr val="F2F5F9"/>
+          </a:solidFill>
+          <a:ln w="9525">
+            <a:solidFill>
+              <a:srgbClr val="DDE3EC"/>
+            </a:solidFill>
+            <a:prstDash val="solid"/>
+          </a:ln>
+        </p:spPr>
+      </p:sp>
+      <p:sp>
+        <p:nvSpPr>
+          <p:cNvPr id="14" name="Text 12"/>
+          <p:cNvSpPr txBox="1"/>
+          <p:nvPr/>
+        </p:nvSpPr>
+        <p:spPr>
+          <a:xfrm>
+            <a:off x="0" y="6565392"/>
+            <a:ext cx="12191695" cy="292608"/>
+          </a:xfrm>
+          <a:prstGeom prst="rect">
+            <a:avLst/>
+          </a:prstGeom>
+          <a:noFill/>
+          <a:ln/>
+        </p:spPr>
+        <p:txBody>
+          <a:bodyPr wrap="square" lIns="0" tIns="0" rIns="0" bIns="0" rtlCol="0" anchor="ctr"/>
+          <a:lstStyle/>
+          <a:p>
+            <a:pPr algn="ctr" indent="0" marL="0">
+              <a:buNone/>
+            </a:pPr>
+            <a:r>
+              <a:rPr lang="en-US" sz="900" b="1" dirty="0">
+                <a:solidFill>
+                  <a:srgbClr val="5B6B82"/>
+                </a:solidFill>
+                <a:latin typeface="Calibri" pitchFamily="34" charset="0"/>
+                <a:ea typeface="Calibri" pitchFamily="34" charset="-122"/>
+                <a:cs typeface="Calibri" pitchFamily="34" charset="-120"/>
+              </a:rPr>
+              <a:t>COMÉDICA DE R.L.  ·  Resumen de Actividades por Riesgo</a:t>
+            </a:r>
+            <a:endParaRPr lang="en-US" sz="900" dirty="0"/>
+          </a:p>
+        </p:txBody>
+      </p:sp>
+      <p:sp>
+        <p:nvSpPr>
+          <p:cNvPr id="15" name="Shape 13"/>
+          <p:cNvSpPr/>
+          <p:nvPr/>
+        </p:nvSpPr>
+        <p:spPr>
+          <a:xfrm>
+            <a:off x="365760" y="1170432"/>
+            <a:ext cx="11460175" cy="219456"/>
+          </a:xfrm>
+          <a:prstGeom prst="roundRect">
+            <a:avLst>
+              <a:gd name="adj" fmla="val 20833"/>
+            </a:avLst>
+          </a:prstGeom>
+          <a:solidFill>
+            <a:srgbClr val="1B4F91"/>
+          </a:solidFill>
+          <a:ln/>
+        </p:spPr>
+      </p:sp>
+      <p:sp>
+        <p:nvSpPr>
+          <p:cNvPr id="16" name="Text 14"/>
+          <p:cNvSpPr txBox="1"/>
+          <p:nvPr/>
+        </p:nvSpPr>
+        <p:spPr>
+          <a:xfrm>
+            <a:off x="493776" y="1170432"/>
+            <a:ext cx="8716975" cy="219456"/>
+          </a:xfrm>
+          <a:prstGeom prst="rect">
+            <a:avLst/>
+          </a:prstGeom>
+          <a:noFill/>
+          <a:ln/>
+        </p:spPr>
+        <p:txBody>
+          <a:bodyPr wrap="square" lIns="0" tIns="0" rIns="0" bIns="0" rtlCol="0" anchor="ctr"/>
+          <a:lstStyle/>
+          <a:p>
+            <a:pPr algn="l" indent="0" marL="0">
+              <a:buNone/>
+            </a:pPr>
+            <a:r>
+              <a:rPr lang="en-US" sz="1100" b="1" dirty="0">
+                <a:solidFill>
+                  <a:srgbClr val="FFFFFF"/>
+                </a:solidFill>
+                <a:latin typeface="Calibri" pitchFamily="34" charset="0"/>
+                <a:ea typeface="Calibri" pitchFamily="34" charset="-122"/>
+                <a:cs typeface="Calibri" pitchFamily="34" charset="-120"/>
+              </a:rPr>
+              <a:t>Riesgo Operacional (RO)</a:t>
+            </a:r>
+            <a:endParaRPr lang="en-US" sz="1100" dirty="0"/>
+          </a:p>
+        </p:txBody>
+      </p:sp>
+      <p:sp>
+        <p:nvSpPr>
+          <p:cNvPr id="17" name="Text 15"/>
+          <p:cNvSpPr txBox="1"/>
+          <p:nvPr/>
+        </p:nvSpPr>
+        <p:spPr>
+          <a:xfrm>
+            <a:off x="9174175" y="1170432"/>
+            <a:ext cx="2523744" cy="219456"/>
+          </a:xfrm>
+          <a:prstGeom prst="rect">
+            <a:avLst/>
+          </a:prstGeom>
+          <a:noFill/>
+          <a:ln/>
+        </p:spPr>
+        <p:txBody>
+          <a:bodyPr wrap="square" lIns="0" tIns="0" rIns="0" bIns="0" rtlCol="0" anchor="ctr"/>
+          <a:lstStyle/>
+          <a:p>
+            <a:pPr algn="r" indent="0" marL="0">
+              <a:buNone/>
+            </a:pPr>
+            <a:r>
+              <a:rPr lang="en-US" sz="800" dirty="0">
+                <a:solidFill>
+                  <a:srgbClr val="FFFFFF"/>
+                </a:solidFill>
+                <a:latin typeface="Calibri" pitchFamily="34" charset="0"/>
+                <a:ea typeface="Calibri" pitchFamily="34" charset="-122"/>
+                <a:cs typeface="Calibri" pitchFamily="34" charset="-120"/>
+              </a:rPr>
+              <a:t>6 actividades</a:t>
+            </a:r>
+            <a:endParaRPr lang="en-US" sz="800" dirty="0"/>
+          </a:p>
+        </p:txBody>
+      </p:sp>
+      <p:sp>
+        <p:nvSpPr>
+          <p:cNvPr id="18" name="Shape 16"/>
+          <p:cNvSpPr/>
+          <p:nvPr/>
+        </p:nvSpPr>
+        <p:spPr>
+          <a:xfrm>
+            <a:off x="365760" y="1472184"/>
+            <a:ext cx="5666080" cy="1051560"/>
+          </a:xfrm>
+          <a:prstGeom prst="roundRect">
+            <a:avLst>
+              <a:gd name="adj" fmla="val 6087"/>
+            </a:avLst>
+          </a:prstGeom>
+          <a:solidFill>
+            <a:srgbClr val="FFFFFF"/>
+          </a:solidFill>
+          <a:ln/>
+          <a:effectLst>
+            <a:outerShdw sx="100000" sy="100000" kx="0" ky="0" algn="bl" rotWithShape="0" blurRad="101600" dist="25400" dir="5400000">
+              <a:srgbClr val="0F2F4E">
+                <a:alpha val="22000"/>
+              </a:srgbClr>
+            </a:outerShdw>
+          </a:effectLst>
+        </p:spPr>
+      </p:sp>
+      <p:sp>
+        <p:nvSpPr>
+          <p:cNvPr id="19" name="Shape 17"/>
+          <p:cNvSpPr/>
+          <p:nvPr/>
+        </p:nvSpPr>
+        <p:spPr>
+          <a:xfrm>
+            <a:off x="365760" y="1472184"/>
+            <a:ext cx="5666080" cy="41148"/>
+          </a:xfrm>
+          <a:prstGeom prst="rect">
+            <a:avLst/>
+          </a:prstGeom>
+          <a:solidFill>
+            <a:srgbClr val="1B4F91"/>
+          </a:solidFill>
+          <a:ln/>
+        </p:spPr>
+      </p:sp>
+      <p:sp>
+        <p:nvSpPr>
+          <p:cNvPr id="20" name="Shape 18"/>
+          <p:cNvSpPr/>
+          <p:nvPr/>
+        </p:nvSpPr>
+        <p:spPr>
+          <a:xfrm>
+            <a:off x="3098216" y="1522476"/>
+            <a:ext cx="201168" cy="201168"/>
+          </a:xfrm>
+          <a:prstGeom prst="ellipse">
+            <a:avLst/>
+          </a:prstGeom>
+          <a:solidFill>
+            <a:srgbClr val="EAF0F8"/>
+          </a:solidFill>
+          <a:ln/>
+        </p:spPr>
+      </p:sp>
+      <p:pic>
+        <p:nvPicPr>
+          <p:cNvPr id="21" name="Image 0" descr="/tmp/claude-0/-home-user-riesgo/579fb8c8-70e5-51d5-80ec-6ed51cc2e8df/scratchpad/pptx-build/icons/settings_1B4F91.png">    </p:cNvPr>
+          <p:cNvPicPr>
+            <a:picLocks noChangeAspect="1"/>
+          </p:cNvPicPr>
+          <p:nvPr/>
+        </p:nvPicPr>
+        <p:blipFill>
+          <a:blip r:embed="rId1"/>
+          <a:stretch>
+            <a:fillRect/>
+          </a:stretch>
+        </p:blipFill>
+        <p:spPr>
+          <a:xfrm>
+            <a:off x="3138449" y="1562710"/>
+            <a:ext cx="120701" cy="120701"/>
+          </a:xfrm>
+          <a:prstGeom prst="rect">
+            <a:avLst/>
+          </a:prstGeom>
+        </p:spPr>
+      </p:pic>
+      <p:sp>
+        <p:nvSpPr>
+          <p:cNvPr id="22" name="Text 19"/>
+          <p:cNvSpPr txBox="1"/>
+          <p:nvPr/>
+        </p:nvSpPr>
+        <p:spPr>
+          <a:xfrm>
+            <a:off x="411480" y="1755648"/>
+            <a:ext cx="5574640" cy="237744"/>
+          </a:xfrm>
+          <a:prstGeom prst="rect">
+            <a:avLst/>
+          </a:prstGeom>
+          <a:noFill/>
+          <a:ln/>
+        </p:spPr>
+        <p:txBody>
+          <a:bodyPr wrap="square" lIns="0" tIns="0" rIns="0" bIns="0" rtlCol="0" anchor="t"/>
+          <a:lstStyle/>
+          <a:p>
+            <a:pPr algn="ctr" indent="0" marL="0">
+              <a:lnSpc>
+                <a:spcPct val="94000"/>
+              </a:lnSpc>
+              <a:buNone/>
+            </a:pPr>
+            <a:r>
+              <a:rPr lang="en-US" sz="760" b="1" dirty="0">
+                <a:solidFill>
+                  <a:srgbClr val="17223A"/>
+                </a:solidFill>
+                <a:latin typeface="Calibri" pitchFamily="34" charset="0"/>
+                <a:ea typeface="Calibri" pitchFamily="34" charset="-122"/>
+                <a:cs typeface="Calibri" pitchFamily="34" charset="-120"/>
+              </a:rPr>
+              <a:t>Evaluación de Proyectos</a:t>
+            </a:r>
+            <a:endParaRPr lang="en-US" sz="760" dirty="0"/>
+          </a:p>
+        </p:txBody>
+      </p:sp>
+      <p:sp>
+        <p:nvSpPr>
+          <p:cNvPr id="23" name="Shape 20"/>
+          <p:cNvSpPr/>
+          <p:nvPr/>
+        </p:nvSpPr>
+        <p:spPr>
+          <a:xfrm>
+            <a:off x="3079928" y="1874520"/>
+            <a:ext cx="237744" cy="13716"/>
+          </a:xfrm>
+          <a:prstGeom prst="rect">
+            <a:avLst/>
+          </a:prstGeom>
+          <a:solidFill>
+            <a:srgbClr val="1B4F91"/>
+          </a:solidFill>
+          <a:ln/>
+        </p:spPr>
+      </p:sp>
+      <p:sp>
+        <p:nvSpPr>
+          <p:cNvPr id="24" name="Shape 21"/>
+          <p:cNvSpPr/>
+          <p:nvPr/>
+        </p:nvSpPr>
+        <p:spPr>
+          <a:xfrm>
+            <a:off x="484632" y="1944014"/>
+            <a:ext cx="38405" cy="38405"/>
+          </a:xfrm>
+          <a:prstGeom prst="ellipse">
+            <a:avLst/>
+          </a:prstGeom>
+          <a:solidFill>
+            <a:srgbClr val="C3CBD6"/>
+          </a:solidFill>
+          <a:ln/>
+        </p:spPr>
+      </p:sp>
+      <p:sp>
+        <p:nvSpPr>
+          <p:cNvPr id="25" name="Text 22"/>
+          <p:cNvSpPr txBox="1"/>
+          <p:nvPr/>
+        </p:nvSpPr>
+        <p:spPr>
+          <a:xfrm>
+            <a:off x="603504" y="1901952"/>
+            <a:ext cx="5309464" cy="137160"/>
+          </a:xfrm>
+          <a:prstGeom prst="rect">
+            <a:avLst/>
+          </a:prstGeom>
+          <a:noFill/>
+          <a:ln/>
+        </p:spPr>
+        <p:txBody>
+          <a:bodyPr wrap="square" lIns="0" tIns="0" rIns="0" bIns="0" rtlCol="0" anchor="t"/>
+          <a:lstStyle/>
+          <a:p>
+            <a:pPr algn="l" indent="0" marL="0">
+              <a:lnSpc>
+                <a:spcPct val="98000"/>
+              </a:lnSpc>
+              <a:buNone/>
+            </a:pPr>
+            <a:r>
+              <a:rPr lang="en-US" sz="800" dirty="0">
+                <a:solidFill>
+                  <a:srgbClr val="243044"/>
+                </a:solidFill>
+                <a:latin typeface="Calibri" pitchFamily="34" charset="0"/>
+                <a:ea typeface="Calibri" pitchFamily="34" charset="-122"/>
+                <a:cs typeface="Calibri" pitchFamily="34" charset="-120"/>
+              </a:rPr>
+              <a:t>Procesador TC: encuestas, matriz de riesgo operacional y requerimiento de información</a:t>
+            </a:r>
+            <a:endParaRPr lang="en-US" sz="800" dirty="0"/>
+          </a:p>
+        </p:txBody>
+      </p:sp>
+      <p:sp>
+        <p:nvSpPr>
+          <p:cNvPr id="26" name="Shape 23"/>
+          <p:cNvSpPr/>
+          <p:nvPr/>
+        </p:nvSpPr>
+        <p:spPr>
+          <a:xfrm>
+            <a:off x="484632" y="2067458"/>
+            <a:ext cx="38405" cy="38405"/>
+          </a:xfrm>
+          <a:prstGeom prst="ellipse">
+            <a:avLst/>
+          </a:prstGeom>
+          <a:solidFill>
+            <a:srgbClr val="C3CBD6"/>
+          </a:solidFill>
+          <a:ln/>
+        </p:spPr>
+      </p:sp>
+      <p:sp>
+        <p:nvSpPr>
+          <p:cNvPr id="27" name="Text 24"/>
+          <p:cNvSpPr txBox="1"/>
+          <p:nvPr/>
+        </p:nvSpPr>
+        <p:spPr>
+          <a:xfrm>
+            <a:off x="603504" y="2025396"/>
+            <a:ext cx="5309464" cy="137160"/>
+          </a:xfrm>
+          <a:prstGeom prst="rect">
+            <a:avLst/>
+          </a:prstGeom>
+          <a:noFill/>
+          <a:ln/>
+        </p:spPr>
+        <p:txBody>
+          <a:bodyPr wrap="square" lIns="0" tIns="0" rIns="0" bIns="0" rtlCol="0" anchor="t"/>
+          <a:lstStyle/>
+          <a:p>
+            <a:pPr algn="l" indent="0" marL="0">
+              <a:lnSpc>
+                <a:spcPct val="98000"/>
+              </a:lnSpc>
+              <a:buNone/>
+            </a:pPr>
+            <a:r>
+              <a:rPr lang="en-US" sz="800" dirty="0">
+                <a:solidFill>
+                  <a:srgbClr val="243044"/>
+                </a:solidFill>
+                <a:latin typeface="Calibri" pitchFamily="34" charset="0"/>
+                <a:ea typeface="Calibri" pitchFamily="34" charset="-122"/>
+                <a:cs typeface="Calibri" pitchFamily="34" charset="-120"/>
+              </a:rPr>
+              <a:t>Gestor Documental: evaluación de peritaje TC</a:t>
+            </a:r>
+            <a:endParaRPr lang="en-US" sz="800" dirty="0"/>
+          </a:p>
+        </p:txBody>
+      </p:sp>
+      <p:sp>
+        <p:nvSpPr>
+          <p:cNvPr id="28" name="Shape 25"/>
+          <p:cNvSpPr/>
+          <p:nvPr/>
+        </p:nvSpPr>
+        <p:spPr>
+          <a:xfrm>
+            <a:off x="484632" y="2190902"/>
+            <a:ext cx="38405" cy="38405"/>
+          </a:xfrm>
+          <a:prstGeom prst="ellipse">
+            <a:avLst/>
+          </a:prstGeom>
+          <a:solidFill>
+            <a:srgbClr val="C3CBD6"/>
+          </a:solidFill>
+          <a:ln/>
+        </p:spPr>
+      </p:sp>
+      <p:sp>
+        <p:nvSpPr>
+          <p:cNvPr id="29" name="Text 26"/>
+          <p:cNvSpPr txBox="1"/>
+          <p:nvPr/>
+        </p:nvSpPr>
+        <p:spPr>
+          <a:xfrm>
+            <a:off x="603504" y="2148840"/>
+            <a:ext cx="5309464" cy="137160"/>
+          </a:xfrm>
+          <a:prstGeom prst="rect">
+            <a:avLst/>
+          </a:prstGeom>
+          <a:noFill/>
+          <a:ln/>
+        </p:spPr>
+        <p:txBody>
+          <a:bodyPr wrap="square" lIns="0" tIns="0" rIns="0" bIns="0" rtlCol="0" anchor="t"/>
+          <a:lstStyle/>
+          <a:p>
+            <a:pPr algn="l" indent="0" marL="0">
+              <a:lnSpc>
+                <a:spcPct val="98000"/>
+              </a:lnSpc>
+              <a:buNone/>
+            </a:pPr>
+            <a:r>
+              <a:rPr lang="en-US" sz="800" dirty="0">
+                <a:solidFill>
+                  <a:srgbClr val="243044"/>
+                </a:solidFill>
+                <a:latin typeface="Calibri" pitchFamily="34" charset="0"/>
+                <a:ea typeface="Calibri" pitchFamily="34" charset="-122"/>
+                <a:cs typeface="Calibri" pitchFamily="34" charset="-120"/>
+              </a:rPr>
+              <a:t>Avalúos: revisión de formulario de informe y reunión de créditos</a:t>
+            </a:r>
+            <a:endParaRPr lang="en-US" sz="800" dirty="0"/>
+          </a:p>
+        </p:txBody>
+      </p:sp>
+      <p:sp>
+        <p:nvSpPr>
+          <p:cNvPr id="30" name="Shape 27"/>
+          <p:cNvSpPr/>
+          <p:nvPr/>
+        </p:nvSpPr>
+        <p:spPr>
+          <a:xfrm>
+            <a:off x="6159856" y="1472184"/>
+            <a:ext cx="5666080" cy="1051560"/>
+          </a:xfrm>
+          <a:prstGeom prst="roundRect">
+            <a:avLst>
+              <a:gd name="adj" fmla="val 6087"/>
+            </a:avLst>
+          </a:prstGeom>
+          <a:solidFill>
+            <a:srgbClr val="FFFFFF"/>
+          </a:solidFill>
+          <a:ln/>
+          <a:effectLst>
+            <a:outerShdw sx="100000" sy="100000" kx="0" ky="0" algn="bl" rotWithShape="0" blurRad="101600" dist="25400" dir="5400000">
+              <a:srgbClr val="0F2F4E">
+                <a:alpha val="22000"/>
+              </a:srgbClr>
+            </a:outerShdw>
+          </a:effectLst>
+        </p:spPr>
+      </p:sp>
+      <p:sp>
+        <p:nvSpPr>
+          <p:cNvPr id="31" name="Shape 28"/>
+          <p:cNvSpPr/>
+          <p:nvPr/>
+        </p:nvSpPr>
+        <p:spPr>
+          <a:xfrm>
+            <a:off x="6159856" y="1472184"/>
+            <a:ext cx="5666080" cy="41148"/>
+          </a:xfrm>
+          <a:prstGeom prst="rect">
+            <a:avLst/>
+          </a:prstGeom>
+          <a:solidFill>
+            <a:srgbClr val="1B4F91"/>
+          </a:solidFill>
+          <a:ln/>
+        </p:spPr>
+      </p:sp>
+      <p:sp>
+        <p:nvSpPr>
+          <p:cNvPr id="32" name="Shape 29"/>
+          <p:cNvSpPr/>
+          <p:nvPr/>
+        </p:nvSpPr>
+        <p:spPr>
+          <a:xfrm>
+            <a:off x="8892311" y="1522476"/>
+            <a:ext cx="201168" cy="201168"/>
+          </a:xfrm>
+          <a:prstGeom prst="ellipse">
+            <a:avLst/>
+          </a:prstGeom>
+          <a:solidFill>
+            <a:srgbClr val="EAF0F8"/>
+          </a:solidFill>
+          <a:ln/>
+        </p:spPr>
+      </p:sp>
+      <p:pic>
+        <p:nvPicPr>
+          <p:cNvPr id="33" name="Image 1" descr="/tmp/claude-0/-home-user-riesgo/579fb8c8-70e5-51d5-80ec-6ed51cc2e8df/scratchpad/pptx-build/icons/briefcase_1B4F91.png">    </p:cNvPr>
+          <p:cNvPicPr>
+            <a:picLocks noChangeAspect="1"/>
+          </p:cNvPicPr>
+          <p:nvPr/>
+        </p:nvPicPr>
+        <p:blipFill>
+          <a:blip r:embed="rId2"/>
+          <a:stretch>
+            <a:fillRect/>
+          </a:stretch>
+        </p:blipFill>
+        <p:spPr>
+          <a:xfrm>
+            <a:off x="8932545" y="1562710"/>
+            <a:ext cx="120701" cy="120701"/>
+          </a:xfrm>
+          <a:prstGeom prst="rect">
+            <a:avLst/>
+          </a:prstGeom>
+        </p:spPr>
+      </p:pic>
+      <p:sp>
+        <p:nvSpPr>
+          <p:cNvPr id="34" name="Text 30"/>
+          <p:cNvSpPr txBox="1"/>
+          <p:nvPr/>
+        </p:nvSpPr>
+        <p:spPr>
+          <a:xfrm>
+            <a:off x="6205576" y="1755648"/>
+            <a:ext cx="5574640" cy="237744"/>
+          </a:xfrm>
+          <a:prstGeom prst="rect">
+            <a:avLst/>
+          </a:prstGeom>
+          <a:noFill/>
+          <a:ln/>
+        </p:spPr>
+        <p:txBody>
+          <a:bodyPr wrap="square" lIns="0" tIns="0" rIns="0" bIns="0" rtlCol="0" anchor="t"/>
+          <a:lstStyle/>
+          <a:p>
+            <a:pPr algn="ctr" indent="0" marL="0">
+              <a:lnSpc>
+                <a:spcPct val="94000"/>
+              </a:lnSpc>
+              <a:buNone/>
+            </a:pPr>
+            <a:r>
+              <a:rPr lang="en-US" sz="760" b="1" dirty="0">
+                <a:solidFill>
+                  <a:srgbClr val="17223A"/>
+                </a:solidFill>
+                <a:latin typeface="Calibri" pitchFamily="34" charset="0"/>
+                <a:ea typeface="Calibri" pitchFamily="34" charset="-122"/>
+                <a:cs typeface="Calibri" pitchFamily="34" charset="-120"/>
+              </a:rPr>
+              <a:t>Gobierno y Seguimiento</a:t>
+            </a:r>
+            <a:endParaRPr lang="en-US" sz="760" dirty="0"/>
+          </a:p>
+        </p:txBody>
+      </p:sp>
+      <p:sp>
+        <p:nvSpPr>
+          <p:cNvPr id="35" name="Shape 31"/>
+          <p:cNvSpPr/>
+          <p:nvPr/>
+        </p:nvSpPr>
+        <p:spPr>
+          <a:xfrm>
+            <a:off x="8874023" y="1874520"/>
+            <a:ext cx="237744" cy="13716"/>
+          </a:xfrm>
+          <a:prstGeom prst="rect">
+            <a:avLst/>
+          </a:prstGeom>
+          <a:solidFill>
+            <a:srgbClr val="1B4F91"/>
+          </a:solidFill>
+          <a:ln/>
+        </p:spPr>
+      </p:sp>
+      <p:sp>
+        <p:nvSpPr>
+          <p:cNvPr id="36" name="Shape 32"/>
+          <p:cNvSpPr/>
+          <p:nvPr/>
+        </p:nvSpPr>
+        <p:spPr>
+          <a:xfrm>
+            <a:off x="6278728" y="1944014"/>
+            <a:ext cx="38405" cy="38405"/>
+          </a:xfrm>
+          <a:prstGeom prst="ellipse">
+            <a:avLst/>
+          </a:prstGeom>
+          <a:solidFill>
+            <a:srgbClr val="C3CBD6"/>
+          </a:solidFill>
+          <a:ln/>
+        </p:spPr>
+      </p:sp>
+      <p:sp>
+        <p:nvSpPr>
+          <p:cNvPr id="37" name="Text 33"/>
+          <p:cNvSpPr txBox="1"/>
+          <p:nvPr/>
+        </p:nvSpPr>
+        <p:spPr>
+          <a:xfrm>
+            <a:off x="6397600" y="1901952"/>
+            <a:ext cx="5309464" cy="137160"/>
+          </a:xfrm>
+          <a:prstGeom prst="rect">
+            <a:avLst/>
+          </a:prstGeom>
+          <a:noFill/>
+          <a:ln/>
+        </p:spPr>
+        <p:txBody>
+          <a:bodyPr wrap="square" lIns="0" tIns="0" rIns="0" bIns="0" rtlCol="0" anchor="t"/>
+          <a:lstStyle/>
+          <a:p>
+            <a:pPr algn="l" indent="0" marL="0">
+              <a:lnSpc>
+                <a:spcPct val="98000"/>
+              </a:lnSpc>
+              <a:buNone/>
+            </a:pPr>
+            <a:r>
+              <a:rPr lang="en-US" sz="800" dirty="0">
+                <a:solidFill>
+                  <a:srgbClr val="243044"/>
+                </a:solidFill>
+                <a:latin typeface="Calibri" pitchFamily="34" charset="0"/>
+                <a:ea typeface="Calibri" pitchFamily="34" charset="-122"/>
+                <a:cs typeface="Calibri" pitchFamily="34" charset="-120"/>
+              </a:rPr>
+              <a:t>Visita SSF: Gobierno Corporativo – Plan de Recuperación (reunión de cierre)</a:t>
+            </a:r>
+            <a:endParaRPr lang="en-US" sz="800" dirty="0"/>
+          </a:p>
+        </p:txBody>
+      </p:sp>
+      <p:sp>
+        <p:nvSpPr>
+          <p:cNvPr id="38" name="Shape 34"/>
+          <p:cNvSpPr/>
+          <p:nvPr/>
+        </p:nvSpPr>
+        <p:spPr>
+          <a:xfrm>
+            <a:off x="6278728" y="2067458"/>
+            <a:ext cx="38405" cy="38405"/>
+          </a:xfrm>
+          <a:prstGeom prst="ellipse">
+            <a:avLst/>
+          </a:prstGeom>
+          <a:solidFill>
+            <a:srgbClr val="C3CBD6"/>
+          </a:solidFill>
+          <a:ln/>
+        </p:spPr>
+      </p:sp>
+      <p:sp>
+        <p:nvSpPr>
+          <p:cNvPr id="39" name="Text 35"/>
+          <p:cNvSpPr txBox="1"/>
+          <p:nvPr/>
+        </p:nvSpPr>
+        <p:spPr>
+          <a:xfrm>
+            <a:off x="6397600" y="2025396"/>
+            <a:ext cx="5309464" cy="137160"/>
+          </a:xfrm>
+          <a:prstGeom prst="rect">
+            <a:avLst/>
+          </a:prstGeom>
+          <a:noFill/>
+          <a:ln/>
+        </p:spPr>
+        <p:txBody>
+          <a:bodyPr wrap="square" lIns="0" tIns="0" rIns="0" bIns="0" rtlCol="0" anchor="t"/>
+          <a:lstStyle/>
+          <a:p>
+            <a:pPr algn="l" indent="0" marL="0">
+              <a:lnSpc>
+                <a:spcPct val="98000"/>
+              </a:lnSpc>
+              <a:buNone/>
+            </a:pPr>
+            <a:r>
+              <a:rPr lang="en-US" sz="800" dirty="0">
+                <a:solidFill>
+                  <a:srgbClr val="243044"/>
+                </a:solidFill>
+                <a:latin typeface="Calibri" pitchFamily="34" charset="0"/>
+                <a:ea typeface="Calibri" pitchFamily="34" charset="-122"/>
+                <a:cs typeface="Calibri" pitchFamily="34" charset="-120"/>
+              </a:rPr>
+              <a:t>Seguimiento al Plan de acción de observaciones de sistemas</a:t>
+            </a:r>
+            <a:endParaRPr lang="en-US" sz="800" dirty="0"/>
+          </a:p>
+        </p:txBody>
+      </p:sp>
+      <p:sp>
+        <p:nvSpPr>
+          <p:cNvPr id="40" name="Shape 36"/>
+          <p:cNvSpPr/>
+          <p:nvPr/>
+        </p:nvSpPr>
+        <p:spPr>
+          <a:xfrm>
+            <a:off x="6278728" y="2190902"/>
+            <a:ext cx="38405" cy="38405"/>
+          </a:xfrm>
+          <a:prstGeom prst="ellipse">
+            <a:avLst/>
+          </a:prstGeom>
+          <a:solidFill>
+            <a:srgbClr val="C3CBD6"/>
+          </a:solidFill>
+          <a:ln/>
+        </p:spPr>
+      </p:sp>
+      <p:sp>
+        <p:nvSpPr>
+          <p:cNvPr id="41" name="Text 37"/>
+          <p:cNvSpPr txBox="1"/>
+          <p:nvPr/>
+        </p:nvSpPr>
+        <p:spPr>
+          <a:xfrm>
+            <a:off x="6397600" y="2148840"/>
+            <a:ext cx="5309464" cy="137160"/>
+          </a:xfrm>
+          <a:prstGeom prst="rect">
+            <a:avLst/>
+          </a:prstGeom>
+          <a:noFill/>
+          <a:ln/>
+        </p:spPr>
+        <p:txBody>
+          <a:bodyPr wrap="square" lIns="0" tIns="0" rIns="0" bIns="0" rtlCol="0" anchor="t"/>
+          <a:lstStyle/>
+          <a:p>
+            <a:pPr algn="l" indent="0" marL="0">
+              <a:lnSpc>
+                <a:spcPct val="98000"/>
+              </a:lnSpc>
+              <a:buNone/>
+            </a:pPr>
+            <a:r>
+              <a:rPr lang="en-US" sz="800" dirty="0">
+                <a:solidFill>
+                  <a:srgbClr val="243044"/>
+                </a:solidFill>
+                <a:latin typeface="Calibri" pitchFamily="34" charset="0"/>
+                <a:ea typeface="Calibri" pitchFamily="34" charset="-122"/>
+                <a:cs typeface="Calibri" pitchFamily="34" charset="-120"/>
+              </a:rPr>
+              <a:t>Seguimiento al proyecto Fábrica de Créditos</a:t>
+            </a:r>
+            <a:endParaRPr lang="en-US" sz="800" dirty="0"/>
+          </a:p>
+        </p:txBody>
+      </p:sp>
+      <p:sp>
+        <p:nvSpPr>
+          <p:cNvPr id="42" name="Shape 38"/>
+          <p:cNvSpPr/>
+          <p:nvPr/>
+        </p:nvSpPr>
+        <p:spPr>
+          <a:xfrm>
+            <a:off x="365760" y="2606040"/>
+            <a:ext cx="5666080" cy="868680"/>
+          </a:xfrm>
+          <a:prstGeom prst="roundRect">
+            <a:avLst>
+              <a:gd name="adj" fmla="val 7368"/>
+            </a:avLst>
+          </a:prstGeom>
+          <a:solidFill>
+            <a:srgbClr val="FFFFFF"/>
+          </a:solidFill>
+          <a:ln/>
+          <a:effectLst>
+            <a:outerShdw sx="100000" sy="100000" kx="0" ky="0" algn="bl" rotWithShape="0" blurRad="101600" dist="25400" dir="5400000">
+              <a:srgbClr val="0F2F4E">
+                <a:alpha val="22000"/>
+              </a:srgbClr>
+            </a:outerShdw>
+          </a:effectLst>
+        </p:spPr>
+      </p:sp>
+      <p:sp>
+        <p:nvSpPr>
+          <p:cNvPr id="43" name="Shape 39"/>
+          <p:cNvSpPr/>
+          <p:nvPr/>
+        </p:nvSpPr>
+        <p:spPr>
+          <a:xfrm>
+            <a:off x="365760" y="2606040"/>
+            <a:ext cx="5666080" cy="41148"/>
+          </a:xfrm>
+          <a:prstGeom prst="rect">
+            <a:avLst/>
+          </a:prstGeom>
+          <a:solidFill>
+            <a:srgbClr val="0F766E"/>
+          </a:solidFill>
+          <a:ln/>
+        </p:spPr>
+      </p:sp>
+      <p:sp>
+        <p:nvSpPr>
+          <p:cNvPr id="44" name="Shape 40"/>
+          <p:cNvSpPr/>
+          <p:nvPr/>
+        </p:nvSpPr>
+        <p:spPr>
+          <a:xfrm>
+            <a:off x="3098216" y="2656332"/>
+            <a:ext cx="201168" cy="201168"/>
+          </a:xfrm>
+          <a:prstGeom prst="ellipse">
+            <a:avLst/>
+          </a:prstGeom>
+          <a:solidFill>
+            <a:srgbClr val="E4F5F3"/>
+          </a:solidFill>
+          <a:ln/>
+        </p:spPr>
+      </p:sp>
+      <p:pic>
+        <p:nvPicPr>
+          <p:cNvPr id="45" name="Image 2" descr="/tmp/claude-0/-home-user-riesgo/579fb8c8-70e5-51d5-80ec-6ed51cc2e8df/scratchpad/pptx-build/icons/creditcard_0F766E.png">    </p:cNvPr>
+          <p:cNvPicPr>
+            <a:picLocks noChangeAspect="1"/>
+          </p:cNvPicPr>
+          <p:nvPr/>
+        </p:nvPicPr>
+        <p:blipFill>
+          <a:blip r:embed="rId3"/>
+          <a:stretch>
+            <a:fillRect/>
+          </a:stretch>
+        </p:blipFill>
+        <p:spPr>
+          <a:xfrm>
+            <a:off x="3138449" y="2696566"/>
+            <a:ext cx="120701" cy="120701"/>
+          </a:xfrm>
+          <a:prstGeom prst="rect">
+            <a:avLst/>
+          </a:prstGeom>
+        </p:spPr>
+      </p:pic>
+      <p:sp>
+        <p:nvSpPr>
+          <p:cNvPr id="46" name="Text 41"/>
+          <p:cNvSpPr txBox="1"/>
+          <p:nvPr/>
+        </p:nvSpPr>
+        <p:spPr>
+          <a:xfrm>
+            <a:off x="411480" y="2889504"/>
+            <a:ext cx="5574640" cy="237744"/>
+          </a:xfrm>
+          <a:prstGeom prst="rect">
+            <a:avLst/>
+          </a:prstGeom>
+          <a:noFill/>
+          <a:ln/>
+        </p:spPr>
+        <p:txBody>
+          <a:bodyPr wrap="square" lIns="0" tIns="0" rIns="0" bIns="0" rtlCol="0" anchor="t"/>
+          <a:lstStyle/>
+          <a:p>
+            <a:pPr algn="ctr" indent="0" marL="0">
+              <a:lnSpc>
+                <a:spcPct val="94000"/>
+              </a:lnSpc>
+              <a:buNone/>
+            </a:pPr>
+            <a:r>
+              <a:rPr lang="en-US" sz="760" b="1" dirty="0">
+                <a:solidFill>
+                  <a:srgbClr val="17223A"/>
+                </a:solidFill>
+                <a:latin typeface="Calibri" pitchFamily="34" charset="0"/>
+                <a:ea typeface="Calibri" pitchFamily="34" charset="-122"/>
+                <a:cs typeface="Calibri" pitchFamily="34" charset="-120"/>
+              </a:rPr>
+              <a:t>Riesgo Crediticio  ·  RIESGO FINANCIERO (RC)</a:t>
+            </a:r>
+            <a:endParaRPr lang="en-US" sz="760" dirty="0"/>
+          </a:p>
+        </p:txBody>
+      </p:sp>
+      <p:sp>
+        <p:nvSpPr>
+          <p:cNvPr id="47" name="Shape 42"/>
+          <p:cNvSpPr/>
+          <p:nvPr/>
+        </p:nvSpPr>
+        <p:spPr>
+          <a:xfrm>
+            <a:off x="3079928" y="3008376"/>
+            <a:ext cx="237744" cy="13716"/>
+          </a:xfrm>
+          <a:prstGeom prst="rect">
+            <a:avLst/>
+          </a:prstGeom>
+          <a:solidFill>
+            <a:srgbClr val="0F766E"/>
+          </a:solidFill>
+          <a:ln/>
+        </p:spPr>
+      </p:sp>
+      <p:sp>
+        <p:nvSpPr>
+          <p:cNvPr id="48" name="Shape 43"/>
+          <p:cNvSpPr/>
+          <p:nvPr/>
+        </p:nvSpPr>
+        <p:spPr>
+          <a:xfrm>
+            <a:off x="484632" y="3077870"/>
+            <a:ext cx="38405" cy="38405"/>
+          </a:xfrm>
+          <a:prstGeom prst="ellipse">
+            <a:avLst/>
+          </a:prstGeom>
+          <a:solidFill>
+            <a:srgbClr val="C3CBD6"/>
+          </a:solidFill>
+          <a:ln/>
+        </p:spPr>
+      </p:sp>
+      <p:sp>
+        <p:nvSpPr>
+          <p:cNvPr id="49" name="Text 44"/>
+          <p:cNvSpPr txBox="1"/>
+          <p:nvPr/>
+        </p:nvSpPr>
+        <p:spPr>
+          <a:xfrm>
+            <a:off x="603504" y="3035808"/>
+            <a:ext cx="5309464" cy="137160"/>
+          </a:xfrm>
+          <a:prstGeom prst="rect">
+            <a:avLst/>
+          </a:prstGeom>
+          <a:noFill/>
+          <a:ln/>
+        </p:spPr>
+        <p:txBody>
+          <a:bodyPr wrap="square" lIns="0" tIns="0" rIns="0" bIns="0" rtlCol="0" anchor="t"/>
+          <a:lstStyle/>
+          <a:p>
+            <a:pPr algn="l" indent="0" marL="0">
+              <a:lnSpc>
+                <a:spcPct val="98000"/>
+              </a:lnSpc>
+              <a:buNone/>
+            </a:pPr>
+            <a:r>
+              <a:rPr lang="en-US" sz="800" dirty="0">
+                <a:solidFill>
+                  <a:srgbClr val="243044"/>
+                </a:solidFill>
+                <a:latin typeface="Calibri" pitchFamily="34" charset="0"/>
+                <a:ea typeface="Calibri" pitchFamily="34" charset="-122"/>
+                <a:cs typeface="Calibri" pitchFamily="34" charset="-120"/>
+              </a:rPr>
+              <a:t>Evaluación de créditos castigados (Gerencia de Operaciones / Soluciones Financieras)</a:t>
+            </a:r>
+            <a:endParaRPr lang="en-US" sz="800" dirty="0"/>
+          </a:p>
+        </p:txBody>
+      </p:sp>
+      <p:sp>
+        <p:nvSpPr>
+          <p:cNvPr id="50" name="Shape 45"/>
+          <p:cNvSpPr/>
+          <p:nvPr/>
+        </p:nvSpPr>
+        <p:spPr>
+          <a:xfrm>
+            <a:off x="484632" y="3201314"/>
+            <a:ext cx="38405" cy="38405"/>
+          </a:xfrm>
+          <a:prstGeom prst="ellipse">
+            <a:avLst/>
+          </a:prstGeom>
+          <a:solidFill>
+            <a:srgbClr val="A6650F"/>
+          </a:solidFill>
+          <a:ln/>
+        </p:spPr>
+      </p:sp>
+      <p:sp>
+        <p:nvSpPr>
+          <p:cNvPr id="51" name="Text 46"/>
+          <p:cNvSpPr txBox="1"/>
+          <p:nvPr/>
+        </p:nvSpPr>
+        <p:spPr>
+          <a:xfrm>
+            <a:off x="603504" y="3159252"/>
+            <a:ext cx="5309464" cy="137160"/>
+          </a:xfrm>
+          <a:prstGeom prst="rect">
+            <a:avLst/>
+          </a:prstGeom>
+          <a:noFill/>
+          <a:ln/>
+        </p:spPr>
+        <p:txBody>
+          <a:bodyPr wrap="square" lIns="0" tIns="0" rIns="0" bIns="0" rtlCol="0" anchor="t"/>
+          <a:lstStyle/>
+          <a:p>
+            <a:pPr algn="l" indent="0" marL="0">
+              <a:lnSpc>
+                <a:spcPct val="98000"/>
+              </a:lnSpc>
+              <a:buNone/>
+            </a:pPr>
+            <a:r>
+              <a:rPr lang="en-US" sz="800" dirty="0">
+                <a:solidFill>
+                  <a:srgbClr val="243044"/>
+                </a:solidFill>
+                <a:latin typeface="Calibri" pitchFamily="34" charset="0"/>
+                <a:ea typeface="Calibri" pitchFamily="34" charset="-122"/>
+                <a:cs typeface="Calibri" pitchFamily="34" charset="-120"/>
+              </a:rPr>
+              <a:t>Análisis de Cartera de Tarjeta de Crédito (Acuerdo CA)  </a:t>
+            </a:r>
+            <a:pPr algn="l" indent="0" marL="0">
+              <a:lnSpc>
+                <a:spcPct val="98000"/>
+              </a:lnSpc>
+              <a:buNone/>
+            </a:pPr>
+            <a:r>
+              <a:rPr lang="en-US" sz="800" b="1" dirty="0">
+                <a:solidFill>
+                  <a:srgbClr val="5B6B82"/>
+                </a:solidFill>
+                <a:latin typeface="Calibri" pitchFamily="34" charset="0"/>
+                <a:ea typeface="Calibri" pitchFamily="34" charset="-122"/>
+                <a:cs typeface="Calibri" pitchFamily="34" charset="-120"/>
+              </a:rPr>
+              <a:t>80%</a:t>
+            </a:r>
+            <a:endParaRPr lang="en-US" sz="800" dirty="0"/>
+          </a:p>
+        </p:txBody>
+      </p:sp>
+      <p:sp>
+        <p:nvSpPr>
+          <p:cNvPr id="52" name="Shape 47"/>
+          <p:cNvSpPr/>
+          <p:nvPr/>
+        </p:nvSpPr>
+        <p:spPr>
+          <a:xfrm>
+            <a:off x="365760" y="3557016"/>
+            <a:ext cx="11460175" cy="219456"/>
+          </a:xfrm>
+          <a:prstGeom prst="roundRect">
+            <a:avLst>
+              <a:gd name="adj" fmla="val 20833"/>
+            </a:avLst>
+          </a:prstGeom>
+          <a:solidFill>
+            <a:srgbClr val="1E8449"/>
+          </a:solidFill>
+          <a:ln/>
+        </p:spPr>
+      </p:sp>
+      <p:sp>
+        <p:nvSpPr>
+          <p:cNvPr id="53" name="Text 48"/>
+          <p:cNvSpPr txBox="1"/>
+          <p:nvPr/>
+        </p:nvSpPr>
+        <p:spPr>
+          <a:xfrm>
+            <a:off x="493776" y="3557016"/>
+            <a:ext cx="8716975" cy="219456"/>
+          </a:xfrm>
+          <a:prstGeom prst="rect">
+            <a:avLst/>
+          </a:prstGeom>
+          <a:noFill/>
+          <a:ln/>
+        </p:spPr>
+        <p:txBody>
+          <a:bodyPr wrap="square" lIns="0" tIns="0" rIns="0" bIns="0" rtlCol="0" anchor="ctr"/>
+          <a:lstStyle/>
+          <a:p>
+            <a:pPr algn="l" indent="0" marL="0">
+              <a:buNone/>
+            </a:pPr>
+            <a:r>
+              <a:rPr lang="en-US" sz="1100" b="1" dirty="0">
+                <a:solidFill>
+                  <a:srgbClr val="FFFFFF"/>
+                </a:solidFill>
+                <a:latin typeface="Calibri" pitchFamily="34" charset="0"/>
+                <a:ea typeface="Calibri" pitchFamily="34" charset="-122"/>
+                <a:cs typeface="Calibri" pitchFamily="34" charset="-120"/>
+              </a:rPr>
+              <a:t>Riesgo Regulatorio y Gestión Avalúos</a:t>
+            </a:r>
+            <a:endParaRPr lang="en-US" sz="1100" dirty="0"/>
+          </a:p>
+        </p:txBody>
+      </p:sp>
+      <p:sp>
+        <p:nvSpPr>
+          <p:cNvPr id="54" name="Text 49"/>
+          <p:cNvSpPr txBox="1"/>
+          <p:nvPr/>
+        </p:nvSpPr>
+        <p:spPr>
+          <a:xfrm>
+            <a:off x="9174175" y="3557016"/>
+            <a:ext cx="2523744" cy="219456"/>
+          </a:xfrm>
+          <a:prstGeom prst="rect">
+            <a:avLst/>
+          </a:prstGeom>
+          <a:noFill/>
+          <a:ln/>
+        </p:spPr>
+        <p:txBody>
+          <a:bodyPr wrap="square" lIns="0" tIns="0" rIns="0" bIns="0" rtlCol="0" anchor="ctr"/>
+          <a:lstStyle/>
+          <a:p>
+            <a:pPr algn="r" indent="0" marL="0">
+              <a:buNone/>
+            </a:pPr>
+            <a:r>
+              <a:rPr lang="en-US" sz="800" b="1" dirty="0">
+                <a:solidFill>
+                  <a:srgbClr val="FFFFFF"/>
+                </a:solidFill>
+                <a:latin typeface="Calibri" pitchFamily="34" charset="0"/>
+                <a:ea typeface="Calibri" pitchFamily="34" charset="-122"/>
+                <a:cs typeface="Calibri" pitchFamily="34" charset="-120"/>
+              </a:rPr>
+              <a:t>PLAN DE ACCIÓN · SABAO-DR-10417</a:t>
+            </a:r>
+            <a:endParaRPr lang="en-US" sz="800" dirty="0"/>
+          </a:p>
+        </p:txBody>
+      </p:sp>
+      <p:sp>
+        <p:nvSpPr>
+          <p:cNvPr id="55" name="Shape 50"/>
+          <p:cNvSpPr/>
+          <p:nvPr/>
+        </p:nvSpPr>
+        <p:spPr>
+          <a:xfrm>
+            <a:off x="365760" y="3840480"/>
+            <a:ext cx="11460175" cy="2633472"/>
+          </a:xfrm>
+          <a:prstGeom prst="roundRect">
+            <a:avLst>
+              <a:gd name="adj" fmla="val 2431"/>
+            </a:avLst>
+          </a:prstGeom>
+          <a:solidFill>
+            <a:srgbClr val="FFFFFF"/>
+          </a:solidFill>
+          <a:ln/>
+          <a:effectLst>
+            <a:outerShdw sx="100000" sy="100000" kx="0" ky="0" algn="bl" rotWithShape="0" blurRad="101600" dist="25400" dir="5400000">
+              <a:srgbClr val="0F2F4E">
+                <a:alpha val="22000"/>
+              </a:srgbClr>
+            </a:outerShdw>
+          </a:effectLst>
+        </p:spPr>
+      </p:sp>
+      <p:sp>
+        <p:nvSpPr>
+          <p:cNvPr id="56" name="Shape 51"/>
+          <p:cNvSpPr/>
+          <p:nvPr/>
+        </p:nvSpPr>
+        <p:spPr>
+          <a:xfrm>
+            <a:off x="365760" y="3840480"/>
+            <a:ext cx="11460175" cy="41148"/>
+          </a:xfrm>
+          <a:prstGeom prst="rect">
+            <a:avLst/>
+          </a:prstGeom>
+          <a:solidFill>
+            <a:srgbClr val="1E8449"/>
+          </a:solidFill>
+          <a:ln/>
+        </p:spPr>
+      </p:sp>
+      <p:sp>
+        <p:nvSpPr>
+          <p:cNvPr id="57" name="Text 52"/>
+          <p:cNvSpPr txBox="1"/>
+          <p:nvPr/>
+        </p:nvSpPr>
+        <p:spPr>
+          <a:xfrm>
+            <a:off x="530352" y="3941064"/>
+            <a:ext cx="11130991" cy="182880"/>
+          </a:xfrm>
+          <a:prstGeom prst="rect">
+            <a:avLst/>
+          </a:prstGeom>
+          <a:noFill/>
+          <a:ln/>
+        </p:spPr>
+        <p:txBody>
+          <a:bodyPr wrap="square" lIns="0" tIns="0" rIns="0" bIns="0" rtlCol="0" anchor="t"/>
+          <a:lstStyle/>
+          <a:p>
+            <a:pPr algn="l" indent="0" marL="0">
+              <a:buNone/>
+            </a:pPr>
+            <a:r>
+              <a:rPr lang="en-US" sz="1100" b="1" dirty="0">
+                <a:solidFill>
+                  <a:srgbClr val="17223A"/>
+                </a:solidFill>
+                <a:latin typeface="Calibri" pitchFamily="34" charset="0"/>
+                <a:ea typeface="Calibri" pitchFamily="34" charset="-122"/>
+                <a:cs typeface="Calibri" pitchFamily="34" charset="-120"/>
+              </a:rPr>
+              <a:t>Seguimiento: Visita focalizada</a:t>
+            </a:r>
+            <a:endParaRPr lang="en-US" sz="1100" dirty="0"/>
+          </a:p>
+        </p:txBody>
+      </p:sp>
+      <p:sp>
+        <p:nvSpPr>
+          <p:cNvPr id="58" name="Text 53"/>
+          <p:cNvSpPr txBox="1"/>
+          <p:nvPr/>
+        </p:nvSpPr>
+        <p:spPr>
+          <a:xfrm>
+            <a:off x="530352" y="4123944"/>
+            <a:ext cx="11130991" cy="164592"/>
+          </a:xfrm>
+          <a:prstGeom prst="rect">
+            <a:avLst/>
+          </a:prstGeom>
+          <a:noFill/>
+          <a:ln/>
+        </p:spPr>
+        <p:txBody>
+          <a:bodyPr wrap="square" lIns="0" tIns="0" rIns="0" bIns="0" rtlCol="0" anchor="t"/>
+          <a:lstStyle/>
+          <a:p>
+            <a:pPr algn="l" indent="0" marL="0">
+              <a:buNone/>
+            </a:pPr>
+            <a:r>
+              <a:rPr lang="en-US" sz="800" dirty="0">
+                <a:solidFill>
+                  <a:srgbClr val="5B6B82"/>
+                </a:solidFill>
+                <a:latin typeface="Calibri" pitchFamily="34" charset="0"/>
+                <a:ea typeface="Calibri" pitchFamily="34" charset="-122"/>
+                <a:cs typeface="Calibri" pitchFamily="34" charset="-120"/>
+              </a:rPr>
+              <a:t>Controles de seguridad de la información y ciberseguridad en la plataforma tecnológica · SABAO-DR-10417</a:t>
+            </a:r>
+            <a:endParaRPr lang="en-US" sz="800" dirty="0"/>
+          </a:p>
+        </p:txBody>
+      </p:sp>
+      <p:sp>
+        <p:nvSpPr>
+          <p:cNvPr id="59" name="Shape 54"/>
+          <p:cNvSpPr/>
+          <p:nvPr/>
+        </p:nvSpPr>
+        <p:spPr>
+          <a:xfrm>
+            <a:off x="530352" y="4379976"/>
+            <a:ext cx="2700452" cy="512064"/>
+          </a:xfrm>
+          <a:prstGeom prst="roundRect">
+            <a:avLst>
+              <a:gd name="adj" fmla="val 7143"/>
+            </a:avLst>
+          </a:prstGeom>
+          <a:solidFill>
+            <a:srgbClr val="F7F9FC"/>
+          </a:solidFill>
+          <a:ln w="9525">
+            <a:solidFill>
+              <a:srgbClr val="E7EAF0"/>
+            </a:solidFill>
+            <a:prstDash val="solid"/>
+          </a:ln>
+        </p:spPr>
+      </p:sp>
+      <p:sp>
+        <p:nvSpPr>
+          <p:cNvPr id="60" name="Text 55"/>
+          <p:cNvSpPr txBox="1"/>
+          <p:nvPr/>
+        </p:nvSpPr>
+        <p:spPr>
+          <a:xfrm>
+            <a:off x="621792" y="4416552"/>
+            <a:ext cx="2517572" cy="146304"/>
+          </a:xfrm>
+          <a:prstGeom prst="rect">
+            <a:avLst/>
+          </a:prstGeom>
+          <a:noFill/>
+          <a:ln/>
+        </p:spPr>
+        <p:txBody>
+          <a:bodyPr wrap="square" lIns="0" tIns="0" rIns="0" bIns="0" rtlCol="0" anchor="ctr"/>
+          <a:lstStyle/>
+          <a:p>
+            <a:pPr algn="l" indent="0" marL="0">
+              <a:buNone/>
+            </a:pPr>
+            <a:r>
+              <a:rPr lang="en-US" sz="700" b="1" spc="30" kern="0" dirty="0">
+                <a:solidFill>
+                  <a:srgbClr val="5B6B82"/>
+                </a:solidFill>
+                <a:latin typeface="Calibri" pitchFamily="34" charset="0"/>
+                <a:ea typeface="Calibri" pitchFamily="34" charset="-122"/>
+                <a:cs typeface="Calibri" pitchFamily="34" charset="-120"/>
+              </a:rPr>
+              <a:t>FECHA DE INICIO</a:t>
+            </a:r>
+            <a:endParaRPr lang="en-US" sz="700" dirty="0"/>
+          </a:p>
+        </p:txBody>
+      </p:sp>
+      <p:sp>
+        <p:nvSpPr>
+          <p:cNvPr id="61" name="Text 56"/>
+          <p:cNvSpPr txBox="1"/>
+          <p:nvPr/>
+        </p:nvSpPr>
+        <p:spPr>
+          <a:xfrm>
+            <a:off x="621792" y="4553712"/>
+            <a:ext cx="2517572" cy="219456"/>
+          </a:xfrm>
+          <a:prstGeom prst="rect">
+            <a:avLst/>
+          </a:prstGeom>
+          <a:noFill/>
+          <a:ln/>
+        </p:spPr>
+        <p:txBody>
+          <a:bodyPr wrap="square" lIns="0" tIns="0" rIns="0" bIns="0" rtlCol="0" anchor="t"/>
+          <a:lstStyle/>
+          <a:p>
+            <a:pPr algn="l" indent="0" marL="0">
+              <a:buNone/>
+            </a:pPr>
+            <a:r>
+              <a:rPr lang="en-US" sz="1500" b="1" dirty="0">
+                <a:solidFill>
+                  <a:srgbClr val="17223A"/>
+                </a:solidFill>
+                <a:latin typeface="Calibri" pitchFamily="34" charset="0"/>
+                <a:ea typeface="Calibri" pitchFamily="34" charset="-122"/>
+                <a:cs typeface="Calibri" pitchFamily="34" charset="-120"/>
+              </a:rPr>
+              <a:t>26/04/2024</a:t>
+            </a:r>
+            <a:endParaRPr lang="en-US" sz="1500" dirty="0"/>
+          </a:p>
+        </p:txBody>
+      </p:sp>
+      <p:sp>
+        <p:nvSpPr>
+          <p:cNvPr id="62" name="Shape 57"/>
+          <p:cNvSpPr/>
+          <p:nvPr/>
+        </p:nvSpPr>
+        <p:spPr>
+          <a:xfrm>
+            <a:off x="3340532" y="4379976"/>
+            <a:ext cx="2700452" cy="512064"/>
+          </a:xfrm>
+          <a:prstGeom prst="roundRect">
+            <a:avLst>
+              <a:gd name="adj" fmla="val 7143"/>
+            </a:avLst>
+          </a:prstGeom>
+          <a:solidFill>
+            <a:srgbClr val="F7F9FC"/>
+          </a:solidFill>
+          <a:ln w="9525">
+            <a:solidFill>
+              <a:srgbClr val="E7EAF0"/>
+            </a:solidFill>
+            <a:prstDash val="solid"/>
+          </a:ln>
+        </p:spPr>
+      </p:sp>
+      <p:sp>
+        <p:nvSpPr>
+          <p:cNvPr id="63" name="Text 58"/>
+          <p:cNvSpPr txBox="1"/>
+          <p:nvPr/>
+        </p:nvSpPr>
+        <p:spPr>
+          <a:xfrm>
+            <a:off x="3431972" y="4416552"/>
+            <a:ext cx="2517572" cy="146304"/>
+          </a:xfrm>
+          <a:prstGeom prst="rect">
+            <a:avLst/>
+          </a:prstGeom>
+          <a:noFill/>
+          <a:ln/>
+        </p:spPr>
+        <p:txBody>
+          <a:bodyPr wrap="square" lIns="0" tIns="0" rIns="0" bIns="0" rtlCol="0" anchor="ctr"/>
+          <a:lstStyle/>
+          <a:p>
+            <a:pPr algn="l" indent="0" marL="0">
+              <a:buNone/>
+            </a:pPr>
+            <a:r>
+              <a:rPr lang="en-US" sz="700" b="1" spc="30" kern="0" dirty="0">
+                <a:solidFill>
+                  <a:srgbClr val="5B6B82"/>
+                </a:solidFill>
+                <a:latin typeface="Calibri" pitchFamily="34" charset="0"/>
+                <a:ea typeface="Calibri" pitchFamily="34" charset="-122"/>
+                <a:cs typeface="Calibri" pitchFamily="34" charset="-120"/>
+              </a:rPr>
+              <a:t>SALIDA Y FIRMA DE ACTA</a:t>
+            </a:r>
+            <a:endParaRPr lang="en-US" sz="700" dirty="0"/>
+          </a:p>
+        </p:txBody>
+      </p:sp>
+      <p:sp>
+        <p:nvSpPr>
+          <p:cNvPr id="64" name="Text 59"/>
+          <p:cNvSpPr txBox="1"/>
+          <p:nvPr/>
+        </p:nvSpPr>
+        <p:spPr>
+          <a:xfrm>
+            <a:off x="3431972" y="4553712"/>
+            <a:ext cx="2517572" cy="219456"/>
+          </a:xfrm>
+          <a:prstGeom prst="rect">
+            <a:avLst/>
+          </a:prstGeom>
+          <a:noFill/>
+          <a:ln/>
+        </p:spPr>
+        <p:txBody>
+          <a:bodyPr wrap="square" lIns="0" tIns="0" rIns="0" bIns="0" rtlCol="0" anchor="t"/>
+          <a:lstStyle/>
+          <a:p>
+            <a:pPr algn="l" indent="0" marL="0">
+              <a:buNone/>
+            </a:pPr>
+            <a:r>
+              <a:rPr lang="en-US" sz="1500" b="1" dirty="0">
+                <a:solidFill>
+                  <a:srgbClr val="C0392B"/>
+                </a:solidFill>
+                <a:latin typeface="Calibri" pitchFamily="34" charset="0"/>
+                <a:ea typeface="Calibri" pitchFamily="34" charset="-122"/>
+                <a:cs typeface="Calibri" pitchFamily="34" charset="-120"/>
+              </a:rPr>
+              <a:t>27/02/2025</a:t>
+            </a:r>
+            <a:endParaRPr lang="en-US" sz="1500" dirty="0"/>
+          </a:p>
+        </p:txBody>
+      </p:sp>
+      <p:sp>
+        <p:nvSpPr>
+          <p:cNvPr id="65" name="Shape 60"/>
+          <p:cNvSpPr/>
+          <p:nvPr/>
+        </p:nvSpPr>
+        <p:spPr>
+          <a:xfrm>
+            <a:off x="6150712" y="4379976"/>
+            <a:ext cx="2700452" cy="512064"/>
+          </a:xfrm>
+          <a:prstGeom prst="roundRect">
+            <a:avLst>
+              <a:gd name="adj" fmla="val 7143"/>
+            </a:avLst>
+          </a:prstGeom>
+          <a:solidFill>
+            <a:srgbClr val="F7F9FC"/>
+          </a:solidFill>
+          <a:ln w="9525">
+            <a:solidFill>
+              <a:srgbClr val="E7EAF0"/>
+            </a:solidFill>
+            <a:prstDash val="solid"/>
+          </a:ln>
+        </p:spPr>
+      </p:sp>
+      <p:sp>
+        <p:nvSpPr>
+          <p:cNvPr id="66" name="Text 61"/>
+          <p:cNvSpPr txBox="1"/>
+          <p:nvPr/>
+        </p:nvSpPr>
+        <p:spPr>
+          <a:xfrm>
+            <a:off x="6242152" y="4416552"/>
+            <a:ext cx="2517572" cy="146304"/>
+          </a:xfrm>
+          <a:prstGeom prst="rect">
+            <a:avLst/>
+          </a:prstGeom>
+          <a:noFill/>
+          <a:ln/>
+        </p:spPr>
+        <p:txBody>
+          <a:bodyPr wrap="square" lIns="0" tIns="0" rIns="0" bIns="0" rtlCol="0" anchor="ctr"/>
+          <a:lstStyle/>
+          <a:p>
+            <a:pPr algn="l" indent="0" marL="0">
+              <a:buNone/>
+            </a:pPr>
+            <a:r>
+              <a:rPr lang="en-US" sz="700" b="1" spc="30" kern="0" dirty="0">
+                <a:solidFill>
+                  <a:srgbClr val="5B6B82"/>
+                </a:solidFill>
+                <a:latin typeface="Calibri" pitchFamily="34" charset="0"/>
+                <a:ea typeface="Calibri" pitchFamily="34" charset="-122"/>
+                <a:cs typeface="Calibri" pitchFamily="34" charset="-120"/>
+              </a:rPr>
+              <a:t>TOTAL DE REQUERIMIENTOS</a:t>
+            </a:r>
+            <a:endParaRPr lang="en-US" sz="700" dirty="0"/>
+          </a:p>
+        </p:txBody>
+      </p:sp>
+      <p:sp>
+        <p:nvSpPr>
+          <p:cNvPr id="67" name="Text 62"/>
+          <p:cNvSpPr txBox="1"/>
+          <p:nvPr/>
+        </p:nvSpPr>
+        <p:spPr>
+          <a:xfrm>
+            <a:off x="6242152" y="4553712"/>
+            <a:ext cx="2517572" cy="219456"/>
+          </a:xfrm>
+          <a:prstGeom prst="rect">
+            <a:avLst/>
+          </a:prstGeom>
+          <a:noFill/>
+          <a:ln/>
+        </p:spPr>
+        <p:txBody>
+          <a:bodyPr wrap="square" lIns="0" tIns="0" rIns="0" bIns="0" rtlCol="0" anchor="t"/>
+          <a:lstStyle/>
+          <a:p>
+            <a:pPr algn="l" indent="0" marL="0">
+              <a:buNone/>
+            </a:pPr>
+            <a:r>
+              <a:rPr lang="en-US" sz="1500" b="1" dirty="0">
+                <a:solidFill>
+                  <a:srgbClr val="17223A"/>
+                </a:solidFill>
+                <a:latin typeface="Calibri" pitchFamily="34" charset="0"/>
+                <a:ea typeface="Calibri" pitchFamily="34" charset="-122"/>
+                <a:cs typeface="Calibri" pitchFamily="34" charset="-120"/>
+              </a:rPr>
+              <a:t>11</a:t>
+            </a:r>
+            <a:pPr algn="l" indent="0" marL="0">
+              <a:buNone/>
+            </a:pPr>
+            <a:r>
+              <a:rPr lang="en-US" sz="900" dirty="0">
+                <a:solidFill>
+                  <a:srgbClr val="5B6B82"/>
+                </a:solidFill>
+                <a:latin typeface="Calibri" pitchFamily="34" charset="0"/>
+                <a:ea typeface="Calibri" pitchFamily="34" charset="-122"/>
+                <a:cs typeface="Calibri" pitchFamily="34" charset="-120"/>
+              </a:rPr>
+              <a:t>  puntos</a:t>
+            </a:r>
+            <a:endParaRPr lang="en-US" sz="1500" dirty="0"/>
+          </a:p>
+        </p:txBody>
+      </p:sp>
+      <p:sp>
+        <p:nvSpPr>
+          <p:cNvPr id="68" name="Shape 63"/>
+          <p:cNvSpPr/>
+          <p:nvPr/>
+        </p:nvSpPr>
+        <p:spPr>
+          <a:xfrm>
+            <a:off x="8960891" y="4379976"/>
+            <a:ext cx="2700452" cy="512064"/>
+          </a:xfrm>
+          <a:prstGeom prst="roundRect">
+            <a:avLst>
+              <a:gd name="adj" fmla="val 7143"/>
+            </a:avLst>
+          </a:prstGeom>
+          <a:solidFill>
+            <a:srgbClr val="F7F9FC"/>
+          </a:solidFill>
+          <a:ln w="9525">
+            <a:solidFill>
+              <a:srgbClr val="E7EAF0"/>
+            </a:solidFill>
+            <a:prstDash val="solid"/>
+          </a:ln>
+        </p:spPr>
+      </p:sp>
+      <p:sp>
+        <p:nvSpPr>
+          <p:cNvPr id="69" name="Text 64"/>
+          <p:cNvSpPr txBox="1"/>
+          <p:nvPr/>
+        </p:nvSpPr>
+        <p:spPr>
+          <a:xfrm>
+            <a:off x="9052331" y="4416552"/>
+            <a:ext cx="2517572" cy="146304"/>
+          </a:xfrm>
+          <a:prstGeom prst="rect">
+            <a:avLst/>
+          </a:prstGeom>
+          <a:noFill/>
+          <a:ln/>
+        </p:spPr>
+        <p:txBody>
+          <a:bodyPr wrap="square" lIns="0" tIns="0" rIns="0" bIns="0" rtlCol="0" anchor="ctr"/>
+          <a:lstStyle/>
+          <a:p>
+            <a:pPr algn="l" indent="0" marL="0">
+              <a:buNone/>
+            </a:pPr>
+            <a:r>
+              <a:rPr lang="en-US" sz="700" b="1" spc="30" kern="0" dirty="0">
+                <a:solidFill>
+                  <a:srgbClr val="5B6B82"/>
+                </a:solidFill>
+                <a:latin typeface="Calibri" pitchFamily="34" charset="0"/>
+                <a:ea typeface="Calibri" pitchFamily="34" charset="-122"/>
+                <a:cs typeface="Calibri" pitchFamily="34" charset="-120"/>
+              </a:rPr>
+              <a:t>OBSERVACIONES REGISTRADAS</a:t>
+            </a:r>
+            <a:endParaRPr lang="en-US" sz="700" dirty="0"/>
+          </a:p>
+        </p:txBody>
+      </p:sp>
+      <p:sp>
+        <p:nvSpPr>
+          <p:cNvPr id="70" name="Text 65"/>
+          <p:cNvSpPr txBox="1"/>
+          <p:nvPr/>
+        </p:nvSpPr>
+        <p:spPr>
+          <a:xfrm>
+            <a:off x="9052331" y="4553712"/>
+            <a:ext cx="2517572" cy="219456"/>
+          </a:xfrm>
+          <a:prstGeom prst="rect">
+            <a:avLst/>
+          </a:prstGeom>
+          <a:noFill/>
+          <a:ln/>
+        </p:spPr>
+        <p:txBody>
+          <a:bodyPr wrap="square" lIns="0" tIns="0" rIns="0" bIns="0" rtlCol="0" anchor="t"/>
+          <a:lstStyle/>
+          <a:p>
+            <a:pPr algn="l" indent="0" marL="0">
+              <a:buNone/>
+            </a:pPr>
+            <a:r>
+              <a:rPr lang="en-US" sz="1500" b="1" dirty="0">
+                <a:solidFill>
+                  <a:srgbClr val="17223A"/>
+                </a:solidFill>
+                <a:latin typeface="Calibri" pitchFamily="34" charset="0"/>
+                <a:ea typeface="Calibri" pitchFamily="34" charset="-122"/>
+                <a:cs typeface="Calibri" pitchFamily="34" charset="-120"/>
+              </a:rPr>
+              <a:t>7</a:t>
+            </a:r>
+            <a:pPr algn="l" indent="0" marL="0">
+              <a:buNone/>
+            </a:pPr>
+            <a:r>
+              <a:rPr lang="en-US" sz="900" dirty="0">
+                <a:solidFill>
+                  <a:srgbClr val="5B6B82"/>
+                </a:solidFill>
+                <a:latin typeface="Calibri" pitchFamily="34" charset="0"/>
+                <a:ea typeface="Calibri" pitchFamily="34" charset="-122"/>
+                <a:cs typeface="Calibri" pitchFamily="34" charset="-120"/>
+              </a:rPr>
+              <a:t>  obs.</a:t>
+            </a:r>
+            <a:endParaRPr lang="en-US" sz="1500" dirty="0"/>
+          </a:p>
+        </p:txBody>
+      </p:sp>
+      <p:sp>
+        <p:nvSpPr>
+          <p:cNvPr id="71" name="Text 66"/>
+          <p:cNvSpPr txBox="1"/>
+          <p:nvPr/>
+        </p:nvSpPr>
+        <p:spPr>
+          <a:xfrm>
+            <a:off x="530352" y="4992624"/>
+            <a:ext cx="2377440" cy="182880"/>
+          </a:xfrm>
+          <a:prstGeom prst="rect">
+            <a:avLst/>
+          </a:prstGeom>
+          <a:noFill/>
+          <a:ln/>
+        </p:spPr>
+        <p:txBody>
+          <a:bodyPr wrap="square" lIns="0" tIns="0" rIns="0" bIns="0" rtlCol="0" anchor="ctr"/>
+          <a:lstStyle/>
+          <a:p>
+            <a:pPr algn="l" indent="0" marL="0">
+              <a:buNone/>
+            </a:pPr>
+            <a:r>
+              <a:rPr lang="en-US" sz="950" dirty="0">
+                <a:solidFill>
+                  <a:srgbClr val="243044"/>
+                </a:solidFill>
+                <a:latin typeface="Calibri" pitchFamily="34" charset="0"/>
+                <a:ea typeface="Calibri" pitchFamily="34" charset="-122"/>
+                <a:cs typeface="Calibri" pitchFamily="34" charset="-120"/>
+              </a:rPr>
+              <a:t>Informe preliminar </a:t>
+            </a:r>
+            <a:pPr algn="l" indent="0" marL="0">
+              <a:buNone/>
+            </a:pPr>
+            <a:r>
+              <a:rPr lang="en-US" sz="950" b="1" dirty="0">
+                <a:solidFill>
+                  <a:srgbClr val="17223A"/>
+                </a:solidFill>
+                <a:latin typeface="Calibri" pitchFamily="34" charset="0"/>
+                <a:ea typeface="Calibri" pitchFamily="34" charset="-122"/>
+                <a:cs typeface="Calibri" pitchFamily="34" charset="-120"/>
+              </a:rPr>
+              <a:t>DS-DR-9005</a:t>
+            </a:r>
+            <a:endParaRPr lang="en-US" sz="950" dirty="0"/>
+          </a:p>
+        </p:txBody>
+      </p:sp>
+      <p:sp>
+        <p:nvSpPr>
+          <p:cNvPr id="72" name="Shape 67"/>
+          <p:cNvSpPr/>
+          <p:nvPr/>
+        </p:nvSpPr>
+        <p:spPr>
+          <a:xfrm>
+            <a:off x="2953512" y="4992624"/>
+            <a:ext cx="1645920" cy="182880"/>
+          </a:xfrm>
+          <a:prstGeom prst="roundRect">
+            <a:avLst>
+              <a:gd name="adj" fmla="val 50000"/>
+            </a:avLst>
+          </a:prstGeom>
+          <a:solidFill>
+            <a:srgbClr val="E4F5EA"/>
+          </a:solidFill>
+          <a:ln/>
+        </p:spPr>
+      </p:sp>
+      <p:sp>
+        <p:nvSpPr>
+          <p:cNvPr id="73" name="Text 68"/>
+          <p:cNvSpPr txBox="1"/>
+          <p:nvPr/>
+        </p:nvSpPr>
+        <p:spPr>
+          <a:xfrm>
+            <a:off x="2953512" y="4992624"/>
+            <a:ext cx="1645920" cy="182880"/>
+          </a:xfrm>
+          <a:prstGeom prst="rect">
+            <a:avLst/>
+          </a:prstGeom>
+          <a:noFill/>
+          <a:ln/>
+        </p:spPr>
+        <p:txBody>
+          <a:bodyPr wrap="square" lIns="0" tIns="0" rIns="0" bIns="0" rtlCol="0" anchor="ctr"/>
+          <a:lstStyle/>
+          <a:p>
+            <a:pPr algn="ctr" indent="0" marL="0">
+              <a:buNone/>
+            </a:pPr>
+            <a:r>
+              <a:rPr lang="en-US" sz="850" b="1" dirty="0">
+                <a:solidFill>
+                  <a:srgbClr val="1E8449"/>
+                </a:solidFill>
+                <a:latin typeface="Calibri" pitchFamily="34" charset="0"/>
+                <a:ea typeface="Calibri" pitchFamily="34" charset="-122"/>
+                <a:cs typeface="Calibri" pitchFamily="34" charset="-120"/>
+              </a:rPr>
+              <a:t>✓ Respondido · Descargo</a:t>
+            </a:r>
+            <a:endParaRPr lang="en-US" sz="850" dirty="0"/>
+          </a:p>
+        </p:txBody>
+      </p:sp>
+      <p:sp>
+        <p:nvSpPr>
+          <p:cNvPr id="74" name="Shape 69"/>
+          <p:cNvSpPr/>
+          <p:nvPr/>
+        </p:nvSpPr>
+        <p:spPr>
+          <a:xfrm>
+            <a:off x="4690872" y="4992624"/>
+            <a:ext cx="1645920" cy="182880"/>
+          </a:xfrm>
+          <a:prstGeom prst="roundRect">
+            <a:avLst>
+              <a:gd name="adj" fmla="val 50000"/>
+            </a:avLst>
+          </a:prstGeom>
+          <a:solidFill>
+            <a:srgbClr val="E7ECF3"/>
+          </a:solidFill>
+          <a:ln/>
+        </p:spPr>
+      </p:sp>
+      <p:sp>
+        <p:nvSpPr>
+          <p:cNvPr id="75" name="Text 70"/>
+          <p:cNvSpPr txBox="1"/>
+          <p:nvPr/>
+        </p:nvSpPr>
+        <p:spPr>
+          <a:xfrm>
+            <a:off x="4690872" y="4992624"/>
+            <a:ext cx="1645920" cy="182880"/>
+          </a:xfrm>
+          <a:prstGeom prst="rect">
+            <a:avLst/>
+          </a:prstGeom>
+          <a:noFill/>
+          <a:ln/>
+        </p:spPr>
+        <p:txBody>
+          <a:bodyPr wrap="square" lIns="0" tIns="0" rIns="0" bIns="0" rtlCol="0" anchor="ctr"/>
+          <a:lstStyle/>
+          <a:p>
+            <a:pPr algn="ctr" indent="0" marL="0">
+              <a:buNone/>
+            </a:pPr>
+            <a:r>
+              <a:rPr lang="en-US" sz="850" b="1" dirty="0">
+                <a:solidFill>
+                  <a:srgbClr val="46586E"/>
+                </a:solidFill>
+                <a:latin typeface="Calibri" pitchFamily="34" charset="0"/>
+                <a:ea typeface="Calibri" pitchFamily="34" charset="-122"/>
+                <a:cs typeface="Calibri" pitchFamily="34" charset="-120"/>
+              </a:rPr>
+              <a:t>Informe final: Pendiente</a:t>
+            </a:r>
+            <a:endParaRPr lang="en-US" sz="850" dirty="0"/>
+          </a:p>
+        </p:txBody>
+      </p:sp>
+      <p:sp>
+        <p:nvSpPr>
+          <p:cNvPr id="76" name="Shape 71"/>
+          <p:cNvSpPr/>
+          <p:nvPr/>
+        </p:nvSpPr>
+        <p:spPr>
+          <a:xfrm>
+            <a:off x="1593159" y="5285232"/>
+            <a:ext cx="100584" cy="100584"/>
+          </a:xfrm>
+          <a:prstGeom prst="ellipse">
+            <a:avLst/>
+          </a:prstGeom>
+          <a:solidFill>
+            <a:srgbClr val="1D63A1"/>
+          </a:solidFill>
+          <a:ln w="19050">
+            <a:solidFill>
+              <a:srgbClr val="FFFFFF"/>
+            </a:solidFill>
+            <a:prstDash val="solid"/>
+          </a:ln>
+        </p:spPr>
+      </p:sp>
+      <p:sp>
+        <p:nvSpPr>
+          <p:cNvPr id="77" name="Text 72"/>
+          <p:cNvSpPr txBox="1"/>
+          <p:nvPr/>
+        </p:nvSpPr>
+        <p:spPr>
+          <a:xfrm>
+            <a:off x="530352" y="5422392"/>
+            <a:ext cx="2226198" cy="146304"/>
+          </a:xfrm>
+          <a:prstGeom prst="rect">
+            <a:avLst/>
+          </a:prstGeom>
+          <a:noFill/>
+          <a:ln/>
+        </p:spPr>
+        <p:txBody>
+          <a:bodyPr wrap="square" lIns="0" tIns="0" rIns="0" bIns="0" rtlCol="0" anchor="t"/>
+          <a:lstStyle/>
+          <a:p>
+            <a:pPr algn="ctr" indent="0" marL="0">
+              <a:buNone/>
+            </a:pPr>
+            <a:r>
+              <a:rPr lang="en-US" sz="850" b="1" dirty="0">
+                <a:solidFill>
+                  <a:srgbClr val="17223A"/>
+                </a:solidFill>
+                <a:latin typeface="Calibri" pitchFamily="34" charset="0"/>
+                <a:ea typeface="Calibri" pitchFamily="34" charset="-122"/>
+                <a:cs typeface="Calibri" pitchFamily="34" charset="-120"/>
+              </a:rPr>
+              <a:t>26/04/2024</a:t>
+            </a:r>
+            <a:endParaRPr lang="en-US" sz="850" dirty="0"/>
+          </a:p>
+        </p:txBody>
+      </p:sp>
+      <p:sp>
+        <p:nvSpPr>
+          <p:cNvPr id="78" name="Text 73"/>
+          <p:cNvSpPr txBox="1"/>
+          <p:nvPr/>
+        </p:nvSpPr>
+        <p:spPr>
+          <a:xfrm>
+            <a:off x="566928" y="5568696"/>
+            <a:ext cx="2153046" cy="292608"/>
+          </a:xfrm>
+          <a:prstGeom prst="rect">
+            <a:avLst/>
+          </a:prstGeom>
+          <a:noFill/>
+          <a:ln/>
+        </p:spPr>
+        <p:txBody>
+          <a:bodyPr wrap="square" lIns="0" tIns="0" rIns="0" bIns="0" rtlCol="0" anchor="t"/>
+          <a:lstStyle/>
+          <a:p>
+            <a:pPr algn="ctr" indent="0" marL="0">
+              <a:lnSpc>
+                <a:spcPct val="105000"/>
+              </a:lnSpc>
+              <a:buNone/>
+            </a:pPr>
+            <a:r>
+              <a:rPr lang="en-US" sz="700" dirty="0">
+                <a:solidFill>
+                  <a:srgbClr val="5B6B82"/>
+                </a:solidFill>
+                <a:latin typeface="Calibri" pitchFamily="34" charset="0"/>
+                <a:ea typeface="Calibri" pitchFamily="34" charset="-122"/>
+                <a:cs typeface="Calibri" pitchFamily="34" charset="-120"/>
+              </a:rPr>
+              <a:t>Inicio de visita y requerimiento</a:t>
+            </a:r>
+            <a:endParaRPr lang="en-US" sz="700" dirty="0"/>
+          </a:p>
+        </p:txBody>
+      </p:sp>
+      <p:sp>
+        <p:nvSpPr>
+          <p:cNvPr id="79" name="Shape 74"/>
+          <p:cNvSpPr/>
+          <p:nvPr/>
+        </p:nvSpPr>
+        <p:spPr>
+          <a:xfrm>
+            <a:off x="1643451" y="5328209"/>
+            <a:ext cx="2226198" cy="14630"/>
+          </a:xfrm>
+          <a:prstGeom prst="rect">
+            <a:avLst/>
+          </a:prstGeom>
+          <a:solidFill>
+            <a:srgbClr val="DCE3EC"/>
+          </a:solidFill>
+          <a:ln/>
+        </p:spPr>
+      </p:sp>
+      <p:sp>
+        <p:nvSpPr>
+          <p:cNvPr id="80" name="Shape 75"/>
+          <p:cNvSpPr/>
+          <p:nvPr/>
+        </p:nvSpPr>
+        <p:spPr>
+          <a:xfrm>
+            <a:off x="3819357" y="5285232"/>
+            <a:ext cx="100584" cy="100584"/>
+          </a:xfrm>
+          <a:prstGeom prst="ellipse">
+            <a:avLst/>
+          </a:prstGeom>
+          <a:solidFill>
+            <a:srgbClr val="133B6C"/>
+          </a:solidFill>
+          <a:ln w="19050">
+            <a:solidFill>
+              <a:srgbClr val="FFFFFF"/>
+            </a:solidFill>
+            <a:prstDash val="solid"/>
+          </a:ln>
+        </p:spPr>
+      </p:sp>
+      <p:sp>
+        <p:nvSpPr>
+          <p:cNvPr id="81" name="Text 76"/>
+          <p:cNvSpPr txBox="1"/>
+          <p:nvPr/>
+        </p:nvSpPr>
+        <p:spPr>
+          <a:xfrm>
+            <a:off x="2756550" y="5422392"/>
+            <a:ext cx="2226198" cy="146304"/>
+          </a:xfrm>
+          <a:prstGeom prst="rect">
+            <a:avLst/>
+          </a:prstGeom>
+          <a:noFill/>
+          <a:ln/>
+        </p:spPr>
+        <p:txBody>
+          <a:bodyPr wrap="square" lIns="0" tIns="0" rIns="0" bIns="0" rtlCol="0" anchor="t"/>
+          <a:lstStyle/>
+          <a:p>
+            <a:pPr algn="ctr" indent="0" marL="0">
+              <a:buNone/>
+            </a:pPr>
+            <a:r>
+              <a:rPr lang="en-US" sz="850" b="1" dirty="0">
+                <a:solidFill>
+                  <a:srgbClr val="17223A"/>
+                </a:solidFill>
+                <a:latin typeface="Calibri" pitchFamily="34" charset="0"/>
+                <a:ea typeface="Calibri" pitchFamily="34" charset="-122"/>
+                <a:cs typeface="Calibri" pitchFamily="34" charset="-120"/>
+              </a:rPr>
+              <a:t>27/02/2025</a:t>
+            </a:r>
+            <a:endParaRPr lang="en-US" sz="850" dirty="0"/>
+          </a:p>
+        </p:txBody>
+      </p:sp>
+      <p:sp>
+        <p:nvSpPr>
+          <p:cNvPr id="82" name="Text 77"/>
+          <p:cNvSpPr txBox="1"/>
+          <p:nvPr/>
+        </p:nvSpPr>
+        <p:spPr>
+          <a:xfrm>
+            <a:off x="2793126" y="5568696"/>
+            <a:ext cx="2153046" cy="292608"/>
+          </a:xfrm>
+          <a:prstGeom prst="rect">
+            <a:avLst/>
+          </a:prstGeom>
+          <a:noFill/>
+          <a:ln/>
+        </p:spPr>
+        <p:txBody>
+          <a:bodyPr wrap="square" lIns="0" tIns="0" rIns="0" bIns="0" rtlCol="0" anchor="t"/>
+          <a:lstStyle/>
+          <a:p>
+            <a:pPr algn="ctr" indent="0" marL="0">
+              <a:lnSpc>
+                <a:spcPct val="105000"/>
+              </a:lnSpc>
+              <a:buNone/>
+            </a:pPr>
+            <a:r>
+              <a:rPr lang="en-US" sz="700" dirty="0">
+                <a:solidFill>
+                  <a:srgbClr val="5B6B82"/>
+                </a:solidFill>
+                <a:latin typeface="Calibri" pitchFamily="34" charset="0"/>
+                <a:ea typeface="Calibri" pitchFamily="34" charset="-122"/>
+                <a:cs typeface="Calibri" pitchFamily="34" charset="-120"/>
+              </a:rPr>
+              <a:t>Salida y firma de acta</a:t>
+            </a:r>
+            <a:endParaRPr lang="en-US" sz="700" dirty="0"/>
+          </a:p>
+        </p:txBody>
+      </p:sp>
+      <p:sp>
+        <p:nvSpPr>
+          <p:cNvPr id="83" name="Shape 78"/>
+          <p:cNvSpPr/>
+          <p:nvPr/>
+        </p:nvSpPr>
+        <p:spPr>
+          <a:xfrm>
+            <a:off x="3869649" y="5328209"/>
+            <a:ext cx="2226198" cy="14630"/>
+          </a:xfrm>
+          <a:prstGeom prst="rect">
+            <a:avLst/>
+          </a:prstGeom>
+          <a:solidFill>
+            <a:srgbClr val="DCE3EC"/>
+          </a:solidFill>
+          <a:ln/>
+        </p:spPr>
+      </p:sp>
+      <p:sp>
+        <p:nvSpPr>
+          <p:cNvPr id="84" name="Shape 79"/>
+          <p:cNvSpPr/>
+          <p:nvPr/>
+        </p:nvSpPr>
+        <p:spPr>
+          <a:xfrm>
+            <a:off x="6045556" y="5285232"/>
+            <a:ext cx="100584" cy="100584"/>
+          </a:xfrm>
+          <a:prstGeom prst="ellipse">
+            <a:avLst/>
+          </a:prstGeom>
+          <a:solidFill>
+            <a:srgbClr val="A6650F"/>
+          </a:solidFill>
+          <a:ln w="19050">
+            <a:solidFill>
+              <a:srgbClr val="FFFFFF"/>
+            </a:solidFill>
+            <a:prstDash val="solid"/>
+          </a:ln>
+        </p:spPr>
+      </p:sp>
+      <p:sp>
+        <p:nvSpPr>
+          <p:cNvPr id="85" name="Text 80"/>
+          <p:cNvSpPr txBox="1"/>
+          <p:nvPr/>
+        </p:nvSpPr>
+        <p:spPr>
+          <a:xfrm>
+            <a:off x="4982748" y="5422392"/>
+            <a:ext cx="2226198" cy="146304"/>
+          </a:xfrm>
+          <a:prstGeom prst="rect">
+            <a:avLst/>
+          </a:prstGeom>
+          <a:noFill/>
+          <a:ln/>
+        </p:spPr>
+        <p:txBody>
+          <a:bodyPr wrap="square" lIns="0" tIns="0" rIns="0" bIns="0" rtlCol="0" anchor="t"/>
+          <a:lstStyle/>
+          <a:p>
+            <a:pPr algn="ctr" indent="0" marL="0">
+              <a:buNone/>
+            </a:pPr>
+            <a:r>
+              <a:rPr lang="en-US" sz="850" b="1" dirty="0">
+                <a:solidFill>
+                  <a:srgbClr val="17223A"/>
+                </a:solidFill>
+                <a:latin typeface="Calibri" pitchFamily="34" charset="0"/>
+                <a:ea typeface="Calibri" pitchFamily="34" charset="-122"/>
+                <a:cs typeface="Calibri" pitchFamily="34" charset="-120"/>
+              </a:rPr>
+              <a:t>08/04/2025</a:t>
+            </a:r>
+            <a:endParaRPr lang="en-US" sz="850" dirty="0"/>
+          </a:p>
+        </p:txBody>
+      </p:sp>
+      <p:sp>
+        <p:nvSpPr>
+          <p:cNvPr id="86" name="Text 81"/>
+          <p:cNvSpPr txBox="1"/>
+          <p:nvPr/>
+        </p:nvSpPr>
+        <p:spPr>
+          <a:xfrm>
+            <a:off x="5019324" y="5568696"/>
+            <a:ext cx="2153046" cy="292608"/>
+          </a:xfrm>
+          <a:prstGeom prst="rect">
+            <a:avLst/>
+          </a:prstGeom>
+          <a:noFill/>
+          <a:ln/>
+        </p:spPr>
+        <p:txBody>
+          <a:bodyPr wrap="square" lIns="0" tIns="0" rIns="0" bIns="0" rtlCol="0" anchor="t"/>
+          <a:lstStyle/>
+          <a:p>
+            <a:pPr algn="ctr" indent="0" marL="0">
+              <a:lnSpc>
+                <a:spcPct val="105000"/>
+              </a:lnSpc>
+              <a:buNone/>
+            </a:pPr>
+            <a:r>
+              <a:rPr lang="en-US" sz="700" dirty="0">
+                <a:solidFill>
+                  <a:srgbClr val="5B6B82"/>
+                </a:solidFill>
+                <a:latin typeface="Calibri" pitchFamily="34" charset="0"/>
+                <a:ea typeface="Calibri" pitchFamily="34" charset="-122"/>
+                <a:cs typeface="Calibri" pitchFamily="34" charset="-120"/>
+              </a:rPr>
+              <a:t>Recepción del informe preliminar</a:t>
+            </a:r>
+            <a:endParaRPr lang="en-US" sz="700" dirty="0"/>
+          </a:p>
+        </p:txBody>
+      </p:sp>
+      <p:sp>
+        <p:nvSpPr>
+          <p:cNvPr id="87" name="Shape 82"/>
+          <p:cNvSpPr/>
+          <p:nvPr/>
+        </p:nvSpPr>
+        <p:spPr>
+          <a:xfrm>
+            <a:off x="6095848" y="5328209"/>
+            <a:ext cx="2226198" cy="14630"/>
+          </a:xfrm>
+          <a:prstGeom prst="rect">
+            <a:avLst/>
+          </a:prstGeom>
+          <a:solidFill>
+            <a:srgbClr val="DCE3EC"/>
+          </a:solidFill>
+          <a:ln/>
+        </p:spPr>
+      </p:sp>
+      <p:sp>
+        <p:nvSpPr>
+          <p:cNvPr id="88" name="Shape 83"/>
+          <p:cNvSpPr/>
+          <p:nvPr/>
+        </p:nvSpPr>
+        <p:spPr>
+          <a:xfrm>
+            <a:off x="8271754" y="5285232"/>
+            <a:ext cx="100584" cy="100584"/>
+          </a:xfrm>
+          <a:prstGeom prst="ellipse">
+            <a:avLst/>
+          </a:prstGeom>
+          <a:solidFill>
+            <a:srgbClr val="1E8449"/>
+          </a:solidFill>
+          <a:ln w="19050">
+            <a:solidFill>
+              <a:srgbClr val="FFFFFF"/>
+            </a:solidFill>
+            <a:prstDash val="solid"/>
+          </a:ln>
+        </p:spPr>
+      </p:sp>
+      <p:sp>
+        <p:nvSpPr>
+          <p:cNvPr id="89" name="Text 84"/>
+          <p:cNvSpPr txBox="1"/>
+          <p:nvPr/>
+        </p:nvSpPr>
+        <p:spPr>
+          <a:xfrm>
+            <a:off x="7208947" y="5422392"/>
+            <a:ext cx="2226198" cy="146304"/>
+          </a:xfrm>
+          <a:prstGeom prst="rect">
+            <a:avLst/>
+          </a:prstGeom>
+          <a:noFill/>
+          <a:ln/>
+        </p:spPr>
+        <p:txBody>
+          <a:bodyPr wrap="square" lIns="0" tIns="0" rIns="0" bIns="0" rtlCol="0" anchor="t"/>
+          <a:lstStyle/>
+          <a:p>
+            <a:pPr algn="ctr" indent="0" marL="0">
+              <a:buNone/>
+            </a:pPr>
+            <a:r>
+              <a:rPr lang="en-US" sz="850" b="1" dirty="0">
+                <a:solidFill>
+                  <a:srgbClr val="17223A"/>
+                </a:solidFill>
+                <a:latin typeface="Calibri" pitchFamily="34" charset="0"/>
+                <a:ea typeface="Calibri" pitchFamily="34" charset="-122"/>
+                <a:cs typeface="Calibri" pitchFamily="34" charset="-120"/>
+              </a:rPr>
+              <a:t>23/04/2025</a:t>
+            </a:r>
+            <a:endParaRPr lang="en-US" sz="850" dirty="0"/>
+          </a:p>
+        </p:txBody>
+      </p:sp>
+      <p:sp>
+        <p:nvSpPr>
+          <p:cNvPr id="90" name="Text 85"/>
+          <p:cNvSpPr txBox="1"/>
+          <p:nvPr/>
+        </p:nvSpPr>
+        <p:spPr>
+          <a:xfrm>
+            <a:off x="7245523" y="5568696"/>
+            <a:ext cx="2153046" cy="292608"/>
+          </a:xfrm>
+          <a:prstGeom prst="rect">
+            <a:avLst/>
+          </a:prstGeom>
+          <a:noFill/>
+          <a:ln/>
+        </p:spPr>
+        <p:txBody>
+          <a:bodyPr wrap="square" lIns="0" tIns="0" rIns="0" bIns="0" rtlCol="0" anchor="t"/>
+          <a:lstStyle/>
+          <a:p>
+            <a:pPr algn="ctr" indent="0" marL="0">
+              <a:lnSpc>
+                <a:spcPct val="105000"/>
+              </a:lnSpc>
+              <a:buNone/>
+            </a:pPr>
+            <a:r>
+              <a:rPr lang="en-US" sz="700" dirty="0">
+                <a:solidFill>
+                  <a:srgbClr val="5B6B82"/>
+                </a:solidFill>
+                <a:latin typeface="Calibri" pitchFamily="34" charset="0"/>
+                <a:ea typeface="Calibri" pitchFamily="34" charset="-122"/>
+                <a:cs typeface="Calibri" pitchFamily="34" charset="-120"/>
+              </a:rPr>
+              <a:t>Respuesta (descargo)</a:t>
+            </a:r>
+            <a:endParaRPr lang="en-US" sz="700" dirty="0"/>
+          </a:p>
+        </p:txBody>
+      </p:sp>
+      <p:sp>
+        <p:nvSpPr>
+          <p:cNvPr id="91" name="Shape 86"/>
+          <p:cNvSpPr/>
+          <p:nvPr/>
+        </p:nvSpPr>
+        <p:spPr>
+          <a:xfrm>
+            <a:off x="8322046" y="5328209"/>
+            <a:ext cx="2226198" cy="14630"/>
+          </a:xfrm>
+          <a:prstGeom prst="rect">
+            <a:avLst/>
+          </a:prstGeom>
+          <a:solidFill>
+            <a:srgbClr val="DCE3EC"/>
+          </a:solidFill>
+          <a:ln/>
+        </p:spPr>
+      </p:sp>
+      <p:sp>
+        <p:nvSpPr>
+          <p:cNvPr id="92" name="Shape 87"/>
+          <p:cNvSpPr/>
+          <p:nvPr/>
+        </p:nvSpPr>
+        <p:spPr>
+          <a:xfrm>
+            <a:off x="10497952" y="5285232"/>
+            <a:ext cx="100584" cy="100584"/>
+          </a:xfrm>
+          <a:prstGeom prst="ellipse">
+            <a:avLst/>
+          </a:prstGeom>
+          <a:solidFill>
+            <a:srgbClr val="17A9B0"/>
+          </a:solidFill>
+          <a:ln w="19050">
+            <a:solidFill>
+              <a:srgbClr val="FFFFFF"/>
+            </a:solidFill>
+            <a:prstDash val="solid"/>
+          </a:ln>
+        </p:spPr>
+      </p:sp>
+      <p:sp>
+        <p:nvSpPr>
+          <p:cNvPr id="93" name="Text 88"/>
+          <p:cNvSpPr txBox="1"/>
+          <p:nvPr/>
+        </p:nvSpPr>
+        <p:spPr>
+          <a:xfrm>
+            <a:off x="9435145" y="5422392"/>
+            <a:ext cx="2226198" cy="146304"/>
+          </a:xfrm>
+          <a:prstGeom prst="rect">
+            <a:avLst/>
+          </a:prstGeom>
+          <a:noFill/>
+          <a:ln/>
+        </p:spPr>
+        <p:txBody>
+          <a:bodyPr wrap="square" lIns="0" tIns="0" rIns="0" bIns="0" rtlCol="0" anchor="t"/>
+          <a:lstStyle/>
+          <a:p>
+            <a:pPr algn="ctr" indent="0" marL="0">
+              <a:buNone/>
+            </a:pPr>
+            <a:r>
+              <a:rPr lang="en-US" sz="850" b="1" dirty="0">
+                <a:solidFill>
+                  <a:srgbClr val="17223A"/>
+                </a:solidFill>
+                <a:latin typeface="Calibri" pitchFamily="34" charset="0"/>
+                <a:ea typeface="Calibri" pitchFamily="34" charset="-122"/>
+                <a:cs typeface="Calibri" pitchFamily="34" charset="-120"/>
+              </a:rPr>
+              <a:t>10/03/2026</a:t>
+            </a:r>
+            <a:endParaRPr lang="en-US" sz="850" dirty="0"/>
+          </a:p>
+        </p:txBody>
+      </p:sp>
+      <p:sp>
+        <p:nvSpPr>
+          <p:cNvPr id="94" name="Text 89"/>
+          <p:cNvSpPr txBox="1"/>
+          <p:nvPr/>
+        </p:nvSpPr>
+        <p:spPr>
+          <a:xfrm>
+            <a:off x="9471721" y="5568696"/>
+            <a:ext cx="2153046" cy="292608"/>
+          </a:xfrm>
+          <a:prstGeom prst="rect">
+            <a:avLst/>
+          </a:prstGeom>
+          <a:noFill/>
+          <a:ln/>
+        </p:spPr>
+        <p:txBody>
+          <a:bodyPr wrap="square" lIns="0" tIns="0" rIns="0" bIns="0" rtlCol="0" anchor="t"/>
+          <a:lstStyle/>
+          <a:p>
+            <a:pPr algn="ctr" indent="0" marL="0">
+              <a:lnSpc>
+                <a:spcPct val="105000"/>
+              </a:lnSpc>
+              <a:buNone/>
+            </a:pPr>
+            <a:r>
+              <a:rPr lang="en-US" sz="700" dirty="0">
+                <a:solidFill>
+                  <a:srgbClr val="5B6B82"/>
+                </a:solidFill>
+                <a:latin typeface="Calibri" pitchFamily="34" charset="0"/>
+                <a:ea typeface="Calibri" pitchFamily="34" charset="-122"/>
+                <a:cs typeface="Calibri" pitchFamily="34" charset="-120"/>
+              </a:rPr>
+              <a:t>Solicitud de prórroga de 6 meses</a:t>
+            </a:r>
+            <a:endParaRPr lang="en-US" sz="700" dirty="0"/>
           </a:p>
         </p:txBody>
       </p:sp>

</xml_diff>